<commit_message>
Refine course 1 instructor deck
</commit_message>
<xml_diff>
--- a/slides/course-01-ai-for-real-estate-sales-approved-instructor-deck.pptx
+++ b/slides/course-01-ai-for-real-estate-sales-approved-instructor-deck.pptx
@@ -1429,7 +1429,7 @@
           <a:p>
             <a:r>
               <a:rPr lang="en-US" dirty="0"/>
-              <a:t>The phrase “just checking in” is the teaching target.</a:t>
+              <a:t>The phrase "just checking in" is the teaching target.</a:t>
             </a:r>
             <a:endParaRPr lang="en-US" dirty="0"/>
           </a:p>
@@ -1517,7 +1517,7 @@
           <a:p>
             <a:r>
               <a:rPr lang="en-US" dirty="0"/>
-              <a:t>Keep the bio brief. Mention GoHouse.ai only as professional context, not as a pitch.</a:t>
+              <a:t>Keep the bio brief. Keep company context minimal and educational. Do not turn this into a product pitch.</a:t>
             </a:r>
             <a:endParaRPr lang="en-US" dirty="0"/>
           </a:p>
@@ -5250,7 +5250,86 @@
       </p:sp>
       <p:sp>
         <p:nvSpPr>
-          <p:cNvPr id="8" name="Text 6"/>
+          <p:cNvPr id="8" name="Shape 6"/>
+          <p:cNvSpPr/>
+          <p:nvPr/>
+        </p:nvSpPr>
+        <p:spPr>
+          <a:xfrm>
+            <a:off x="585216" y="4187952"/>
+            <a:ext cx="4092489" cy="734812"/>
+          </a:xfrm>
+          <a:prstGeom prst="roundRect">
+            <a:avLst>
+              <a:gd name="adj" fmla="val 4978"/>
+            </a:avLst>
+          </a:prstGeom>
+          <a:solidFill>
+            <a:srgbClr val="FFFFFF">
+              <a:alpha val="97000"/>
+            </a:srgbClr>
+          </a:solidFill>
+          <a:ln w="7620">
+            <a:solidFill>
+              <a:srgbClr val="D7E4EA">
+                <a:alpha val="75000"/>
+              </a:srgbClr>
+            </a:solidFill>
+            <a:prstDash val="solid"/>
+          </a:ln>
+        </p:spPr>
+      </p:sp>
+      <p:pic>
+        <p:nvPicPr>
+          <p:cNvPr id="9" name="Image 0" descr="C:\Users\TR4_1950X\Documents\New project\assets\brand\miami-realtors-logo-color.png">    </p:cNvPr>
+          <p:cNvPicPr>
+            <a:picLocks noChangeAspect="1"/>
+          </p:cNvPicPr>
+          <p:nvPr/>
+        </p:nvPicPr>
+        <p:blipFill>
+          <a:blip r:embed="rId1"/>
+          <a:stretch>
+            <a:fillRect/>
+          </a:stretch>
+        </p:blipFill>
+        <p:spPr>
+          <a:xfrm>
+            <a:off x="749808" y="4315968"/>
+            <a:ext cx="1184697" cy="517368"/>
+          </a:xfrm>
+          <a:prstGeom prst="rect">
+            <a:avLst/>
+          </a:prstGeom>
+        </p:spPr>
+      </p:pic>
+      <p:pic>
+        <p:nvPicPr>
+          <p:cNvPr id="10" name="Image 1" descr="C:\Users\TR4_1950X\Documents\New project\assets\brand\rworld-official-logo-color.png">    </p:cNvPr>
+          <p:cNvPicPr>
+            <a:picLocks noChangeAspect="1"/>
+          </p:cNvPicPr>
+          <p:nvPr/>
+        </p:nvPicPr>
+        <p:blipFill>
+          <a:blip r:embed="rId2"/>
+          <a:stretch>
+            <a:fillRect/>
+          </a:stretch>
+        </p:blipFill>
+        <p:spPr>
+          <a:xfrm>
+            <a:off x="2318553" y="4345960"/>
+            <a:ext cx="2249424" cy="457383"/>
+          </a:xfrm>
+          <a:prstGeom prst="rect">
+            <a:avLst/>
+          </a:prstGeom>
+        </p:spPr>
+      </p:pic>
+      <p:sp>
+        <p:nvSpPr>
+          <p:cNvPr id="11" name="Text 7"/>
           <p:cNvSpPr/>
           <p:nvPr/>
         </p:nvSpPr>
@@ -5278,7 +5357,7 @@
                   <a:srgbClr val="D7EDEE"/>
                 </a:solidFill>
               </a:rPr>
-              <a:t>For MIAMI REALTORS® + RWorld members</a:t>
+              <a:t>For MIAMI REALTORS + RWorld members</a:t>
             </a:r>
             <a:endParaRPr lang="en-US" sz="1200" dirty="0"/>
           </a:p>
@@ -5286,7 +5365,7 @@
       </p:sp>
       <p:sp>
         <p:nvSpPr>
-          <p:cNvPr id="9" name="Text 7"/>
+          <p:cNvPr id="12" name="Text 8"/>
           <p:cNvSpPr/>
           <p:nvPr/>
         </p:nvSpPr>
@@ -6154,7 +6233,7 @@
                 <a:ea typeface="Aptos" pitchFamily="34" charset="-122"/>
                 <a:cs typeface="Aptos" pitchFamily="34" charset="-120"/>
               </a:rPr>
-              <a:t>Approved REALTOR® education course | MIAMI REALTORS® + RWorld members</a:t>
+              <a:t>Approved REALTOR education course | MIAMI REALTORS + RWorld members</a:t>
             </a:r>
             <a:endParaRPr lang="en-US" sz="720" dirty="0"/>
           </a:p>
@@ -7096,7 +7175,7 @@
                 <a:ea typeface="Aptos" pitchFamily="34" charset="-122"/>
                 <a:cs typeface="Aptos" pitchFamily="34" charset="-120"/>
               </a:rPr>
-              <a:t>Approved REALTOR® education course | MIAMI REALTORS® + RWorld members</a:t>
+              <a:t>Approved REALTOR education course | MIAMI REALTORS + RWorld members</a:t>
             </a:r>
             <a:endParaRPr lang="en-US" sz="720" dirty="0"/>
           </a:p>
@@ -7695,7 +7774,7 @@
                 <a:ea typeface="Aptos" pitchFamily="34" charset="-122"/>
                 <a:cs typeface="Aptos" pitchFamily="34" charset="-120"/>
               </a:rPr>
-              <a:t>Approved REALTOR® education course | MIAMI REALTORS® + RWorld members</a:t>
+              <a:t>Approved REALTOR education course | MIAMI REALTORS + RWorld members</a:t>
             </a:r>
             <a:endParaRPr lang="en-US" sz="720" dirty="0"/>
           </a:p>
@@ -8191,7 +8270,7 @@
                 <a:ea typeface="Aptos" pitchFamily="34" charset="-122"/>
                 <a:cs typeface="Aptos" pitchFamily="34" charset="-120"/>
               </a:rPr>
-              <a:t>Approved REALTOR® education course | MIAMI REALTORS® + RWorld members</a:t>
+              <a:t>Approved REALTOR education course | MIAMI REALTORS + RWorld members</a:t>
             </a:r>
             <a:endParaRPr lang="en-US" sz="720" dirty="0"/>
           </a:p>
@@ -8694,7 +8773,7 @@
                   <a:srgbClr val="102033"/>
                 </a:solidFill>
               </a:rPr>
-              <a:t>You are helping me as a REALTOR®</a:t>
+              <a:t>You are helping me as a REALTOR</a:t>
             </a:r>
             <a:endParaRPr lang="en-US" sz="1150" dirty="0"/>
           </a:p>
@@ -9261,7 +9340,7 @@
                 <a:ea typeface="Aptos" pitchFamily="34" charset="-122"/>
                 <a:cs typeface="Aptos" pitchFamily="34" charset="-120"/>
               </a:rPr>
-              <a:t>Approved REALTOR® education course | MIAMI REALTORS® + RWorld members</a:t>
+              <a:t>Approved REALTOR education course | MIAMI REALTORS + RWorld members</a:t>
             </a:r>
             <a:endParaRPr lang="en-US" sz="720" dirty="0"/>
           </a:p>
@@ -9811,7 +9890,7 @@
                 <a:ea typeface="Aptos" pitchFamily="34" charset="-122"/>
                 <a:cs typeface="Aptos" pitchFamily="34" charset="-120"/>
               </a:rPr>
-              <a:t>Approved REALTOR® education course | MIAMI REALTORS® + RWorld members</a:t>
+              <a:t>Approved REALTOR education course | MIAMI REALTORS + RWorld members</a:t>
             </a:r>
             <a:endParaRPr lang="en-US" sz="720" dirty="0"/>
           </a:p>
@@ -10361,7 +10440,7 @@
                 <a:ea typeface="Aptos" pitchFamily="34" charset="-122"/>
                 <a:cs typeface="Aptos" pitchFamily="34" charset="-120"/>
               </a:rPr>
-              <a:t>Approved REALTOR® education course | MIAMI REALTORS® + RWorld members</a:t>
+              <a:t>Approved REALTOR education course | MIAMI REALTORS + RWorld members</a:t>
             </a:r>
             <a:endParaRPr lang="en-US" sz="720" dirty="0"/>
           </a:p>
@@ -10960,7 +11039,7 @@
                 <a:ea typeface="Aptos" pitchFamily="34" charset="-122"/>
                 <a:cs typeface="Aptos" pitchFamily="34" charset="-120"/>
               </a:rPr>
-              <a:t>Approved REALTOR® education course | MIAMI REALTORS® + RWorld members</a:t>
+              <a:t>Approved REALTOR education course | MIAMI REALTORS + RWorld members</a:t>
             </a:r>
             <a:endParaRPr lang="en-US" sz="720" dirty="0"/>
           </a:p>
@@ -11252,7 +11331,7 @@
                 <a:ea typeface="Aptos" pitchFamily="34" charset="-122"/>
                 <a:cs typeface="Aptos" pitchFamily="34" charset="-120"/>
               </a:rPr>
-              <a:t>Brief context: real estate technology, online lead workflows, and practical AI adoption</a:t>
+              <a:t>Real estate technology, online lead workflows, and practical AI adoption</a:t>
             </a:r>
             <a:endParaRPr lang="en-US" sz="1650" dirty="0"/>
           </a:p>
@@ -11270,7 +11349,7 @@
                 <a:ea typeface="Aptos" pitchFamily="34" charset="-122"/>
                 <a:cs typeface="Aptos" pitchFamily="34" charset="-120"/>
               </a:rPr>
-              <a:t>No official logos or brand marks are used</a:t>
+              <a:t>Focus: usable sales communication, follow-up, listing prep, and daily productivity</a:t>
             </a:r>
             <a:endParaRPr lang="en-US" sz="1650" dirty="0"/>
           </a:p>
@@ -11288,7 +11367,7 @@
                 <a:ea typeface="Aptos" pitchFamily="34" charset="-122"/>
                 <a:cs typeface="Aptos" pitchFamily="34" charset="-120"/>
               </a:rPr>
-              <a:t>Examples are synthetic and classroom-safe</a:t>
+              <a:t>Questions are welcome throughout the class</a:t>
             </a:r>
             <a:endParaRPr lang="en-US" sz="1650" dirty="0"/>
           </a:p>
@@ -11353,7 +11432,7 @@
                   <a:srgbClr val="16324F"/>
                 </a:solidFill>
               </a:rPr>
-              <a:t>Practical course rule</a:t>
+              <a:t>Make it usable</a:t>
             </a:r>
             <a:endParaRPr lang="en-US" sz="1750" dirty="0"/>
           </a:p>
@@ -11391,7 +11470,7 @@
                   <a:srgbClr val="102033"/>
                 </a:solidFill>
               </a:rPr>
-              <a:t>Use AI where it reduces friction, then review before clients see it.</a:t>
+              <a:t>Turn each example into one repeatable workflow you can use this week.</a:t>
             </a:r>
             <a:endParaRPr lang="en-US" sz="1220" dirty="0"/>
           </a:p>
@@ -11539,7 +11618,7 @@
                 <a:ea typeface="Aptos" pitchFamily="34" charset="-122"/>
                 <a:cs typeface="Aptos" pitchFamily="34" charset="-120"/>
               </a:rPr>
-              <a:t>Approved REALTOR® education course | MIAMI REALTORS® + RWorld members</a:t>
+              <a:t>Approved REALTOR education course | MIAMI REALTORS + RWorld members</a:t>
             </a:r>
             <a:endParaRPr lang="en-US" sz="720" dirty="0"/>
           </a:p>
@@ -11897,7 +11976,7 @@
                   <a:srgbClr val="102033"/>
                 </a:solidFill>
               </a:rPr>
-              <a:t>Rewrite this text so it sounds warm, concise, and natural for a REALTOR®: [draft]</a:t>
+              <a:t>Rewrite this text so it sounds warm, concise, and natural for a REALTOR: [draft]</a:t>
             </a:r>
             <a:endParaRPr lang="en-US" sz="1260" dirty="0"/>
           </a:p>
@@ -12337,7 +12416,7 @@
                 <a:ea typeface="Aptos" pitchFamily="34" charset="-122"/>
                 <a:cs typeface="Aptos" pitchFamily="34" charset="-120"/>
               </a:rPr>
-              <a:t>Approved REALTOR® education course | MIAMI REALTORS® + RWorld members</a:t>
+              <a:t>Approved REALTOR education course | MIAMI REALTORS + RWorld members</a:t>
             </a:r>
             <a:endParaRPr lang="en-US" sz="720" dirty="0"/>
           </a:p>
@@ -12900,7 +12979,7 @@
                   <a:srgbClr val="16324F"/>
                 </a:solidFill>
               </a:rPr>
-              <a:t>Practical course rule</a:t>
+              <a:t>Useful beats frequent</a:t>
             </a:r>
             <a:endParaRPr lang="en-US" sz="1750" dirty="0"/>
           </a:p>
@@ -12938,7 +13017,7 @@
                   <a:srgbClr val="102033"/>
                 </a:solidFill>
               </a:rPr>
-              <a:t>Use AI where it reduces friction, then review before clients see it.</a:t>
+              <a:t>Better follow-up gives the lead a reason to respond and a clear next step.</a:t>
             </a:r>
             <a:endParaRPr lang="en-US" sz="1220" dirty="0"/>
           </a:p>
@@ -13086,7 +13165,7 @@
                 <a:ea typeface="Aptos" pitchFamily="34" charset="-122"/>
                 <a:cs typeface="Aptos" pitchFamily="34" charset="-120"/>
               </a:rPr>
-              <a:t>Approved REALTOR® education course | MIAMI REALTORS® + RWorld members</a:t>
+              <a:t>Approved REALTOR education course | MIAMI REALTORS + RWorld members</a:t>
             </a:r>
             <a:endParaRPr lang="en-US" sz="720" dirty="0"/>
           </a:p>
@@ -14094,7 +14173,7 @@
                 <a:ea typeface="Aptos" pitchFamily="34" charset="-122"/>
                 <a:cs typeface="Aptos" pitchFamily="34" charset="-120"/>
               </a:rPr>
-              <a:t>Approved REALTOR® education course | MIAMI REALTORS® + RWorld members</a:t>
+              <a:t>Approved REALTOR education course | MIAMI REALTORS + RWorld members</a:t>
             </a:r>
             <a:endParaRPr lang="en-US" sz="720" dirty="0"/>
           </a:p>
@@ -14326,7 +14405,7 @@
                 <a:ea typeface="Aptos Display" pitchFamily="34" charset="-122"/>
                 <a:cs typeface="Aptos Display" pitchFamily="34" charset="-120"/>
               </a:rPr>
-              <a:t>Property inquiry response that does more than answer “available?”</a:t>
+              <a:t>Property inquiry response that does more than answer "available?"</a:t>
             </a:r>
             <a:endParaRPr lang="en-US" sz="2300" dirty="0"/>
           </a:p>
@@ -14418,7 +14497,7 @@
                   <a:srgbClr val="16324F"/>
                 </a:solidFill>
               </a:rPr>
-              <a:t>Lead asked: “Is the condo on Brickell still available?”</a:t>
+              <a:t>Lead asked: "Is the condo on Brickell still available?"</a:t>
             </a:r>
             <a:endParaRPr lang="en-US" sz="1280" dirty="0"/>
           </a:p>
@@ -14546,7 +14625,7 @@
                   <a:srgbClr val="102033"/>
                 </a:solidFill>
               </a:rPr>
-              <a:t>Weak: “Yes, it is available. Let me know if you want to see it.”</a:t>
+              <a:t>Weak: "Yes, it is available. Let me know if you want to see it."</a:t>
             </a:r>
             <a:endParaRPr lang="en-US" sz="1320" dirty="0"/>
           </a:p>
@@ -14566,7 +14645,7 @@
                   <a:srgbClr val="102033"/>
                 </a:solidFill>
               </a:rPr>
-              <a:t>Better: “Yes, it appears available as of my latest check. Are you looking specifically in Brickell, or would similar buildings with strong amenities also be worth sending over?”</a:t>
+              <a:t>Better: "Yes, it appears available as of my latest check. Are you looking specifically in Brickell, or would similar buildings with strong amenities also be worth sending over?"</a:t>
             </a:r>
             <a:endParaRPr lang="en-US" sz="1320" dirty="0"/>
           </a:p>
@@ -14664,7 +14743,7 @@
                 <a:ea typeface="Aptos" pitchFamily="34" charset="-122"/>
                 <a:cs typeface="Aptos" pitchFamily="34" charset="-120"/>
               </a:rPr>
-              <a:t>Approved REALTOR® education course | MIAMI REALTORS® + RWorld members</a:t>
+              <a:t>Approved REALTOR education course | MIAMI REALTORS + RWorld members</a:t>
             </a:r>
             <a:endParaRPr lang="en-US" sz="720" dirty="0"/>
           </a:p>
@@ -15243,7 +15322,7 @@
                 <a:ea typeface="Aptos" pitchFamily="34" charset="-122"/>
                 <a:cs typeface="Aptos" pitchFamily="34" charset="-120"/>
               </a:rPr>
-              <a:t>Approved REALTOR® education course | MIAMI REALTORS® + RWorld members</a:t>
+              <a:t>Approved REALTOR education course | MIAMI REALTORS + RWorld members</a:t>
             </a:r>
             <a:endParaRPr lang="en-US" sz="720" dirty="0"/>
           </a:p>
@@ -16185,7 +16264,7 @@
                 <a:ea typeface="Aptos" pitchFamily="34" charset="-122"/>
                 <a:cs typeface="Aptos" pitchFamily="34" charset="-120"/>
               </a:rPr>
-              <a:t>Approved REALTOR® education course | MIAMI REALTORS® + RWorld members</a:t>
+              <a:t>Approved REALTOR education course | MIAMI REALTORS + RWorld members</a:t>
             </a:r>
             <a:endParaRPr lang="en-US" sz="720" dirty="0"/>
           </a:p>
@@ -16766,7 +16845,7 @@
                   <a:srgbClr val="16324F"/>
                 </a:solidFill>
               </a:rPr>
-              <a:t>Practical course rule</a:t>
+              <a:t>Facts first</a:t>
             </a:r>
             <a:endParaRPr lang="en-US" sz="1750" dirty="0"/>
           </a:p>
@@ -16804,7 +16883,7 @@
                   <a:srgbClr val="102033"/>
                 </a:solidFill>
               </a:rPr>
-              <a:t>Use AI where it reduces friction, then review before clients see it.</a:t>
+              <a:t>Feed AI verified property facts. Do not ask it to invent listing details.</a:t>
             </a:r>
             <a:endParaRPr lang="en-US" sz="1220" dirty="0"/>
           </a:p>
@@ -16952,7 +17031,7 @@
                 <a:ea typeface="Aptos" pitchFamily="34" charset="-122"/>
                 <a:cs typeface="Aptos" pitchFamily="34" charset="-120"/>
               </a:rPr>
-              <a:t>Approved REALTOR® education course | MIAMI REALTORS® + RWorld members</a:t>
+              <a:t>Approved REALTOR education course | MIAMI REALTORS + RWorld members</a:t>
             </a:r>
             <a:endParaRPr lang="en-US" sz="720" dirty="0"/>
           </a:p>
@@ -17504,7 +17583,7 @@
                 <a:ea typeface="Aptos" pitchFamily="34" charset="-122"/>
                 <a:cs typeface="Aptos" pitchFamily="34" charset="-120"/>
               </a:rPr>
-              <a:t>Approved REALTOR® education course | MIAMI REALTORS® + RWorld members</a:t>
+              <a:t>Approved REALTOR education course | MIAMI REALTORS + RWorld members</a:t>
             </a:r>
             <a:endParaRPr lang="en-US" sz="720" dirty="0"/>
           </a:p>
@@ -17915,7 +17994,7 @@
                   <a:srgbClr val="16324F"/>
                 </a:solidFill>
               </a:rPr>
-              <a:t>Practical course rule</a:t>
+              <a:t>Use it where work repeats</a:t>
             </a:r>
             <a:endParaRPr lang="en-US" sz="1750" dirty="0"/>
           </a:p>
@@ -17953,7 +18032,7 @@
                   <a:srgbClr val="102033"/>
                 </a:solidFill>
               </a:rPr>
-              <a:t>Use AI where it reduces friction, then review before clients see it.</a:t>
+              <a:t>Start with messages, notes, follow-up, and prep before chasing new tools.</a:t>
             </a:r>
             <a:endParaRPr lang="en-US" sz="1220" dirty="0"/>
           </a:p>
@@ -18101,7 +18180,7 @@
                 <a:ea typeface="Aptos" pitchFamily="34" charset="-122"/>
                 <a:cs typeface="Aptos" pitchFamily="34" charset="-120"/>
               </a:rPr>
-              <a:t>Approved REALTOR® education course | MIAMI REALTORS® + RWorld members</a:t>
+              <a:t>Approved REALTOR education course | MIAMI REALTORS + RWorld members</a:t>
             </a:r>
             <a:endParaRPr lang="en-US" sz="720" dirty="0"/>
           </a:p>
@@ -18989,7 +19068,7 @@
                 <a:ea typeface="Aptos" pitchFamily="34" charset="-122"/>
                 <a:cs typeface="Aptos" pitchFamily="34" charset="-120"/>
               </a:rPr>
-              <a:t>Approved REALTOR® education course | MIAMI REALTORS® + RWorld members</a:t>
+              <a:t>Approved REALTOR education course | MIAMI REALTORS + RWorld members</a:t>
             </a:r>
             <a:endParaRPr lang="en-US" sz="720" dirty="0"/>
           </a:p>
@@ -19550,7 +19629,7 @@
                 <a:ea typeface="Aptos" pitchFamily="34" charset="-122"/>
                 <a:cs typeface="Aptos" pitchFamily="34" charset="-120"/>
               </a:rPr>
-              <a:t>Approved REALTOR® education course | MIAMI REALTORS® + RWorld members</a:t>
+              <a:t>Approved REALTOR education course | MIAMI REALTORS + RWorld members</a:t>
             </a:r>
             <a:endParaRPr lang="en-US" sz="720" dirty="0"/>
           </a:p>
@@ -20131,7 +20210,7 @@
                   <a:srgbClr val="16324F"/>
                 </a:solidFill>
               </a:rPr>
-              <a:t>Practical course rule</a:t>
+              <a:t>Practice before pressure</a:t>
             </a:r>
             <a:endParaRPr lang="en-US" sz="1750" dirty="0"/>
           </a:p>
@@ -20169,7 +20248,7 @@
                   <a:srgbClr val="102033"/>
                 </a:solidFill>
               </a:rPr>
-              <a:t>Use AI where it reduces friction, then review before clients see it.</a:t>
+              <a:t>Role-play makes client conversations clearer and less reactive.</a:t>
             </a:r>
             <a:endParaRPr lang="en-US" sz="1220" dirty="0"/>
           </a:p>
@@ -20317,7 +20396,7 @@
                 <a:ea typeface="Aptos" pitchFamily="34" charset="-122"/>
                 <a:cs typeface="Aptos" pitchFamily="34" charset="-120"/>
               </a:rPr>
-              <a:t>Approved REALTOR® education course | MIAMI REALTORS® + RWorld members</a:t>
+              <a:t>Approved REALTOR education course | MIAMI REALTORS + RWorld members</a:t>
             </a:r>
             <a:endParaRPr lang="en-US" sz="720" dirty="0"/>
           </a:p>
@@ -20641,7 +20720,7 @@
                   <a:srgbClr val="FFFFFF"/>
                 </a:solidFill>
               </a:rPr>
-              <a:t>“Role-play as a seller who believes their home is worth more than recent comparable sales. Push back realistically. After each of my responses, tell me what was clear, what sounded defensive, and what I should try next.”</a:t>
+              <a:t>"Role-play as a seller who believes their home is worth more than recent comparable sales. Push back realistically. After each of my responses, tell me what was clear, what sounded defensive, and what I should try next."</a:t>
             </a:r>
             <a:endParaRPr lang="en-US" sz="1800" dirty="0"/>
           </a:p>
@@ -20703,7 +20782,7 @@
                 <a:ea typeface="Aptos" pitchFamily="34" charset="-122"/>
                 <a:cs typeface="Aptos" pitchFamily="34" charset="-120"/>
               </a:rPr>
-              <a:t>Approved REALTOR® education course | MIAMI REALTORS® + RWorld members</a:t>
+              <a:t>Approved REALTOR education course | MIAMI REALTORS + RWorld members</a:t>
             </a:r>
             <a:endParaRPr lang="en-US" sz="720" dirty="0"/>
           </a:p>
@@ -21027,7 +21106,7 @@
                   <a:srgbClr val="FFFFFF"/>
                 </a:solidFill>
               </a:rPr>
-              <a:t>“Act as a cautious buyer who wants to wait for rates to drop. Help me practice a conversation that is educational, not pushy. Challenge any claims that sound too certain.”</a:t>
+              <a:t>"Act as a cautious buyer who wants to wait for rates to drop. Help me practice a conversation that is educational, not pushy. Challenge any claims that sound too certain."</a:t>
             </a:r>
             <a:endParaRPr lang="en-US" sz="1800" dirty="0"/>
           </a:p>
@@ -21089,7 +21168,7 @@
                 <a:ea typeface="Aptos" pitchFamily="34" charset="-122"/>
                 <a:cs typeface="Aptos" pitchFamily="34" charset="-120"/>
               </a:rPr>
-              <a:t>Approved REALTOR® education course | MIAMI REALTORS® + RWorld members</a:t>
+              <a:t>Approved REALTOR education course | MIAMI REALTORS + RWorld members</a:t>
             </a:r>
             <a:endParaRPr lang="en-US" sz="720" dirty="0"/>
           </a:p>
@@ -21668,7 +21747,7 @@
                 <a:ea typeface="Aptos" pitchFamily="34" charset="-122"/>
                 <a:cs typeface="Aptos" pitchFamily="34" charset="-120"/>
               </a:rPr>
-              <a:t>Approved REALTOR® education course | MIAMI REALTORS® + RWorld members</a:t>
+              <a:t>Approved REALTOR education course | MIAMI REALTORS + RWorld members</a:t>
             </a:r>
             <a:endParaRPr lang="en-US" sz="720" dirty="0"/>
           </a:p>
@@ -22780,7 +22859,7 @@
                 <a:ea typeface="Aptos" pitchFamily="34" charset="-122"/>
                 <a:cs typeface="Aptos" pitchFamily="34" charset="-120"/>
               </a:rPr>
-              <a:t>Approved REALTOR® education course | MIAMI REALTORS® + RWorld members</a:t>
+              <a:t>Approved REALTOR education course | MIAMI REALTORS + RWorld members</a:t>
             </a:r>
             <a:endParaRPr lang="en-US" sz="720" dirty="0"/>
           </a:p>
@@ -23245,7 +23324,7 @@
                   <a:srgbClr val="16324F"/>
                 </a:solidFill>
               </a:rPr>
-              <a:t>Practical course rule</a:t>
+              <a:t>Review before use</a:t>
             </a:r>
             <a:endParaRPr lang="en-US" sz="1750" dirty="0"/>
           </a:p>
@@ -23283,7 +23362,7 @@
                   <a:srgbClr val="102033"/>
                 </a:solidFill>
               </a:rPr>
-              <a:t>Use AI where it reduces friction, then review before clients see it.</a:t>
+              <a:t>Private data, brokerage policy, MLS rules, advertising, and Fair Housing still apply.</a:t>
             </a:r>
             <a:endParaRPr lang="en-US" sz="1220" dirty="0"/>
           </a:p>
@@ -23431,7 +23510,7 @@
                 <a:ea typeface="Aptos" pitchFamily="34" charset="-122"/>
                 <a:cs typeface="Aptos" pitchFamily="34" charset="-120"/>
               </a:rPr>
-              <a:t>Approved REALTOR® education course | MIAMI REALTORS® + RWorld members</a:t>
+              <a:t>Approved REALTOR education course | MIAMI REALTORS + RWorld members</a:t>
             </a:r>
             <a:endParaRPr lang="en-US" sz="720" dirty="0"/>
           </a:p>
@@ -23860,7 +23939,7 @@
                   <a:srgbClr val="16324F"/>
                 </a:solidFill>
               </a:rPr>
-              <a:t>Practical course rule</a:t>
+              <a:t>What this class builds</a:t>
             </a:r>
             <a:endParaRPr lang="en-US" sz="1750" dirty="0"/>
           </a:p>
@@ -23898,7 +23977,7 @@
                   <a:srgbClr val="102033"/>
                 </a:solidFill>
               </a:rPr>
-              <a:t>Use AI where it reduces friction, then review before clients see it.</a:t>
+              <a:t>A practical AI workflow for real estate sales, not a technical certification.</a:t>
             </a:r>
             <a:endParaRPr lang="en-US" sz="1220" dirty="0"/>
           </a:p>
@@ -24046,7 +24125,7 @@
                 <a:ea typeface="Aptos" pitchFamily="34" charset="-122"/>
                 <a:cs typeface="Aptos" pitchFamily="34" charset="-120"/>
               </a:rPr>
-              <a:t>Approved REALTOR® education course | MIAMI REALTORS® + RWorld members</a:t>
+              <a:t>Approved REALTOR education course | MIAMI REALTORS + RWorld members</a:t>
             </a:r>
             <a:endParaRPr lang="en-US" sz="720" dirty="0"/>
           </a:p>
@@ -24320,43 +24399,7 @@
         <p:spPr>
           <a:xfrm>
             <a:off x="1115568" y="1947672"/>
-            <a:ext cx="1645920" cy="164592"/>
-          </a:xfrm>
-          <a:prstGeom prst="rect">
-            <a:avLst/>
-          </a:prstGeom>
-          <a:noFill/>
-          <a:ln/>
-        </p:spPr>
-        <p:txBody>
-          <a:bodyPr wrap="square" lIns="0" tIns="0" rIns="0" bIns="0" rtlCol="0" anchor="ctr"/>
-          <a:lstStyle/>
-          <a:p>
-            <a:pPr indent="0" marL="0">
-              <a:buNone/>
-            </a:pPr>
-            <a:r>
-              <a:rPr lang="en-US" sz="1050" b="1" dirty="0">
-                <a:solidFill>
-                  <a:srgbClr val="008F8F"/>
-                </a:solidFill>
-              </a:rPr>
-              <a:t>Private data</a:t>
-            </a:r>
-            <a:endParaRPr lang="en-US" sz="1050" dirty="0"/>
-          </a:p>
-        </p:txBody>
-      </p:sp>
-      <p:sp>
-        <p:nvSpPr>
-          <p:cNvPr id="9" name="Text 7"/>
-          <p:cNvSpPr/>
-          <p:nvPr/>
-        </p:nvSpPr>
-        <p:spPr>
-          <a:xfrm>
-            <a:off x="2788920" y="1911096"/>
-            <a:ext cx="7223760" cy="219456"/>
+            <a:ext cx="2011680" cy="164592"/>
           </a:xfrm>
           <a:prstGeom prst="rect">
             <a:avLst/>
@@ -24374,14 +24417,52 @@
               <a:buNone/>
             </a:pPr>
             <a:r>
-              <a:rPr lang="en-US" sz="1150" dirty="0">
+              <a:rPr lang="en-US" sz="1030" b="1" dirty="0">
+                <a:solidFill>
+                  <a:srgbClr val="008F8F"/>
+                </a:solidFill>
+              </a:rPr>
+              <a:t>Private data</a:t>
+            </a:r>
+            <a:endParaRPr lang="en-US" sz="1030" dirty="0"/>
+          </a:p>
+        </p:txBody>
+      </p:sp>
+      <p:sp>
+        <p:nvSpPr>
+          <p:cNvPr id="9" name="Text 7"/>
+          <p:cNvSpPr/>
+          <p:nvPr/>
+        </p:nvSpPr>
+        <p:spPr>
+          <a:xfrm>
+            <a:off x="3310128" y="1911096"/>
+            <a:ext cx="6629400" cy="219456"/>
+          </a:xfrm>
+          <a:prstGeom prst="rect">
+            <a:avLst/>
+          </a:prstGeom>
+          <a:noFill/>
+          <a:ln/>
+        </p:spPr>
+        <p:txBody>
+          <a:bodyPr wrap="square" lIns="0" tIns="0" rIns="0" bIns="0" rtlCol="0" anchor="ctr">
+            <a:normAutofit/>
+          </a:bodyPr>
+          <a:lstStyle/>
+          <a:p>
+            <a:pPr indent="0" marL="0">
+              <a:buNone/>
+            </a:pPr>
+            <a:r>
+              <a:rPr lang="en-US" sz="1130" dirty="0">
                 <a:solidFill>
                   <a:srgbClr val="102033"/>
                 </a:solidFill>
               </a:rPr>
               <a:t>Remove names, contact info, financial details, and sensitive context before using public tools.</a:t>
             </a:r>
-            <a:endParaRPr lang="en-US" sz="1150" dirty="0"/>
+            <a:endParaRPr lang="en-US" sz="1130" dirty="0"/>
           </a:p>
         </p:txBody>
       </p:sp>
@@ -24421,43 +24502,7 @@
         <p:spPr>
           <a:xfrm>
             <a:off x="1115568" y="2788920"/>
-            <a:ext cx="1645920" cy="164592"/>
-          </a:xfrm>
-          <a:prstGeom prst="rect">
-            <a:avLst/>
-          </a:prstGeom>
-          <a:noFill/>
-          <a:ln/>
-        </p:spPr>
-        <p:txBody>
-          <a:bodyPr wrap="square" lIns="0" tIns="0" rIns="0" bIns="0" rtlCol="0" anchor="ctr"/>
-          <a:lstStyle/>
-          <a:p>
-            <a:pPr indent="0" marL="0">
-              <a:buNone/>
-            </a:pPr>
-            <a:r>
-              <a:rPr lang="en-US" sz="1050" b="1" dirty="0">
-                <a:solidFill>
-                  <a:srgbClr val="008F8F"/>
-                </a:solidFill>
-              </a:rPr>
-              <a:t>Advertising</a:t>
-            </a:r>
-            <a:endParaRPr lang="en-US" sz="1050" dirty="0"/>
-          </a:p>
-        </p:txBody>
-      </p:sp>
-      <p:sp>
-        <p:nvSpPr>
-          <p:cNvPr id="12" name="Text 10"/>
-          <p:cNvSpPr/>
-          <p:nvPr/>
-        </p:nvSpPr>
-        <p:spPr>
-          <a:xfrm>
-            <a:off x="2788920" y="2752344"/>
-            <a:ext cx="7223760" cy="219456"/>
+            <a:ext cx="2011680" cy="164592"/>
           </a:xfrm>
           <a:prstGeom prst="rect">
             <a:avLst/>
@@ -24475,14 +24520,52 @@
               <a:buNone/>
             </a:pPr>
             <a:r>
-              <a:rPr lang="en-US" sz="1150" dirty="0">
+              <a:rPr lang="en-US" sz="1030" b="1" dirty="0">
+                <a:solidFill>
+                  <a:srgbClr val="008F8F"/>
+                </a:solidFill>
+              </a:rPr>
+              <a:t>Advertising</a:t>
+            </a:r>
+            <a:endParaRPr lang="en-US" sz="1030" dirty="0"/>
+          </a:p>
+        </p:txBody>
+      </p:sp>
+      <p:sp>
+        <p:nvSpPr>
+          <p:cNvPr id="12" name="Text 10"/>
+          <p:cNvSpPr/>
+          <p:nvPr/>
+        </p:nvSpPr>
+        <p:spPr>
+          <a:xfrm>
+            <a:off x="3310128" y="2752344"/>
+            <a:ext cx="6629400" cy="219456"/>
+          </a:xfrm>
+          <a:prstGeom prst="rect">
+            <a:avLst/>
+          </a:prstGeom>
+          <a:noFill/>
+          <a:ln/>
+        </p:spPr>
+        <p:txBody>
+          <a:bodyPr wrap="square" lIns="0" tIns="0" rIns="0" bIns="0" rtlCol="0" anchor="ctr">
+            <a:normAutofit/>
+          </a:bodyPr>
+          <a:lstStyle/>
+          <a:p>
+            <a:pPr indent="0" marL="0">
+              <a:buNone/>
+            </a:pPr>
+            <a:r>
+              <a:rPr lang="en-US" sz="1130" dirty="0">
                 <a:solidFill>
                   <a:srgbClr val="102033"/>
                 </a:solidFill>
               </a:rPr>
               <a:t>Review claims, disclosures, brokerage rules, and platform requirements.</a:t>
             </a:r>
-            <a:endParaRPr lang="en-US" sz="1150" dirty="0"/>
+            <a:endParaRPr lang="en-US" sz="1130" dirty="0"/>
           </a:p>
         </p:txBody>
       </p:sp>
@@ -24522,43 +24605,7 @@
         <p:spPr>
           <a:xfrm>
             <a:off x="1115568" y="3630168"/>
-            <a:ext cx="1645920" cy="164592"/>
-          </a:xfrm>
-          <a:prstGeom prst="rect">
-            <a:avLst/>
-          </a:prstGeom>
-          <a:noFill/>
-          <a:ln/>
-        </p:spPr>
-        <p:txBody>
-          <a:bodyPr wrap="square" lIns="0" tIns="0" rIns="0" bIns="0" rtlCol="0" anchor="ctr"/>
-          <a:lstStyle/>
-          <a:p>
-            <a:pPr indent="0" marL="0">
-              <a:buNone/>
-            </a:pPr>
-            <a:r>
-              <a:rPr lang="en-US" sz="1050" b="1" dirty="0">
-                <a:solidFill>
-                  <a:srgbClr val="008F8F"/>
-                </a:solidFill>
-              </a:rPr>
-              <a:t>MLS</a:t>
-            </a:r>
-            <a:endParaRPr lang="en-US" sz="1050" dirty="0"/>
-          </a:p>
-        </p:txBody>
-      </p:sp>
-      <p:sp>
-        <p:nvSpPr>
-          <p:cNvPr id="15" name="Text 13"/>
-          <p:cNvSpPr/>
-          <p:nvPr/>
-        </p:nvSpPr>
-        <p:spPr>
-          <a:xfrm>
-            <a:off x="2788920" y="3593592"/>
-            <a:ext cx="7223760" cy="219456"/>
+            <a:ext cx="2011680" cy="164592"/>
           </a:xfrm>
           <a:prstGeom prst="rect">
             <a:avLst/>
@@ -24576,14 +24623,52 @@
               <a:buNone/>
             </a:pPr>
             <a:r>
-              <a:rPr lang="en-US" sz="1150" dirty="0">
+              <a:rPr lang="en-US" sz="1030" b="1" dirty="0">
+                <a:solidFill>
+                  <a:srgbClr val="008F8F"/>
+                </a:solidFill>
+              </a:rPr>
+              <a:t>MLS</a:t>
+            </a:r>
+            <a:endParaRPr lang="en-US" sz="1030" dirty="0"/>
+          </a:p>
+        </p:txBody>
+      </p:sp>
+      <p:sp>
+        <p:nvSpPr>
+          <p:cNvPr id="15" name="Text 13"/>
+          <p:cNvSpPr/>
+          <p:nvPr/>
+        </p:nvSpPr>
+        <p:spPr>
+          <a:xfrm>
+            <a:off x="3310128" y="3593592"/>
+            <a:ext cx="6629400" cy="219456"/>
+          </a:xfrm>
+          <a:prstGeom prst="rect">
+            <a:avLst/>
+          </a:prstGeom>
+          <a:noFill/>
+          <a:ln/>
+        </p:spPr>
+        <p:txBody>
+          <a:bodyPr wrap="square" lIns="0" tIns="0" rIns="0" bIns="0" rtlCol="0" anchor="ctr">
+            <a:normAutofit/>
+          </a:bodyPr>
+          <a:lstStyle/>
+          <a:p>
+            <a:pPr indent="0" marL="0">
+              <a:buNone/>
+            </a:pPr>
+            <a:r>
+              <a:rPr lang="en-US" sz="1130" dirty="0">
                 <a:solidFill>
                   <a:srgbClr val="102033"/>
                 </a:solidFill>
               </a:rPr>
               <a:t>Follow MLS rules for listing data, remarks, photos, and public display.</a:t>
             </a:r>
-            <a:endParaRPr lang="en-US" sz="1150" dirty="0"/>
+            <a:endParaRPr lang="en-US" sz="1130" dirty="0"/>
           </a:p>
         </p:txBody>
       </p:sp>
@@ -24623,43 +24708,7 @@
         <p:spPr>
           <a:xfrm>
             <a:off x="1115568" y="4471416"/>
-            <a:ext cx="1645920" cy="164592"/>
-          </a:xfrm>
-          <a:prstGeom prst="rect">
-            <a:avLst/>
-          </a:prstGeom>
-          <a:noFill/>
-          <a:ln/>
-        </p:spPr>
-        <p:txBody>
-          <a:bodyPr wrap="square" lIns="0" tIns="0" rIns="0" bIns="0" rtlCol="0" anchor="ctr"/>
-          <a:lstStyle/>
-          <a:p>
-            <a:pPr indent="0" marL="0">
-              <a:buNone/>
-            </a:pPr>
-            <a:r>
-              <a:rPr lang="en-US" sz="1050" b="1" dirty="0">
-                <a:solidFill>
-                  <a:srgbClr val="008F8F"/>
-                </a:solidFill>
-              </a:rPr>
-              <a:t>Consumer communication</a:t>
-            </a:r>
-            <a:endParaRPr lang="en-US" sz="1050" dirty="0"/>
-          </a:p>
-        </p:txBody>
-      </p:sp>
-      <p:sp>
-        <p:nvSpPr>
-          <p:cNvPr id="18" name="Text 16"/>
-          <p:cNvSpPr/>
-          <p:nvPr/>
-        </p:nvSpPr>
-        <p:spPr>
-          <a:xfrm>
-            <a:off x="2788920" y="4434840"/>
-            <a:ext cx="7223760" cy="219456"/>
+            <a:ext cx="2011680" cy="164592"/>
           </a:xfrm>
           <a:prstGeom prst="rect">
             <a:avLst/>
@@ -24677,14 +24726,52 @@
               <a:buNone/>
             </a:pPr>
             <a:r>
-              <a:rPr lang="en-US" sz="1150" dirty="0">
+              <a:rPr lang="en-US" sz="1030" b="1" dirty="0">
+                <a:solidFill>
+                  <a:srgbClr val="008F8F"/>
+                </a:solidFill>
+              </a:rPr>
+              <a:t>Consumer communication</a:t>
+            </a:r>
+            <a:endParaRPr lang="en-US" sz="1030" dirty="0"/>
+          </a:p>
+        </p:txBody>
+      </p:sp>
+      <p:sp>
+        <p:nvSpPr>
+          <p:cNvPr id="18" name="Text 16"/>
+          <p:cNvSpPr/>
+          <p:nvPr/>
+        </p:nvSpPr>
+        <p:spPr>
+          <a:xfrm>
+            <a:off x="3310128" y="4434840"/>
+            <a:ext cx="6629400" cy="219456"/>
+          </a:xfrm>
+          <a:prstGeom prst="rect">
+            <a:avLst/>
+          </a:prstGeom>
+          <a:noFill/>
+          <a:ln/>
+        </p:spPr>
+        <p:txBody>
+          <a:bodyPr wrap="square" lIns="0" tIns="0" rIns="0" bIns="0" rtlCol="0" anchor="ctr">
+            <a:normAutofit/>
+          </a:bodyPr>
+          <a:lstStyle/>
+          <a:p>
+            <a:pPr indent="0" marL="0">
+              <a:buNone/>
+            </a:pPr>
+            <a:r>
+              <a:rPr lang="en-US" sz="1130" dirty="0">
                 <a:solidFill>
                   <a:srgbClr val="102033"/>
                 </a:solidFill>
               </a:rPr>
               <a:t>Keep records, respect opt-outs, and do not automate beyond policy.</a:t>
             </a:r>
-            <a:endParaRPr lang="en-US" sz="1150" dirty="0"/>
+            <a:endParaRPr lang="en-US" sz="1130" dirty="0"/>
           </a:p>
         </p:txBody>
       </p:sp>
@@ -24744,7 +24831,7 @@
                 <a:ea typeface="Aptos" pitchFamily="34" charset="-122"/>
                 <a:cs typeface="Aptos" pitchFamily="34" charset="-120"/>
               </a:rPr>
-              <a:t>Approved REALTOR® education course | MIAMI REALTORS® + RWorld members</a:t>
+              <a:t>Approved REALTOR education course | MIAMI REALTORS + RWorld members</a:t>
             </a:r>
             <a:endParaRPr lang="en-US" sz="720" dirty="0"/>
           </a:p>
@@ -25323,7 +25410,7 @@
                 <a:ea typeface="Aptos" pitchFamily="34" charset="-122"/>
                 <a:cs typeface="Aptos" pitchFamily="34" charset="-120"/>
               </a:rPr>
-              <a:t>Approved REALTOR® education course | MIAMI REALTORS® + RWorld members</a:t>
+              <a:t>Approved REALTOR education course | MIAMI REALTORS + RWorld members</a:t>
             </a:r>
             <a:endParaRPr lang="en-US" sz="720" dirty="0"/>
           </a:p>
@@ -26417,7 +26504,7 @@
                 <a:ea typeface="Aptos" pitchFamily="34" charset="-122"/>
                 <a:cs typeface="Aptos" pitchFamily="34" charset="-120"/>
               </a:rPr>
-              <a:t>Approved REALTOR® education course | MIAMI REALTORS® + RWorld members</a:t>
+              <a:t>Approved REALTOR education course | MIAMI REALTORS + RWorld members</a:t>
             </a:r>
             <a:endParaRPr lang="en-US" sz="720" dirty="0"/>
           </a:p>
@@ -26825,7 +26912,7 @@
                 <a:ea typeface="Aptos" pitchFamily="34" charset="-122"/>
                 <a:cs typeface="Aptos" pitchFamily="34" charset="-120"/>
               </a:rPr>
-              <a:t>Approved REALTOR® education course | MIAMI REALTORS® + RWorld members</a:t>
+              <a:t>Approved REALTOR education course | MIAMI REALTORS + RWorld members</a:t>
             </a:r>
             <a:endParaRPr lang="en-US" sz="720" dirty="0"/>
           </a:p>
@@ -27710,7 +27797,7 @@
                 <a:ea typeface="Aptos" pitchFamily="34" charset="-122"/>
                 <a:cs typeface="Aptos" pitchFamily="34" charset="-120"/>
               </a:rPr>
-              <a:t>Approved REALTOR® education course | MIAMI REALTORS® + RWorld members</a:t>
+              <a:t>Approved REALTOR education course | MIAMI REALTORS + RWorld members</a:t>
             </a:r>
             <a:endParaRPr lang="en-US" sz="720" dirty="0"/>
           </a:p>
@@ -28121,7 +28208,7 @@
                   <a:srgbClr val="16324F"/>
                 </a:solidFill>
               </a:rPr>
-              <a:t>Practical course rule</a:t>
+              <a:t>Keep sources close</a:t>
             </a:r>
             <a:endParaRPr lang="en-US" sz="1750" dirty="0"/>
           </a:p>
@@ -28159,7 +28246,7 @@
                   <a:srgbClr val="102033"/>
                 </a:solidFill>
               </a:rPr>
-              <a:t>Use AI where it reduces friction, then review before clients see it.</a:t>
+              <a:t>Use authoritative local rules and broker guidance when the answer matters.</a:t>
             </a:r>
             <a:endParaRPr lang="en-US" sz="1220" dirty="0"/>
           </a:p>
@@ -28307,7 +28394,7 @@
                 <a:ea typeface="Aptos" pitchFamily="34" charset="-122"/>
                 <a:cs typeface="Aptos" pitchFamily="34" charset="-120"/>
               </a:rPr>
-              <a:t>Approved REALTOR® education course | MIAMI REALTORS® + RWorld members</a:t>
+              <a:t>Approved REALTOR education course | MIAMI REALTORS + RWorld members</a:t>
             </a:r>
             <a:endParaRPr lang="en-US" sz="720" dirty="0"/>
           </a:p>
@@ -28700,7 +28787,7 @@
                   <a:srgbClr val="16324F"/>
                 </a:solidFill>
               </a:rPr>
-              <a:t>Professional judgment stays in the loop.</a:t>
+              <a:t>Professional judgment stays in the loop</a:t>
             </a:r>
             <a:endParaRPr lang="en-US" sz="1750" dirty="0"/>
           </a:p>
@@ -28886,7 +28973,7 @@
                 <a:ea typeface="Aptos" pitchFamily="34" charset="-122"/>
                 <a:cs typeface="Aptos" pitchFamily="34" charset="-120"/>
               </a:rPr>
-              <a:t>Approved REALTOR® education course | MIAMI REALTORS® + RWorld members</a:t>
+              <a:t>Approved REALTOR education course | MIAMI REALTORS + RWorld members</a:t>
             </a:r>
             <a:endParaRPr lang="en-US" sz="720" dirty="0"/>
           </a:p>
@@ -29227,6 +29314,85 @@
         </p:nvSpPr>
         <p:spPr>
           <a:xfrm>
+            <a:off x="6281928" y="3547872"/>
+            <a:ext cx="3673693" cy="645201"/>
+          </a:xfrm>
+          <a:prstGeom prst="roundRect">
+            <a:avLst>
+              <a:gd name="adj" fmla="val 5669"/>
+            </a:avLst>
+          </a:prstGeom>
+          <a:solidFill>
+            <a:srgbClr val="FFFFFF">
+              <a:alpha val="97000"/>
+            </a:srgbClr>
+          </a:solidFill>
+          <a:ln w="7620">
+            <a:solidFill>
+              <a:srgbClr val="D7E4EA">
+                <a:alpha val="75000"/>
+              </a:srgbClr>
+            </a:solidFill>
+            <a:prstDash val="solid"/>
+          </a:ln>
+        </p:spPr>
+      </p:sp>
+      <p:pic>
+        <p:nvPicPr>
+          <p:cNvPr id="11" name="Image 0" descr="C:\Users\TR4_1950X\Documents\New project\assets\brand\miami-realtors-logo-color.png">    </p:cNvPr>
+          <p:cNvPicPr>
+            <a:picLocks noChangeAspect="1"/>
+          </p:cNvPicPr>
+          <p:nvPr/>
+        </p:nvPicPr>
+        <p:blipFill>
+          <a:blip r:embed="rId1"/>
+          <a:stretch>
+            <a:fillRect/>
+          </a:stretch>
+        </p:blipFill>
+        <p:spPr>
+          <a:xfrm>
+            <a:off x="6446520" y="3675888"/>
+            <a:ext cx="1040221" cy="454274"/>
+          </a:xfrm>
+          <a:prstGeom prst="rect">
+            <a:avLst/>
+          </a:prstGeom>
+        </p:spPr>
+      </p:pic>
+      <p:pic>
+        <p:nvPicPr>
+          <p:cNvPr id="12" name="Image 1" descr="C:\Users\TR4_1950X\Documents\New project\assets\brand\rworld-official-logo-color.png">    </p:cNvPr>
+          <p:cNvPicPr>
+            <a:picLocks noChangeAspect="1"/>
+          </p:cNvPicPr>
+          <p:nvPr/>
+        </p:nvPicPr>
+        <p:blipFill>
+          <a:blip r:embed="rId2"/>
+          <a:stretch>
+            <a:fillRect/>
+          </a:stretch>
+        </p:blipFill>
+        <p:spPr>
+          <a:xfrm>
+            <a:off x="7870789" y="3702223"/>
+            <a:ext cx="1975104" cy="401604"/>
+          </a:xfrm>
+          <a:prstGeom prst="rect">
+            <a:avLst/>
+          </a:prstGeom>
+        </p:spPr>
+      </p:pic>
+      <p:sp>
+        <p:nvSpPr>
+          <p:cNvPr id="13" name="Shape 9"/>
+          <p:cNvSpPr/>
+          <p:nvPr/>
+        </p:nvSpPr>
+        <p:spPr>
+          <a:xfrm>
             <a:off x="502920" y="6473952"/>
             <a:ext cx="11201400" cy="0"/>
           </a:xfrm>
@@ -29244,7 +29410,7 @@
       </p:sp>
       <p:sp>
         <p:nvSpPr>
-          <p:cNvPr id="11" name="Text 9"/>
+          <p:cNvPr id="14" name="Text 10"/>
           <p:cNvSpPr/>
           <p:nvPr/>
         </p:nvSpPr>
@@ -29275,7 +29441,7 @@
                 <a:ea typeface="Aptos" pitchFamily="34" charset="-122"/>
                 <a:cs typeface="Aptos" pitchFamily="34" charset="-120"/>
               </a:rPr>
-              <a:t>Approved REALTOR® education course | MIAMI REALTORS® + RWorld members</a:t>
+              <a:t>Approved REALTOR education course | MIAMI REALTORS + RWorld members</a:t>
             </a:r>
             <a:endParaRPr lang="en-US" sz="720" dirty="0"/>
           </a:p>
@@ -29283,7 +29449,7 @@
       </p:sp>
       <p:sp>
         <p:nvSpPr>
-          <p:cNvPr id="12" name="Text 10"/>
+          <p:cNvPr id="15" name="Text 11"/>
           <p:cNvSpPr/>
           <p:nvPr/>
         </p:nvSpPr>
@@ -30649,7 +30815,7 @@
                 <a:ea typeface="Aptos" pitchFamily="34" charset="-122"/>
                 <a:cs typeface="Aptos" pitchFamily="34" charset="-120"/>
               </a:rPr>
-              <a:t>Approved REALTOR® education course | MIAMI REALTORS® + RWorld members</a:t>
+              <a:t>Approved REALTOR education course | MIAMI REALTORS + RWorld members</a:t>
             </a:r>
             <a:endParaRPr lang="en-US" sz="720" dirty="0"/>
           </a:p>
@@ -31212,7 +31378,7 @@
                   <a:srgbClr val="16324F"/>
                 </a:solidFill>
               </a:rPr>
-              <a:t>Practical course rule</a:t>
+              <a:t>Speed plus judgment</a:t>
             </a:r>
             <a:endParaRPr lang="en-US" sz="1750" dirty="0"/>
           </a:p>
@@ -31250,7 +31416,7 @@
                   <a:srgbClr val="102033"/>
                 </a:solidFill>
               </a:rPr>
-              <a:t>Use AI where it reduces friction, then review before clients see it.</a:t>
+              <a:t>AI can reduce blank-page time; the agent still owns accuracy and relationship quality.</a:t>
             </a:r>
             <a:endParaRPr lang="en-US" sz="1220" dirty="0"/>
           </a:p>
@@ -31398,7 +31564,7 @@
                 <a:ea typeface="Aptos" pitchFamily="34" charset="-122"/>
                 <a:cs typeface="Aptos" pitchFamily="34" charset="-120"/>
               </a:rPr>
-              <a:t>Approved REALTOR® education course | MIAMI REALTORS® + RWorld members</a:t>
+              <a:t>Approved REALTOR education course | MIAMI REALTORS + RWorld members</a:t>
             </a:r>
             <a:endParaRPr lang="en-US" sz="720" dirty="0"/>
           </a:p>
@@ -31999,7 +32165,7 @@
                 <a:ea typeface="Aptos" pitchFamily="34" charset="-122"/>
                 <a:cs typeface="Aptos" pitchFamily="34" charset="-120"/>
               </a:rPr>
-              <a:t>Approved REALTOR® education course | MIAMI REALTORS® + RWorld members</a:t>
+              <a:t>Approved REALTOR education course | MIAMI REALTORS + RWorld members</a:t>
             </a:r>
             <a:endParaRPr lang="en-US" sz="720" dirty="0"/>
           </a:p>
@@ -32596,7 +32762,7 @@
                 <a:ea typeface="Aptos" pitchFamily="34" charset="-122"/>
                 <a:cs typeface="Aptos" pitchFamily="34" charset="-120"/>
               </a:rPr>
-              <a:t>Approved REALTOR® education course | MIAMI REALTORS® + RWorld members</a:t>
+              <a:t>Approved REALTOR education course | MIAMI REALTORS + RWorld members</a:t>
             </a:r>
             <a:endParaRPr lang="en-US" sz="720" dirty="0"/>
           </a:p>

</xml_diff>

<commit_message>
Use combined MIAMI RWorld logo in course 1 deck
</commit_message>
<xml_diff>
--- a/slides/course-01-ai-for-real-estate-sales-approved-instructor-deck.pptx
+++ b/slides/course-01-ai-for-real-estate-sales-approved-instructor-deck.pptx
@@ -5420,12 +5420,12 @@
         </p:nvSpPr>
         <p:spPr>
           <a:xfrm>
-            <a:off x="585216" y="4187952"/>
-            <a:ext cx="4092489" cy="734812"/>
+            <a:off x="603504" y="4206240"/>
+            <a:ext cx="4281587" cy="819302"/>
           </a:xfrm>
           <a:prstGeom prst="roundRect">
             <a:avLst>
-              <a:gd name="adj" fmla="val 4978"/>
+              <a:gd name="adj" fmla="val 4464"/>
             </a:avLst>
           </a:prstGeom>
           <a:solidFill>
@@ -5445,7 +5445,7 @@
       </p:sp>
       <p:pic>
         <p:nvPicPr>
-          <p:cNvPr id="14" name="Image 0" descr="C:\Users\TR4_1950X\Documents\New project\assets\brand\miami-realtors-logo-color.png">    </p:cNvPr>
+          <p:cNvPr id="14" name="Image 0" descr="C:\Users\TR4_1950X\Documents\New project\assets\brand\miami-realtors-rworld-combined-logo.png">    </p:cNvPr>
           <p:cNvPicPr>
             <a:picLocks noChangeAspect="1"/>
           </p:cNvPicPr>
@@ -5460,40 +5460,16 @@
         <p:spPr>
           <a:xfrm>
             <a:off x="749808" y="4315968"/>
-            <a:ext cx="1184697" cy="517368"/>
+            <a:ext cx="3988979" cy="599846"/>
           </a:xfrm>
           <a:prstGeom prst="rect">
             <a:avLst/>
           </a:prstGeom>
         </p:spPr>
       </p:pic>
-      <p:pic>
-        <p:nvPicPr>
-          <p:cNvPr id="15" name="Image 1" descr="C:\Users\TR4_1950X\Documents\New project\assets\brand\rworld-official-logo-color.png">    </p:cNvPr>
-          <p:cNvPicPr>
-            <a:picLocks noChangeAspect="1"/>
-          </p:cNvPicPr>
-          <p:nvPr/>
-        </p:nvPicPr>
-        <p:blipFill>
-          <a:blip r:embed="rId2"/>
-          <a:stretch>
-            <a:fillRect/>
-          </a:stretch>
-        </p:blipFill>
-        <p:spPr>
-          <a:xfrm>
-            <a:off x="2318553" y="4345960"/>
-            <a:ext cx="2249424" cy="457383"/>
-          </a:xfrm>
-          <a:prstGeom prst="rect">
-            <a:avLst/>
-          </a:prstGeom>
-        </p:spPr>
-      </p:pic>
-      <p:sp>
-        <p:nvSpPr>
-          <p:cNvPr id="16" name="Text 12"/>
+      <p:sp>
+        <p:nvSpPr>
+          <p:cNvPr id="15" name="Text 12"/>
           <p:cNvSpPr/>
           <p:nvPr/>
         </p:nvSpPr>
@@ -5529,7 +5505,7 @@
       </p:sp>
       <p:sp>
         <p:nvSpPr>
-          <p:cNvPr id="17" name="Text 13"/>
+          <p:cNvPr id="16" name="Text 13"/>
           <p:cNvSpPr/>
           <p:nvPr/>
         </p:nvSpPr>
@@ -35206,12 +35182,12 @@
         </p:nvSpPr>
         <p:spPr>
           <a:xfrm>
-            <a:off x="6281928" y="3547872"/>
-            <a:ext cx="3673693" cy="645201"/>
+            <a:off x="6300216" y="3566160"/>
+            <a:ext cx="3795126" cy="746150"/>
           </a:xfrm>
           <a:prstGeom prst="roundRect">
             <a:avLst>
-              <a:gd name="adj" fmla="val 5669"/>
+              <a:gd name="adj" fmla="val 4902"/>
             </a:avLst>
           </a:prstGeom>
           <a:solidFill>
@@ -35231,7 +35207,7 @@
       </p:sp>
       <p:pic>
         <p:nvPicPr>
-          <p:cNvPr id="15" name="Image 0" descr="C:\Users\TR4_1950X\Documents\New project\assets\brand\miami-realtors-logo-color.png">    </p:cNvPr>
+          <p:cNvPr id="15" name="Image 0" descr="C:\Users\TR4_1950X\Documents\New project\assets\brand\miami-realtors-rworld-combined-logo.png">    </p:cNvPr>
           <p:cNvPicPr>
             <a:picLocks noChangeAspect="1"/>
           </p:cNvPicPr>
@@ -35246,40 +35222,16 @@
         <p:spPr>
           <a:xfrm>
             <a:off x="6446520" y="3675888"/>
-            <a:ext cx="1040221" cy="454274"/>
+            <a:ext cx="3502518" cy="526694"/>
           </a:xfrm>
           <a:prstGeom prst="rect">
             <a:avLst/>
           </a:prstGeom>
         </p:spPr>
       </p:pic>
-      <p:pic>
-        <p:nvPicPr>
-          <p:cNvPr id="16" name="Image 1" descr="C:\Users\TR4_1950X\Documents\New project\assets\brand\rworld-official-logo-color.png">    </p:cNvPr>
-          <p:cNvPicPr>
-            <a:picLocks noChangeAspect="1"/>
-          </p:cNvPicPr>
-          <p:nvPr/>
-        </p:nvPicPr>
-        <p:blipFill>
-          <a:blip r:embed="rId2"/>
-          <a:stretch>
-            <a:fillRect/>
-          </a:stretch>
-        </p:blipFill>
-        <p:spPr>
-          <a:xfrm>
-            <a:off x="7870789" y="3702223"/>
-            <a:ext cx="1975104" cy="401604"/>
-          </a:xfrm>
-          <a:prstGeom prst="rect">
-            <a:avLst/>
-          </a:prstGeom>
-        </p:spPr>
-      </p:pic>
-      <p:sp>
-        <p:nvSpPr>
-          <p:cNvPr id="17" name="Shape 13"/>
+      <p:sp>
+        <p:nvSpPr>
+          <p:cNvPr id="16" name="Shape 13"/>
           <p:cNvSpPr/>
           <p:nvPr/>
         </p:nvSpPr>
@@ -35302,7 +35254,7 @@
       </p:sp>
       <p:sp>
         <p:nvSpPr>
-          <p:cNvPr id="18" name="Text 14"/>
+          <p:cNvPr id="17" name="Text 14"/>
           <p:cNvSpPr/>
           <p:nvPr/>
         </p:nvSpPr>
@@ -35341,7 +35293,7 @@
       </p:sp>
       <p:sp>
         <p:nvSpPr>
-          <p:cNvPr id="19" name="Text 15"/>
+          <p:cNvPr id="18" name="Text 15"/>
           <p:cNvSpPr/>
           <p:nvPr/>
         </p:nvSpPr>

</xml_diff>

<commit_message>
Add instructor bio slide to course 1 deck
</commit_message>
<xml_diff>
--- a/slides/course-01-ai-for-real-estate-sales-approved-instructor-deck.pptx
+++ b/slides/course-01-ai-for-real-estate-sales-approved-instructor-deck.pptx
@@ -53,9 +53,10 @@
     <p:sldId id="301" r:id="rId47"/>
     <p:sldId id="302" r:id="rId48"/>
     <p:sldId id="303" r:id="rId49"/>
+    <p:sldId id="304" r:id="rId50"/>
   </p:sldIdLst>
   <p:notesMasterIdLst>
-    <p:notesMasterId r:id="rId50"/>
+    <p:notesMasterId r:id="rId51"/>
   </p:notesMasterIdLst>
   <p:sldSz cx="12191695" cy="6858000"/>
   <p:notesSz cx="6858000" cy="12191695"/>
@@ -4245,7 +4246,7 @@
           <a:p>
             <a:r>
               <a:rPr lang="en-US" dirty="0"/>
-              <a:t>Use remaining time for questions, examples, and follow-up requests.</a:t>
+              <a:t>Use this slide briefly. Keep it personal and contextual: why you teach this topic, why online lead response matters, and why the class remains vendor-neutral.</a:t>
             </a:r>
             <a:endParaRPr lang="en-US" dirty="0"/>
           </a:p>
@@ -4269,6 +4270,94 @@
             <a:fld id="{F7021451-1387-4CA6-816F-3879F97B5CBC}" type="slidenum">
               <a:rPr lang="en-US"/>
               <a:t>48</a:t>
+            </a:fld>
+            <a:endParaRPr lang="en-US"/>
+          </a:p>
+        </p:txBody>
+      </p:sp>
+    </p:spTree>
+    <p:extLst>
+      <p:ext uri="{BB962C8B-B14F-4D97-AF65-F5344CB8AC3E}">
+        <p14:creationId xmlns:p14="http://schemas.microsoft.com/office/powerpoint/2010/main" val="1024086991"/>
+      </p:ext>
+    </p:extLst>
+  </p:cSld>
+  <p:clrMapOvr>
+    <a:masterClrMapping/>
+  </p:clrMapOvr>
+</p:notes>
+</file>
+
+<file path=ppt/notesSlides/notesSlide49.xml><?xml version="1.0" encoding="utf-8"?>
+<p:notes xmlns:a="http://schemas.openxmlformats.org/drawingml/2006/main" xmlns:r="http://schemas.openxmlformats.org/officeDocument/2006/relationships" xmlns:p="http://schemas.openxmlformats.org/presentationml/2006/main">
+  <p:cSld>
+    <p:spTree>
+      <p:nvGrpSpPr>
+        <p:cNvPr id="1" name=""/>
+        <p:cNvGrpSpPr/>
+        <p:nvPr/>
+      </p:nvGrpSpPr>
+      <p:grpSpPr>
+        <a:xfrm>
+          <a:off x="0" y="0"/>
+          <a:ext cx="0" cy="0"/>
+          <a:chOff x="0" y="0"/>
+          <a:chExt cx="0" cy="0"/>
+        </a:xfrm>
+      </p:grpSpPr>
+      <p:sp>
+        <p:nvSpPr>
+          <p:cNvPr id="2" name="Slide Image Placeholder 1"/>
+          <p:cNvSpPr>
+            <a:spLocks noGrp="1" noRot="1" noChangeAspect="1"/>
+          </p:cNvSpPr>
+          <p:nvPr>
+            <p:ph type="sldImg"/>
+          </p:nvPr>
+        </p:nvSpPr>
+        <p:spPr/>
+      </p:sp>
+      <p:sp>
+        <p:nvSpPr>
+          <p:cNvPr id="3" name="Notes Placeholder 2"/>
+          <p:cNvSpPr>
+            <a:spLocks noGrp="1"/>
+          </p:cNvSpPr>
+          <p:nvPr>
+            <p:ph type="body" idx="1"/>
+          </p:nvPr>
+        </p:nvSpPr>
+        <p:spPr/>
+        <p:txBody>
+          <a:bodyPr/>
+          <a:lstStyle/>
+          <a:p>
+            <a:r>
+              <a:rPr lang="en-US" dirty="0"/>
+              <a:t>Use remaining time for questions, examples, and follow-up requests.</a:t>
+            </a:r>
+            <a:endParaRPr lang="en-US" dirty="0"/>
+          </a:p>
+        </p:txBody>
+      </p:sp>
+      <p:sp>
+        <p:nvSpPr>
+          <p:cNvPr id="4" name="Slide Number Placeholder 3"/>
+          <p:cNvSpPr>
+            <a:spLocks noGrp="1"/>
+          </p:cNvSpPr>
+          <p:nvPr>
+            <p:ph type="sldNum" sz="quarter" idx="10"/>
+          </p:nvPr>
+        </p:nvSpPr>
+        <p:spPr/>
+        <p:txBody>
+          <a:bodyPr/>
+          <a:lstStyle/>
+          <a:p>
+            <a:fld id="{F7021451-1387-4CA6-816F-3879F97B5CBC}" type="slidenum">
+              <a:rPr lang="en-US"/>
+              <a:t>49</a:t>
             </a:fld>
             <a:endParaRPr lang="en-US"/>
           </a:p>
@@ -6657,7 +6746,7 @@
                 <a:ea typeface="Aptos" pitchFamily="34" charset="-122"/>
                 <a:cs typeface="Aptos" pitchFamily="34" charset="-120"/>
               </a:rPr>
-              <a:t>11/48</a:t>
+              <a:t>11/49</a:t>
             </a:r>
             <a:endParaRPr lang="en-US" sz="720" dirty="0"/>
           </a:p>
@@ -7715,7 +7804,7 @@
                 <a:ea typeface="Aptos" pitchFamily="34" charset="-122"/>
                 <a:cs typeface="Aptos" pitchFamily="34" charset="-120"/>
               </a:rPr>
-              <a:t>12/48</a:t>
+              <a:t>12/49</a:t>
             </a:r>
             <a:endParaRPr lang="en-US" sz="720" dirty="0"/>
           </a:p>
@@ -8520,7 +8609,7 @@
                 <a:ea typeface="Aptos" pitchFamily="34" charset="-122"/>
                 <a:cs typeface="Aptos" pitchFamily="34" charset="-120"/>
               </a:rPr>
-              <a:t>13/48</a:t>
+              <a:t>13/49</a:t>
             </a:r>
             <a:endParaRPr lang="en-US" sz="720" dirty="0"/>
           </a:p>
@@ -9132,7 +9221,7 @@
                 <a:ea typeface="Aptos" pitchFamily="34" charset="-122"/>
                 <a:cs typeface="Aptos" pitchFamily="34" charset="-120"/>
               </a:rPr>
-              <a:t>14/48</a:t>
+              <a:t>14/49</a:t>
             </a:r>
             <a:endParaRPr lang="en-US" sz="720" dirty="0"/>
           </a:p>
@@ -10447,7 +10536,7 @@
                 <a:ea typeface="Aptos" pitchFamily="34" charset="-122"/>
                 <a:cs typeface="Aptos" pitchFamily="34" charset="-120"/>
               </a:rPr>
-              <a:t>16/48</a:t>
+              <a:t>16/49</a:t>
             </a:r>
             <a:endParaRPr lang="en-US" sz="720" dirty="0"/>
           </a:p>
@@ -11113,7 +11202,7 @@
                 <a:ea typeface="Aptos" pitchFamily="34" charset="-122"/>
                 <a:cs typeface="Aptos" pitchFamily="34" charset="-120"/>
               </a:rPr>
-              <a:t>17/48</a:t>
+              <a:t>17/49</a:t>
             </a:r>
             <a:endParaRPr lang="en-US" sz="720" dirty="0"/>
           </a:p>
@@ -11779,7 +11868,7 @@
                 <a:ea typeface="Aptos" pitchFamily="34" charset="-122"/>
                 <a:cs typeface="Aptos" pitchFamily="34" charset="-120"/>
               </a:rPr>
-              <a:t>18/48</a:t>
+              <a:t>18/49</a:t>
             </a:r>
             <a:endParaRPr lang="en-US" sz="720" dirty="0"/>
           </a:p>
@@ -12584,7 +12673,7 @@
                 <a:ea typeface="Aptos" pitchFamily="34" charset="-122"/>
                 <a:cs typeface="Aptos" pitchFamily="34" charset="-120"/>
               </a:rPr>
-              <a:t>19/48</a:t>
+              <a:t>19/49</a:t>
             </a:r>
             <a:endParaRPr lang="en-US" sz="720" dirty="0"/>
           </a:p>
@@ -13304,7 +13393,7 @@
                 <a:ea typeface="Aptos" pitchFamily="34" charset="-122"/>
                 <a:cs typeface="Aptos" pitchFamily="34" charset="-120"/>
               </a:rPr>
-              <a:t>2/48</a:t>
+              <a:t>2/49</a:t>
             </a:r>
             <a:endParaRPr lang="en-US" sz="720" dirty="0"/>
           </a:p>
@@ -14218,7 +14307,7 @@
                 <a:ea typeface="Aptos" pitchFamily="34" charset="-122"/>
                 <a:cs typeface="Aptos" pitchFamily="34" charset="-120"/>
               </a:rPr>
-              <a:t>20/48</a:t>
+              <a:t>20/49</a:t>
             </a:r>
             <a:endParaRPr lang="en-US" sz="720" dirty="0"/>
           </a:p>
@@ -15237,7 +15326,7 @@
                 <a:ea typeface="Aptos" pitchFamily="34" charset="-122"/>
                 <a:cs typeface="Aptos" pitchFamily="34" charset="-120"/>
               </a:rPr>
-              <a:t>22/48</a:t>
+              <a:t>22/49</a:t>
             </a:r>
             <a:endParaRPr lang="en-US" sz="720" dirty="0"/>
           </a:p>
@@ -16361,7 +16450,7 @@
                 <a:ea typeface="Aptos" pitchFamily="34" charset="-122"/>
                 <a:cs typeface="Aptos" pitchFamily="34" charset="-120"/>
               </a:rPr>
-              <a:t>23/48</a:t>
+              <a:t>23/49</a:t>
             </a:r>
             <a:endParaRPr lang="en-US" sz="720" dirty="0"/>
           </a:p>
@@ -17047,7 +17136,7 @@
                 <a:ea typeface="Aptos" pitchFamily="34" charset="-122"/>
                 <a:cs typeface="Aptos" pitchFamily="34" charset="-120"/>
               </a:rPr>
-              <a:t>24/48</a:t>
+              <a:t>24/49</a:t>
             </a:r>
             <a:endParaRPr lang="en-US" sz="720" dirty="0"/>
           </a:p>
@@ -17832,7 +17921,7 @@
                 <a:ea typeface="Aptos" pitchFamily="34" charset="-122"/>
                 <a:cs typeface="Aptos" pitchFamily="34" charset="-120"/>
               </a:rPr>
-              <a:t>25/48</a:t>
+              <a:t>25/49</a:t>
             </a:r>
             <a:endParaRPr lang="en-US" sz="720" dirty="0"/>
           </a:p>
@@ -18890,7 +18979,7 @@
                 <a:ea typeface="Aptos" pitchFamily="34" charset="-122"/>
                 <a:cs typeface="Aptos" pitchFamily="34" charset="-120"/>
               </a:rPr>
-              <a:t>26/48</a:t>
+              <a:t>26/49</a:t>
             </a:r>
             <a:endParaRPr lang="en-US" sz="720" dirty="0"/>
           </a:p>
@@ -19927,7 +20016,7 @@
                 <a:ea typeface="Aptos" pitchFamily="34" charset="-122"/>
                 <a:cs typeface="Aptos" pitchFamily="34" charset="-120"/>
               </a:rPr>
-              <a:t>28/48</a:t>
+              <a:t>28/49</a:t>
             </a:r>
             <a:endParaRPr lang="en-US" sz="720" dirty="0"/>
           </a:p>
@@ -20595,7 +20684,7 @@
                 <a:ea typeface="Aptos" pitchFamily="34" charset="-122"/>
                 <a:cs typeface="Aptos" pitchFamily="34" charset="-120"/>
               </a:rPr>
-              <a:t>29/48</a:t>
+              <a:t>29/49</a:t>
             </a:r>
             <a:endParaRPr lang="en-US" sz="720" dirty="0"/>
           </a:p>
@@ -21333,7 +21422,7 @@
                 <a:ea typeface="Aptos" pitchFamily="34" charset="-122"/>
                 <a:cs typeface="Aptos" pitchFamily="34" charset="-120"/>
               </a:rPr>
-              <a:t>3/48</a:t>
+              <a:t>3/49</a:t>
             </a:r>
             <a:endParaRPr lang="en-US" sz="720" dirty="0"/>
           </a:p>
@@ -22337,7 +22426,7 @@
                 <a:ea typeface="Aptos" pitchFamily="34" charset="-122"/>
                 <a:cs typeface="Aptos" pitchFamily="34" charset="-120"/>
               </a:rPr>
-              <a:t>30/48</a:t>
+              <a:t>30/49</a:t>
             </a:r>
             <a:endParaRPr lang="en-US" sz="720" dirty="0"/>
           </a:p>
@@ -23104,7 +23193,7 @@
                 <a:ea typeface="Aptos" pitchFamily="34" charset="-122"/>
                 <a:cs typeface="Aptos" pitchFamily="34" charset="-120"/>
               </a:rPr>
-              <a:t>31/48</a:t>
+              <a:t>31/49</a:t>
             </a:r>
             <a:endParaRPr lang="en-US" sz="720" dirty="0"/>
           </a:p>
@@ -24141,7 +24230,7 @@
                 <a:ea typeface="Aptos" pitchFamily="34" charset="-122"/>
                 <a:cs typeface="Aptos" pitchFamily="34" charset="-120"/>
               </a:rPr>
-              <a:t>33/48</a:t>
+              <a:t>33/49</a:t>
             </a:r>
             <a:endParaRPr lang="en-US" sz="720" dirty="0"/>
           </a:p>
@@ -24643,7 +24732,7 @@
                 <a:ea typeface="Aptos" pitchFamily="34" charset="-122"/>
                 <a:cs typeface="Aptos" pitchFamily="34" charset="-120"/>
               </a:rPr>
-              <a:t>34/48</a:t>
+              <a:t>34/49</a:t>
             </a:r>
             <a:endParaRPr lang="en-US" sz="720" dirty="0"/>
           </a:p>
@@ -25145,7 +25234,7 @@
                 <a:ea typeface="Aptos" pitchFamily="34" charset="-122"/>
                 <a:cs typeface="Aptos" pitchFamily="34" charset="-120"/>
               </a:rPr>
-              <a:t>35/48</a:t>
+              <a:t>35/49</a:t>
             </a:r>
             <a:endParaRPr lang="en-US" sz="720" dirty="0"/>
           </a:p>
@@ -25930,7 +26019,7 @@
                 <a:ea typeface="Aptos" pitchFamily="34" charset="-122"/>
                 <a:cs typeface="Aptos" pitchFamily="34" charset="-120"/>
               </a:rPr>
-              <a:t>36/48</a:t>
+              <a:t>36/49</a:t>
             </a:r>
             <a:endParaRPr lang="en-US" sz="720" dirty="0"/>
           </a:p>
@@ -27287,7 +27376,7 @@
                 <a:ea typeface="Aptos" pitchFamily="34" charset="-122"/>
                 <a:cs typeface="Aptos" pitchFamily="34" charset="-120"/>
               </a:rPr>
-              <a:t>38/48</a:t>
+              <a:t>38/49</a:t>
             </a:r>
             <a:endParaRPr lang="en-US" sz="720" dirty="0"/>
           </a:p>
@@ -28079,7 +28168,7 @@
                 <a:ea typeface="Aptos" pitchFamily="34" charset="-122"/>
                 <a:cs typeface="Aptos" pitchFamily="34" charset="-120"/>
               </a:rPr>
-              <a:t>39/48</a:t>
+              <a:t>39/49</a:t>
             </a:r>
             <a:endParaRPr lang="en-US" sz="720" dirty="0"/>
           </a:p>
@@ -28835,7 +28924,7 @@
                 <a:ea typeface="Aptos" pitchFamily="34" charset="-122"/>
                 <a:cs typeface="Aptos" pitchFamily="34" charset="-120"/>
               </a:rPr>
-              <a:t>4/48</a:t>
+              <a:t>4/49</a:t>
             </a:r>
             <a:endParaRPr lang="en-US" sz="720" dirty="0"/>
           </a:p>
@@ -29657,7 +29746,7 @@
                 <a:ea typeface="Aptos" pitchFamily="34" charset="-122"/>
                 <a:cs typeface="Aptos" pitchFamily="34" charset="-120"/>
               </a:rPr>
-              <a:t>40/48</a:t>
+              <a:t>40/49</a:t>
             </a:r>
             <a:endParaRPr lang="en-US" sz="720" dirty="0"/>
           </a:p>
@@ -30442,7 +30531,7 @@
                 <a:ea typeface="Aptos" pitchFamily="34" charset="-122"/>
                 <a:cs typeface="Aptos" pitchFamily="34" charset="-120"/>
               </a:rPr>
-              <a:t>41/48</a:t>
+              <a:t>41/49</a:t>
             </a:r>
             <a:endParaRPr lang="en-US" sz="720" dirty="0"/>
           </a:p>
@@ -31781,7 +31870,7 @@
                 <a:ea typeface="Aptos" pitchFamily="34" charset="-122"/>
                 <a:cs typeface="Aptos" pitchFamily="34" charset="-120"/>
               </a:rPr>
-              <a:t>43/48</a:t>
+              <a:t>43/49</a:t>
             </a:r>
             <a:endParaRPr lang="en-US" sz="720" dirty="0"/>
           </a:p>
@@ -32305,7 +32394,7 @@
                 <a:ea typeface="Aptos" pitchFamily="34" charset="-122"/>
                 <a:cs typeface="Aptos" pitchFamily="34" charset="-120"/>
               </a:rPr>
-              <a:t>44/48</a:t>
+              <a:t>44/49</a:t>
             </a:r>
             <a:endParaRPr lang="en-US" sz="720" dirty="0"/>
           </a:p>
@@ -33306,7 +33395,7 @@
                 <a:ea typeface="Aptos" pitchFamily="34" charset="-122"/>
                 <a:cs typeface="Aptos" pitchFamily="34" charset="-120"/>
               </a:rPr>
-              <a:t>45/48</a:t>
+              <a:t>45/49</a:t>
             </a:r>
             <a:endParaRPr lang="en-US" sz="720" dirty="0"/>
           </a:p>
@@ -34044,7 +34133,7 @@
                 <a:ea typeface="Aptos" pitchFamily="34" charset="-122"/>
                 <a:cs typeface="Aptos" pitchFamily="34" charset="-120"/>
               </a:rPr>
-              <a:t>46/48</a:t>
+              <a:t>46/49</a:t>
             </a:r>
             <a:endParaRPr lang="en-US" sz="720" dirty="0"/>
           </a:p>
@@ -34764,7 +34853,7 @@
                 <a:ea typeface="Aptos" pitchFamily="34" charset="-122"/>
                 <a:cs typeface="Aptos" pitchFamily="34" charset="-120"/>
               </a:rPr>
-              <a:t>47/48</a:t>
+              <a:t>47/49</a:t>
             </a:r>
             <a:endParaRPr lang="en-US" sz="720" dirty="0"/>
           </a:p>
@@ -35032,6 +35121,894 @@
                 <a:ea typeface="Aptos" pitchFamily="34" charset="-122"/>
                 <a:cs typeface="Aptos" pitchFamily="34" charset="-120"/>
               </a:rPr>
+              <a:t>ABOUT THE INSTRUCTOR</a:t>
+            </a:r>
+            <a:endParaRPr lang="en-US" sz="880" dirty="0"/>
+          </a:p>
+        </p:txBody>
+      </p:sp>
+      <p:sp>
+        <p:nvSpPr>
+          <p:cNvPr id="10" name="Text 8"/>
+          <p:cNvSpPr/>
+          <p:nvPr/>
+        </p:nvSpPr>
+        <p:spPr>
+          <a:xfrm>
+            <a:off x="658368" y="786384"/>
+            <a:ext cx="10424160" cy="585216"/>
+          </a:xfrm>
+          <a:prstGeom prst="rect">
+            <a:avLst/>
+          </a:prstGeom>
+          <a:noFill/>
+          <a:ln/>
+        </p:spPr>
+        <p:txBody>
+          <a:bodyPr wrap="square" lIns="0" tIns="0" rIns="0" bIns="0" rtlCol="0" anchor="ctr">
+            <a:normAutofit/>
+          </a:bodyPr>
+          <a:lstStyle/>
+          <a:p>
+            <a:pPr indent="0" marL="0">
+              <a:buNone/>
+            </a:pPr>
+            <a:r>
+              <a:rPr lang="en-US" sz="2800" b="1" dirty="0">
+                <a:solidFill>
+                  <a:srgbClr val="102033"/>
+                </a:solidFill>
+                <a:latin typeface="Aptos Display" pitchFamily="34" charset="0"/>
+                <a:ea typeface="Aptos Display" pitchFamily="34" charset="-122"/>
+                <a:cs typeface="Aptos Display" pitchFamily="34" charset="-120"/>
+              </a:rPr>
+              <a:t>About the Instructor</a:t>
+            </a:r>
+            <a:endParaRPr lang="en-US" sz="2800" dirty="0"/>
+          </a:p>
+        </p:txBody>
+      </p:sp>
+      <p:sp>
+        <p:nvSpPr>
+          <p:cNvPr id="11" name="Shape 9"/>
+          <p:cNvSpPr/>
+          <p:nvPr/>
+        </p:nvSpPr>
+        <p:spPr>
+          <a:xfrm>
+            <a:off x="868680" y="1828800"/>
+            <a:ext cx="4800600" cy="3520440"/>
+          </a:xfrm>
+          <a:prstGeom prst="roundRect">
+            <a:avLst>
+              <a:gd name="adj" fmla="val 1558"/>
+            </a:avLst>
+          </a:prstGeom>
+          <a:solidFill>
+            <a:srgbClr val="FFFFFF"/>
+          </a:solidFill>
+          <a:ln w="10160">
+            <a:solidFill>
+              <a:srgbClr val="D8E6E8"/>
+            </a:solidFill>
+            <a:prstDash val="solid"/>
+          </a:ln>
+        </p:spPr>
+      </p:sp>
+      <p:sp>
+        <p:nvSpPr>
+          <p:cNvPr id="12" name="Text 10"/>
+          <p:cNvSpPr/>
+          <p:nvPr/>
+        </p:nvSpPr>
+        <p:spPr>
+          <a:xfrm>
+            <a:off x="1170432" y="2084832"/>
+            <a:ext cx="1280160" cy="164592"/>
+          </a:xfrm>
+          <a:prstGeom prst="rect">
+            <a:avLst/>
+          </a:prstGeom>
+          <a:noFill/>
+          <a:ln/>
+        </p:spPr>
+        <p:txBody>
+          <a:bodyPr wrap="square" lIns="0" tIns="0" rIns="0" bIns="0" rtlCol="0" anchor="ctr"/>
+          <a:lstStyle/>
+          <a:p>
+            <a:pPr indent="0" marL="0">
+              <a:buNone/>
+            </a:pPr>
+            <a:r>
+              <a:rPr lang="en-US" sz="950" b="1" dirty="0">
+                <a:solidFill>
+                  <a:srgbClr val="008F8F"/>
+                </a:solidFill>
+              </a:rPr>
+              <a:t>Instructor</a:t>
+            </a:r>
+            <a:endParaRPr lang="en-US" sz="950" dirty="0"/>
+          </a:p>
+        </p:txBody>
+      </p:sp>
+      <p:sp>
+        <p:nvSpPr>
+          <p:cNvPr id="13" name="Text 11"/>
+          <p:cNvSpPr/>
+          <p:nvPr/>
+        </p:nvSpPr>
+        <p:spPr>
+          <a:xfrm>
+            <a:off x="1170432" y="2395728"/>
+            <a:ext cx="4160520" cy="347472"/>
+          </a:xfrm>
+          <a:prstGeom prst="rect">
+            <a:avLst/>
+          </a:prstGeom>
+          <a:noFill/>
+          <a:ln/>
+        </p:spPr>
+        <p:txBody>
+          <a:bodyPr wrap="square" lIns="0" tIns="0" rIns="0" bIns="0" rtlCol="0" anchor="ctr">
+            <a:normAutofit/>
+          </a:bodyPr>
+          <a:lstStyle/>
+          <a:p>
+            <a:pPr indent="0" marL="0">
+              <a:buNone/>
+            </a:pPr>
+            <a:r>
+              <a:rPr lang="en-US" sz="2200" b="1" dirty="0">
+                <a:solidFill>
+                  <a:srgbClr val="16324F"/>
+                </a:solidFill>
+              </a:rPr>
+              <a:t>Ian Burton Price</a:t>
+            </a:r>
+            <a:endParaRPr lang="en-US" sz="2200" dirty="0"/>
+          </a:p>
+        </p:txBody>
+      </p:sp>
+      <p:sp>
+        <p:nvSpPr>
+          <p:cNvPr id="14" name="Text 12"/>
+          <p:cNvSpPr/>
+          <p:nvPr/>
+        </p:nvSpPr>
+        <p:spPr>
+          <a:xfrm>
+            <a:off x="1170432" y="2816352"/>
+            <a:ext cx="4160520" cy="274320"/>
+          </a:xfrm>
+          <a:prstGeom prst="rect">
+            <a:avLst/>
+          </a:prstGeom>
+          <a:noFill/>
+          <a:ln/>
+        </p:spPr>
+        <p:txBody>
+          <a:bodyPr wrap="square" lIns="0" tIns="0" rIns="0" bIns="0" rtlCol="0" anchor="ctr">
+            <a:normAutofit/>
+          </a:bodyPr>
+          <a:lstStyle/>
+          <a:p>
+            <a:pPr indent="0" marL="0">
+              <a:buNone/>
+            </a:pPr>
+            <a:r>
+              <a:rPr lang="en-US" sz="1280" dirty="0">
+                <a:solidFill>
+                  <a:srgbClr val="52606D"/>
+                </a:solidFill>
+              </a:rPr>
+              <a:t>Real estate technology educator and founder of GoHouse.ai</a:t>
+            </a:r>
+            <a:endParaRPr lang="en-US" sz="1280" dirty="0"/>
+          </a:p>
+        </p:txBody>
+      </p:sp>
+      <p:sp>
+        <p:nvSpPr>
+          <p:cNvPr id="15" name="Shape 13"/>
+          <p:cNvSpPr/>
+          <p:nvPr/>
+        </p:nvSpPr>
+        <p:spPr>
+          <a:xfrm>
+            <a:off x="1170432" y="3291840"/>
+            <a:ext cx="1234440" cy="0"/>
+          </a:xfrm>
+          <a:prstGeom prst="line">
+            <a:avLst/>
+          </a:prstGeom>
+          <a:noFill/>
+          <a:ln w="38100">
+            <a:solidFill>
+              <a:srgbClr val="F45B69"/>
+            </a:solidFill>
+            <a:prstDash val="solid"/>
+          </a:ln>
+        </p:spPr>
+      </p:sp>
+      <p:sp>
+        <p:nvSpPr>
+          <p:cNvPr id="16" name="Text 14"/>
+          <p:cNvSpPr/>
+          <p:nvPr/>
+        </p:nvSpPr>
+        <p:spPr>
+          <a:xfrm>
+            <a:off x="1170432" y="3584448"/>
+            <a:ext cx="4069080" cy="1005840"/>
+          </a:xfrm>
+          <a:prstGeom prst="rect">
+            <a:avLst/>
+          </a:prstGeom>
+          <a:noFill/>
+          <a:ln/>
+        </p:spPr>
+        <p:txBody>
+          <a:bodyPr wrap="square" lIns="254" tIns="254" rIns="254" bIns="254" rtlCol="0" anchor="t">
+            <a:normAutofit/>
+          </a:bodyPr>
+          <a:lstStyle/>
+          <a:p>
+            <a:pPr marL="203200" indent="-203200">
+              <a:buSzPct val="100000"/>
+              <a:buChar char="•"/>
+            </a:pPr>
+            <a:r>
+              <a:rPr lang="en-US" sz="1170" dirty="0">
+                <a:solidFill>
+                  <a:srgbClr val="102033"/>
+                </a:solidFill>
+                <a:latin typeface="Aptos" pitchFamily="34" charset="0"/>
+                <a:ea typeface="Aptos" pitchFamily="34" charset="-122"/>
+                <a:cs typeface="Aptos" pitchFamily="34" charset="-120"/>
+              </a:rPr>
+              <a:t>Practical AI workflows for real estate sales, online lead response, and daily agent productivity</a:t>
+            </a:r>
+            <a:endParaRPr lang="en-US" sz="1170" dirty="0"/>
+          </a:p>
+          <a:p>
+            <a:pPr marL="203200" indent="-203200">
+              <a:buSzPct val="100000"/>
+              <a:buChar char="•"/>
+            </a:pPr>
+            <a:r>
+              <a:rPr lang="en-US" sz="1170" dirty="0">
+                <a:solidFill>
+                  <a:srgbClr val="102033"/>
+                </a:solidFill>
+                <a:latin typeface="Aptos" pitchFamily="34" charset="0"/>
+                <a:ea typeface="Aptos" pitchFamily="34" charset="-122"/>
+                <a:cs typeface="Aptos" pitchFamily="34" charset="-120"/>
+              </a:rPr>
+              <a:t>Focus on helping agents use AI responsibly while keeping their own voice and professional judgment</a:t>
+            </a:r>
+            <a:endParaRPr lang="en-US" sz="1170" dirty="0"/>
+          </a:p>
+          <a:p>
+            <a:pPr marL="203200" indent="-203200">
+              <a:buSzPct val="100000"/>
+              <a:buChar char="•"/>
+            </a:pPr>
+            <a:r>
+              <a:rPr lang="en-US" sz="1170" dirty="0">
+                <a:solidFill>
+                  <a:srgbClr val="102033"/>
+                </a:solidFill>
+                <a:latin typeface="Aptos" pitchFamily="34" charset="0"/>
+                <a:ea typeface="Aptos" pitchFamily="34" charset="-122"/>
+                <a:cs typeface="Aptos" pitchFamily="34" charset="-120"/>
+              </a:rPr>
+              <a:t>Experience building at the intersection of real estate websites, CRMs, lead conversion, and automation</a:t>
+            </a:r>
+            <a:endParaRPr lang="en-US" sz="1170" dirty="0"/>
+          </a:p>
+        </p:txBody>
+      </p:sp>
+      <p:sp>
+        <p:nvSpPr>
+          <p:cNvPr id="17" name="Shape 15"/>
+          <p:cNvSpPr/>
+          <p:nvPr/>
+        </p:nvSpPr>
+        <p:spPr>
+          <a:xfrm>
+            <a:off x="6172200" y="1737360"/>
+            <a:ext cx="128016" cy="3657600"/>
+          </a:xfrm>
+          <a:prstGeom prst="rect">
+            <a:avLst/>
+          </a:prstGeom>
+          <a:solidFill>
+            <a:srgbClr val="008F8F"/>
+          </a:solidFill>
+          <a:ln w="12700">
+            <a:solidFill>
+              <a:srgbClr val="008F8F"/>
+            </a:solidFill>
+            <a:prstDash val="solid"/>
+          </a:ln>
+        </p:spPr>
+      </p:sp>
+      <p:sp>
+        <p:nvSpPr>
+          <p:cNvPr id="18" name="Shape 16"/>
+          <p:cNvSpPr/>
+          <p:nvPr/>
+        </p:nvSpPr>
+        <p:spPr>
+          <a:xfrm>
+            <a:off x="6309360" y="1828800"/>
+            <a:ext cx="4434840" cy="3520440"/>
+          </a:xfrm>
+          <a:prstGeom prst="roundRect">
+            <a:avLst>
+              <a:gd name="adj" fmla="val 1558"/>
+            </a:avLst>
+          </a:prstGeom>
+          <a:solidFill>
+            <a:srgbClr val="EAF7F7"/>
+          </a:solidFill>
+          <a:ln w="10160">
+            <a:solidFill>
+              <a:srgbClr val="BFDADC"/>
+            </a:solidFill>
+            <a:prstDash val="solid"/>
+          </a:ln>
+        </p:spPr>
+      </p:sp>
+      <p:sp>
+        <p:nvSpPr>
+          <p:cNvPr id="19" name="Text 17"/>
+          <p:cNvSpPr/>
+          <p:nvPr/>
+        </p:nvSpPr>
+        <p:spPr>
+          <a:xfrm>
+            <a:off x="6629400" y="2130552"/>
+            <a:ext cx="2743200" cy="347472"/>
+          </a:xfrm>
+          <a:prstGeom prst="rect">
+            <a:avLst/>
+          </a:prstGeom>
+          <a:noFill/>
+          <a:ln/>
+        </p:spPr>
+        <p:txBody>
+          <a:bodyPr wrap="square" lIns="0" tIns="0" rIns="0" bIns="0" rtlCol="0" anchor="ctr"/>
+          <a:lstStyle/>
+          <a:p>
+            <a:pPr indent="0" marL="0">
+              <a:buNone/>
+            </a:pPr>
+            <a:r>
+              <a:rPr lang="en-US" sz="2200" b="1" dirty="0">
+                <a:solidFill>
+                  <a:srgbClr val="16324F"/>
+                </a:solidFill>
+              </a:rPr>
+              <a:t>GoHouse.ai</a:t>
+            </a:r>
+            <a:endParaRPr lang="en-US" sz="2200" dirty="0"/>
+          </a:p>
+        </p:txBody>
+      </p:sp>
+      <p:sp>
+        <p:nvSpPr>
+          <p:cNvPr id="20" name="Text 18"/>
+          <p:cNvSpPr/>
+          <p:nvPr/>
+        </p:nvSpPr>
+        <p:spPr>
+          <a:xfrm>
+            <a:off x="6629400" y="2606040"/>
+            <a:ext cx="3566160" cy="201168"/>
+          </a:xfrm>
+          <a:prstGeom prst="rect">
+            <a:avLst/>
+          </a:prstGeom>
+          <a:noFill/>
+          <a:ln/>
+        </p:spPr>
+        <p:txBody>
+          <a:bodyPr wrap="square" lIns="0" tIns="0" rIns="0" bIns="0" rtlCol="0" anchor="ctr"/>
+          <a:lstStyle/>
+          <a:p>
+            <a:pPr indent="0" marL="0">
+              <a:buNone/>
+            </a:pPr>
+            <a:r>
+              <a:rPr lang="en-US" sz="1050" b="1" dirty="0">
+                <a:solidFill>
+                  <a:srgbClr val="008F8F"/>
+                </a:solidFill>
+              </a:rPr>
+              <a:t>Where this work shows up in the real world</a:t>
+            </a:r>
+            <a:endParaRPr lang="en-US" sz="1050" dirty="0"/>
+          </a:p>
+        </p:txBody>
+      </p:sp>
+      <p:sp>
+        <p:nvSpPr>
+          <p:cNvPr id="21" name="Text 19"/>
+          <p:cNvSpPr/>
+          <p:nvPr/>
+        </p:nvSpPr>
+        <p:spPr>
+          <a:xfrm>
+            <a:off x="6629400" y="3090672"/>
+            <a:ext cx="3657600" cy="1325880"/>
+          </a:xfrm>
+          <a:prstGeom prst="rect">
+            <a:avLst/>
+          </a:prstGeom>
+          <a:noFill/>
+          <a:ln/>
+        </p:spPr>
+        <p:txBody>
+          <a:bodyPr wrap="square" lIns="254" tIns="254" rIns="254" bIns="254" rtlCol="0" anchor="t">
+            <a:normAutofit/>
+          </a:bodyPr>
+          <a:lstStyle/>
+          <a:p>
+            <a:pPr marL="203200" indent="-203200">
+              <a:buSzPct val="100000"/>
+              <a:buChar char="•"/>
+            </a:pPr>
+            <a:r>
+              <a:rPr lang="en-US" sz="1170" dirty="0">
+                <a:solidFill>
+                  <a:srgbClr val="102033"/>
+                </a:solidFill>
+                <a:latin typeface="Aptos" pitchFamily="34" charset="0"/>
+                <a:ea typeface="Aptos" pitchFamily="34" charset="-122"/>
+                <a:cs typeface="Aptos" pitchFamily="34" charset="-120"/>
+              </a:rPr>
+              <a:t>GoHouse.ai is an AI-assisted real estate lead engagement and follow-up platform</a:t>
+            </a:r>
+            <a:endParaRPr lang="en-US" sz="1170" dirty="0"/>
+          </a:p>
+          <a:p>
+            <a:pPr marL="203200" indent="-203200">
+              <a:buSzPct val="100000"/>
+              <a:buChar char="•"/>
+            </a:pPr>
+            <a:r>
+              <a:rPr lang="en-US" sz="1170" dirty="0">
+                <a:solidFill>
+                  <a:srgbClr val="102033"/>
+                </a:solidFill>
+                <a:latin typeface="Aptos" pitchFamily="34" charset="0"/>
+                <a:ea typeface="Aptos" pitchFamily="34" charset="-122"/>
+                <a:cs typeface="Aptos" pitchFamily="34" charset="-120"/>
+              </a:rPr>
+              <a:t>Built around faster response, clearer nurture workflows, and better conversion from online interest to real conversations</a:t>
+            </a:r>
+            <a:endParaRPr lang="en-US" sz="1170" dirty="0"/>
+          </a:p>
+          <a:p>
+            <a:pPr marL="203200" indent="-203200">
+              <a:buSzPct val="100000"/>
+              <a:buChar char="•"/>
+            </a:pPr>
+            <a:r>
+              <a:rPr lang="en-US" sz="1170" dirty="0">
+                <a:solidFill>
+                  <a:srgbClr val="102033"/>
+                </a:solidFill>
+                <a:latin typeface="Aptos" pitchFamily="34" charset="0"/>
+                <a:ea typeface="Aptos" pitchFamily="34" charset="-122"/>
+                <a:cs typeface="Aptos" pitchFamily="34" charset="-120"/>
+              </a:rPr>
+              <a:t>Mentioned here as instructor context; no GoHouse.ai product is required for this course</a:t>
+            </a:r>
+            <a:endParaRPr lang="en-US" sz="1170" dirty="0"/>
+          </a:p>
+        </p:txBody>
+      </p:sp>
+      <p:sp>
+        <p:nvSpPr>
+          <p:cNvPr id="22" name="Text 20"/>
+          <p:cNvSpPr/>
+          <p:nvPr/>
+        </p:nvSpPr>
+        <p:spPr>
+          <a:xfrm>
+            <a:off x="6629400" y="4800600"/>
+            <a:ext cx="2651760" cy="164592"/>
+          </a:xfrm>
+          <a:prstGeom prst="rect">
+            <a:avLst/>
+          </a:prstGeom>
+          <a:noFill/>
+          <a:ln/>
+        </p:spPr>
+        <p:txBody>
+          <a:bodyPr wrap="square" lIns="0" tIns="0" rIns="0" bIns="0" rtlCol="0" anchor="ctr"/>
+          <a:lstStyle/>
+          <a:p>
+            <a:pPr indent="0" marL="0">
+              <a:buNone/>
+            </a:pPr>
+            <a:r>
+              <a:rPr lang="en-US" sz="950" b="1" dirty="0">
+                <a:solidFill>
+                  <a:srgbClr val="2E7D5B"/>
+                </a:solidFill>
+              </a:rPr>
+              <a:t>Context, not a product requirement</a:t>
+            </a:r>
+            <a:endParaRPr lang="en-US" sz="950" dirty="0"/>
+          </a:p>
+        </p:txBody>
+      </p:sp>
+      <p:sp>
+        <p:nvSpPr>
+          <p:cNvPr id="23" name="Shape 21"/>
+          <p:cNvSpPr/>
+          <p:nvPr/>
+        </p:nvSpPr>
+        <p:spPr>
+          <a:xfrm>
+            <a:off x="502920" y="6473952"/>
+            <a:ext cx="11201400" cy="0"/>
+          </a:xfrm>
+          <a:prstGeom prst="line">
+            <a:avLst/>
+          </a:prstGeom>
+          <a:noFill/>
+          <a:ln w="9525">
+            <a:solidFill>
+              <a:srgbClr val="D8E6E8"/>
+            </a:solidFill>
+            <a:prstDash val="solid"/>
+          </a:ln>
+        </p:spPr>
+      </p:sp>
+      <p:sp>
+        <p:nvSpPr>
+          <p:cNvPr id="24" name="Text 22"/>
+          <p:cNvSpPr/>
+          <p:nvPr/>
+        </p:nvSpPr>
+        <p:spPr>
+          <a:xfrm>
+            <a:off x="502920" y="6565392"/>
+            <a:ext cx="7132320" cy="164592"/>
+          </a:xfrm>
+          <a:prstGeom prst="rect">
+            <a:avLst/>
+          </a:prstGeom>
+          <a:noFill/>
+          <a:ln/>
+        </p:spPr>
+        <p:txBody>
+          <a:bodyPr wrap="square" lIns="0" tIns="0" rIns="0" bIns="0" rtlCol="0" anchor="ctr"/>
+          <a:lstStyle/>
+          <a:p>
+            <a:pPr indent="0" marL="0">
+              <a:buNone/>
+            </a:pPr>
+            <a:r>
+              <a:rPr lang="en-US" sz="720" dirty="0">
+                <a:solidFill>
+                  <a:srgbClr val="52606D"/>
+                </a:solidFill>
+                <a:latin typeface="Aptos" pitchFamily="34" charset="0"/>
+                <a:ea typeface="Aptos" pitchFamily="34" charset="-122"/>
+                <a:cs typeface="Aptos" pitchFamily="34" charset="-120"/>
+              </a:rPr>
+              <a:t>Approved REALTOR education course | MIAMI REALTORS + RWorld members</a:t>
+            </a:r>
+            <a:endParaRPr lang="en-US" sz="720" dirty="0"/>
+          </a:p>
+        </p:txBody>
+      </p:sp>
+      <p:sp>
+        <p:nvSpPr>
+          <p:cNvPr id="25" name="Text 23"/>
+          <p:cNvSpPr/>
+          <p:nvPr/>
+        </p:nvSpPr>
+        <p:spPr>
+          <a:xfrm>
+            <a:off x="10927080" y="6565392"/>
+            <a:ext cx="731520" cy="164592"/>
+          </a:xfrm>
+          <a:prstGeom prst="rect">
+            <a:avLst/>
+          </a:prstGeom>
+          <a:noFill/>
+          <a:ln/>
+        </p:spPr>
+        <p:txBody>
+          <a:bodyPr wrap="square" lIns="0" tIns="0" rIns="0" bIns="0" rtlCol="0" anchor="ctr"/>
+          <a:lstStyle/>
+          <a:p>
+            <a:pPr algn="r" indent="0" marL="0">
+              <a:buNone/>
+            </a:pPr>
+            <a:r>
+              <a:rPr lang="en-US" sz="720" dirty="0">
+                <a:solidFill>
+                  <a:srgbClr val="52606D"/>
+                </a:solidFill>
+                <a:latin typeface="Aptos" pitchFamily="34" charset="0"/>
+                <a:ea typeface="Aptos" pitchFamily="34" charset="-122"/>
+                <a:cs typeface="Aptos" pitchFamily="34" charset="-120"/>
+              </a:rPr>
+              <a:t>48/49</a:t>
+            </a:r>
+            <a:endParaRPr lang="en-US" sz="720" dirty="0"/>
+          </a:p>
+        </p:txBody>
+      </p:sp>
+    </p:spTree>
+  </p:cSld>
+  <p:clrMapOvr>
+    <a:masterClrMapping/>
+  </p:clrMapOvr>
+</p:sld>
+</file>
+
+<file path=ppt/slides/slide49.xml><?xml version="1.0" encoding="utf-8"?>
+<p:sld xmlns:a="http://schemas.openxmlformats.org/drawingml/2006/main" xmlns:r="http://schemas.openxmlformats.org/officeDocument/2006/relationships" xmlns:p="http://schemas.openxmlformats.org/presentationml/2006/main">
+  <p:cSld name="Slide 49">
+    <p:bg>
+      <p:bgPr>
+        <a:solidFill>
+          <a:srgbClr val="F7FAFC"/>
+        </a:solidFill>
+      </p:bgPr>
+    </p:bg>
+    <p:spTree>
+      <p:nvGrpSpPr>
+        <p:cNvPr id="1" name=""/>
+        <p:cNvGrpSpPr/>
+        <p:nvPr/>
+      </p:nvGrpSpPr>
+      <p:grpSpPr>
+        <a:xfrm>
+          <a:off x="0" y="0"/>
+          <a:ext cx="0" cy="0"/>
+          <a:chOff x="0" y="0"/>
+          <a:chExt cx="0" cy="0"/>
+        </a:xfrm>
+      </p:grpSpPr>
+      <p:sp>
+        <p:nvSpPr>
+          <p:cNvPr id="2" name="Shape 0"/>
+          <p:cNvSpPr/>
+          <p:nvPr/>
+        </p:nvSpPr>
+        <p:spPr>
+          <a:xfrm>
+            <a:off x="9784080" y="-502920"/>
+            <a:ext cx="2880360" cy="2880360"/>
+          </a:xfrm>
+          <a:prstGeom prst="arc">
+            <a:avLst/>
+          </a:prstGeom>
+          <a:solidFill>
+            <a:srgbClr val="FFFFFF">
+              <a:alpha val="0"/>
+            </a:srgbClr>
+          </a:solidFill>
+          <a:ln w="25400">
+            <a:solidFill>
+              <a:srgbClr val="E9F8F0"/>
+            </a:solidFill>
+            <a:prstDash val="solid"/>
+          </a:ln>
+        </p:spPr>
+      </p:sp>
+      <p:sp>
+        <p:nvSpPr>
+          <p:cNvPr id="3" name="Shape 1"/>
+          <p:cNvSpPr/>
+          <p:nvPr/>
+        </p:nvSpPr>
+        <p:spPr>
+          <a:xfrm>
+            <a:off x="-731520" y="5349240"/>
+            <a:ext cx="2057400" cy="2057400"/>
+          </a:xfrm>
+          <a:prstGeom prst="arc">
+            <a:avLst/>
+          </a:prstGeom>
+          <a:solidFill>
+            <a:srgbClr val="FFFFFF">
+              <a:alpha val="0"/>
+            </a:srgbClr>
+          </a:solidFill>
+          <a:ln w="25400">
+            <a:solidFill>
+              <a:srgbClr val="E9F8F0"/>
+            </a:solidFill>
+            <a:prstDash val="solid"/>
+          </a:ln>
+        </p:spPr>
+      </p:sp>
+      <p:sp>
+        <p:nvSpPr>
+          <p:cNvPr id="4" name="Shape 2"/>
+          <p:cNvSpPr/>
+          <p:nvPr/>
+        </p:nvSpPr>
+        <p:spPr>
+          <a:xfrm>
+            <a:off x="9281160" y="493776"/>
+            <a:ext cx="219456" cy="114300"/>
+          </a:xfrm>
+          <a:prstGeom prst="rect">
+            <a:avLst/>
+          </a:prstGeom>
+          <a:solidFill>
+            <a:srgbClr val="008F8F">
+              <a:alpha val="92000"/>
+            </a:srgbClr>
+          </a:solidFill>
+          <a:ln w="12700">
+            <a:solidFill>
+              <a:srgbClr val="008F8F">
+                <a:alpha val="0"/>
+              </a:srgbClr>
+            </a:solidFill>
+            <a:prstDash val="solid"/>
+          </a:ln>
+        </p:spPr>
+      </p:sp>
+      <p:sp>
+        <p:nvSpPr>
+          <p:cNvPr id="5" name="Shape 3"/>
+          <p:cNvSpPr/>
+          <p:nvPr/>
+        </p:nvSpPr>
+        <p:spPr>
+          <a:xfrm>
+            <a:off x="9628632" y="493776"/>
+            <a:ext cx="219456" cy="155448"/>
+          </a:xfrm>
+          <a:prstGeom prst="rect">
+            <a:avLst/>
+          </a:prstGeom>
+          <a:solidFill>
+            <a:srgbClr val="2F80ED">
+              <a:alpha val="92000"/>
+            </a:srgbClr>
+          </a:solidFill>
+          <a:ln w="12700">
+            <a:solidFill>
+              <a:srgbClr val="2F80ED">
+                <a:alpha val="0"/>
+              </a:srgbClr>
+            </a:solidFill>
+            <a:prstDash val="solid"/>
+          </a:ln>
+        </p:spPr>
+      </p:sp>
+      <p:sp>
+        <p:nvSpPr>
+          <p:cNvPr id="6" name="Shape 4"/>
+          <p:cNvSpPr/>
+          <p:nvPr/>
+        </p:nvSpPr>
+        <p:spPr>
+          <a:xfrm>
+            <a:off x="9976104" y="493776"/>
+            <a:ext cx="219456" cy="73152"/>
+          </a:xfrm>
+          <a:prstGeom prst="rect">
+            <a:avLst/>
+          </a:prstGeom>
+          <a:solidFill>
+            <a:srgbClr val="F45B69">
+              <a:alpha val="92000"/>
+            </a:srgbClr>
+          </a:solidFill>
+          <a:ln w="12700">
+            <a:solidFill>
+              <a:srgbClr val="F45B69">
+                <a:alpha val="0"/>
+              </a:srgbClr>
+            </a:solidFill>
+            <a:prstDash val="solid"/>
+          </a:ln>
+        </p:spPr>
+      </p:sp>
+      <p:sp>
+        <p:nvSpPr>
+          <p:cNvPr id="7" name="Shape 5"/>
+          <p:cNvSpPr/>
+          <p:nvPr/>
+        </p:nvSpPr>
+        <p:spPr>
+          <a:xfrm>
+            <a:off x="10323576" y="493776"/>
+            <a:ext cx="219456" cy="114300"/>
+          </a:xfrm>
+          <a:prstGeom prst="rect">
+            <a:avLst/>
+          </a:prstGeom>
+          <a:solidFill>
+            <a:srgbClr val="F2B84B">
+              <a:alpha val="92000"/>
+            </a:srgbClr>
+          </a:solidFill>
+          <a:ln w="12700">
+            <a:solidFill>
+              <a:srgbClr val="F2B84B">
+                <a:alpha val="0"/>
+              </a:srgbClr>
+            </a:solidFill>
+            <a:prstDash val="solid"/>
+          </a:ln>
+        </p:spPr>
+      </p:sp>
+      <p:sp>
+        <p:nvSpPr>
+          <p:cNvPr id="8" name="Shape 6"/>
+          <p:cNvSpPr/>
+          <p:nvPr/>
+        </p:nvSpPr>
+        <p:spPr>
+          <a:xfrm>
+            <a:off x="658368" y="438912"/>
+            <a:ext cx="109728" cy="256032"/>
+          </a:xfrm>
+          <a:prstGeom prst="rect">
+            <a:avLst/>
+          </a:prstGeom>
+          <a:solidFill>
+            <a:srgbClr val="008F8F"/>
+          </a:solidFill>
+          <a:ln w="12700">
+            <a:solidFill>
+              <a:srgbClr val="008F8F"/>
+            </a:solidFill>
+            <a:prstDash val="solid"/>
+          </a:ln>
+        </p:spPr>
+      </p:sp>
+      <p:sp>
+        <p:nvSpPr>
+          <p:cNvPr id="9" name="Text 7"/>
+          <p:cNvSpPr/>
+          <p:nvPr/>
+        </p:nvSpPr>
+        <p:spPr>
+          <a:xfrm>
+            <a:off x="841248" y="429768"/>
+            <a:ext cx="4937760" cy="228600"/>
+          </a:xfrm>
+          <a:prstGeom prst="rect">
+            <a:avLst/>
+          </a:prstGeom>
+          <a:noFill/>
+          <a:ln/>
+        </p:spPr>
+        <p:txBody>
+          <a:bodyPr wrap="square" lIns="0" tIns="0" rIns="0" bIns="0" rtlCol="0" anchor="ctr">
+            <a:normAutofit/>
+          </a:bodyPr>
+          <a:lstStyle/>
+          <a:p>
+            <a:pPr indent="0" marL="0">
+              <a:buNone/>
+            </a:pPr>
+            <a:r>
+              <a:rPr lang="en-US" sz="880" b="1" dirty="0">
+                <a:solidFill>
+                  <a:srgbClr val="008F8F"/>
+                </a:solidFill>
+                <a:latin typeface="Aptos" pitchFamily="34" charset="0"/>
+                <a:ea typeface="Aptos" pitchFamily="34" charset="-122"/>
+                <a:cs typeface="Aptos" pitchFamily="34" charset="-120"/>
+              </a:rPr>
               <a:t>THANK YOU</a:t>
             </a:r>
             <a:endParaRPr lang="en-US" sz="880" dirty="0"/>
@@ -35324,7 +36301,7 @@
                 <a:ea typeface="Aptos" pitchFamily="34" charset="-122"/>
                 <a:cs typeface="Aptos" pitchFamily="34" charset="-120"/>
               </a:rPr>
-              <a:t>48/48</a:t>
+              <a:t>49/49</a:t>
             </a:r>
             <a:endParaRPr lang="en-US" sz="720" dirty="0"/>
           </a:p>
@@ -37034,7 +38011,7 @@
                 <a:ea typeface="Aptos" pitchFamily="34" charset="-122"/>
                 <a:cs typeface="Aptos" pitchFamily="34" charset="-120"/>
               </a:rPr>
-              <a:t>5/48</a:t>
+              <a:t>5/49</a:t>
             </a:r>
             <a:endParaRPr lang="en-US" sz="720" dirty="0"/>
           </a:p>
@@ -38053,7 +39030,7 @@
                 <a:ea typeface="Aptos" pitchFamily="34" charset="-122"/>
                 <a:cs typeface="Aptos" pitchFamily="34" charset="-120"/>
               </a:rPr>
-              <a:t>7/48</a:t>
+              <a:t>7/49</a:t>
             </a:r>
             <a:endParaRPr lang="en-US" sz="720" dirty="0"/>
           </a:p>
@@ -38770,7 +39747,7 @@
                 <a:ea typeface="Aptos" pitchFamily="34" charset="-122"/>
                 <a:cs typeface="Aptos" pitchFamily="34" charset="-120"/>
               </a:rPr>
-              <a:t>8/48</a:t>
+              <a:t>8/49</a:t>
             </a:r>
             <a:endParaRPr lang="en-US" sz="720" dirty="0"/>
           </a:p>
@@ -39573,7 +40550,7 @@
                 <a:ea typeface="Aptos" pitchFamily="34" charset="-122"/>
                 <a:cs typeface="Aptos" pitchFamily="34" charset="-120"/>
               </a:rPr>
-              <a:t>9/48</a:t>
+              <a:t>9/49</a:t>
             </a:r>
             <a:endParaRPr lang="en-US" sz="720" dirty="0"/>
           </a:p>

</xml_diff>

<commit_message>
Add GoHouse logo to course 1 deck
</commit_message>
<xml_diff>
--- a/slides/course-01-ai-for-real-estate-sales-approved-instructor-deck.pptx
+++ b/slides/course-01-ai-for-real-estate-sales-approved-instructor-deck.pptx
@@ -4069,7 +4069,7 @@
           <a:p>
             <a:r>
               <a:rPr lang="en-US" dirty="0"/>
-              <a:t>This course provides general education, not legal, financial, brokerage, MLS, or Fair Housing advice. Point attendees to brokerage AI policies, Fair Housing and advertising guidance, MLS rules, and appropriate professionals when needed. Close on action, not a generic thank-you slide.</a:t>
+              <a:t>This course provides general education, not legal, financial, brokerage, MLS, or Fair Housing advice. Point attendees to brokerage AI policies, Fair Housing and advertising guidance, MLS rules, and appropriate professionals when needed. Close on action and presenter contact, not a generic thank-you slide.</a:t>
             </a:r>
             <a:endParaRPr lang="en-US" dirty="0"/>
           </a:p>
@@ -5351,7 +5351,7 @@
         <p:spPr>
           <a:xfrm>
             <a:off x="2487168" y="3401568"/>
-            <a:ext cx="4023360" cy="146304"/>
+            <a:ext cx="2423160" cy="146304"/>
           </a:xfrm>
           <a:prstGeom prst="rect">
             <a:avLst/>
@@ -5372,46 +5372,15 @@
                   <a:srgbClr val="D7EDEE"/>
                 </a:solidFill>
               </a:rPr>
-              <a:t>Presented by Ian Burton Price | GoHouse.ai</a:t>
+              <a:t>Presented by Ian Burton Price</a:t>
             </a:r>
             <a:endParaRPr lang="en-US" sz="1030" dirty="0"/>
           </a:p>
         </p:txBody>
-      </p:sp>
-      <p:sp>
-        <p:nvSpPr>
-          <p:cNvPr id="16" name="Shape 14"/>
-          <p:cNvSpPr/>
-          <p:nvPr/>
-        </p:nvSpPr>
-        <p:spPr>
-          <a:xfrm>
-            <a:off x="603504" y="4206240"/>
-            <a:ext cx="4281587" cy="819302"/>
-          </a:xfrm>
-          <a:prstGeom prst="roundRect">
-            <a:avLst>
-              <a:gd name="adj" fmla="val 4464"/>
-            </a:avLst>
-          </a:prstGeom>
-          <a:solidFill>
-            <a:srgbClr val="FFFFFF">
-              <a:alpha val="97000"/>
-            </a:srgbClr>
-          </a:solidFill>
-          <a:ln w="7620">
-            <a:solidFill>
-              <a:srgbClr val="D7E4EA">
-                <a:alpha val="75000"/>
-              </a:srgbClr>
-            </a:solidFill>
-            <a:prstDash val="solid"/>
-          </a:ln>
-        </p:spPr>
       </p:sp>
       <p:pic>
         <p:nvPicPr>
-          <p:cNvPr id="17" name="Image 0" descr="C:\Users\TR4_1950X\Documents\New project\assets\brand\miami-realtors-rworld-combined-logo.png">    </p:cNvPr>
+          <p:cNvPr id="16" name="Image 0" descr="C:\Users\TR4_1950X\Documents\New project\assets\brand\gohouse-logo-w-text-large-transparent.png">    </p:cNvPr>
           <p:cNvPicPr>
             <a:picLocks noChangeAspect="1"/>
           </p:cNvPicPr>
@@ -5425,6 +5394,61 @@
         </p:blipFill>
         <p:spPr>
           <a:xfrm>
+            <a:off x="4736592" y="3264408"/>
+            <a:ext cx="960120" cy="192024"/>
+          </a:xfrm>
+          <a:prstGeom prst="rect">
+            <a:avLst/>
+          </a:prstGeom>
+        </p:spPr>
+      </p:pic>
+      <p:sp>
+        <p:nvSpPr>
+          <p:cNvPr id="17" name="Shape 14"/>
+          <p:cNvSpPr/>
+          <p:nvPr/>
+        </p:nvSpPr>
+        <p:spPr>
+          <a:xfrm>
+            <a:off x="603504" y="4206240"/>
+            <a:ext cx="4281587" cy="819302"/>
+          </a:xfrm>
+          <a:prstGeom prst="roundRect">
+            <a:avLst>
+              <a:gd name="adj" fmla="val 4464"/>
+            </a:avLst>
+          </a:prstGeom>
+          <a:solidFill>
+            <a:srgbClr val="FFFFFF">
+              <a:alpha val="97000"/>
+            </a:srgbClr>
+          </a:solidFill>
+          <a:ln w="7620">
+            <a:solidFill>
+              <a:srgbClr val="D7E4EA">
+                <a:alpha val="75000"/>
+              </a:srgbClr>
+            </a:solidFill>
+            <a:prstDash val="solid"/>
+          </a:ln>
+        </p:spPr>
+      </p:sp>
+      <p:pic>
+        <p:nvPicPr>
+          <p:cNvPr id="18" name="Image 1" descr="C:\Users\TR4_1950X\Documents\New project\assets\brand\miami-realtors-rworld-combined-logo.png">    </p:cNvPr>
+          <p:cNvPicPr>
+            <a:picLocks noChangeAspect="1"/>
+          </p:cNvPicPr>
+          <p:nvPr/>
+        </p:nvPicPr>
+        <p:blipFill>
+          <a:blip r:embed="rId2"/>
+          <a:stretch>
+            <a:fillRect/>
+          </a:stretch>
+        </p:blipFill>
+        <p:spPr>
+          <a:xfrm>
             <a:off x="749808" y="4315968"/>
             <a:ext cx="3988979" cy="599846"/>
           </a:xfrm>
@@ -5435,7 +5459,7 @@
       </p:pic>
       <p:sp>
         <p:nvSpPr>
-          <p:cNvPr id="18" name="Text 15"/>
+          <p:cNvPr id="19" name="Text 15"/>
           <p:cNvSpPr/>
           <p:nvPr/>
         </p:nvSpPr>
@@ -5471,7 +5495,7 @@
       </p:sp>
       <p:sp>
         <p:nvSpPr>
-          <p:cNvPr id="19" name="Text 16"/>
+          <p:cNvPr id="20" name="Text 16"/>
           <p:cNvSpPr/>
           <p:nvPr/>
         </p:nvSpPr>
@@ -21649,9 +21673,33 @@
           </a:p>
         </p:txBody>
       </p:sp>
-      <p:sp>
-        <p:nvSpPr>
-          <p:cNvPr id="15" name="Shape 13"/>
+      <p:pic>
+        <p:nvPicPr>
+          <p:cNvPr id="15" name="Image 0" descr="C:\Users\TR4_1950X\Documents\New project\assets\brand\gohouse-logo-w-text-large-transparent.png">    </p:cNvPr>
+          <p:cNvPicPr>
+            <a:picLocks noChangeAspect="1"/>
+          </p:cNvPicPr>
+          <p:nvPr/>
+        </p:nvPicPr>
+        <p:blipFill>
+          <a:blip r:embed="rId1"/>
+          <a:stretch>
+            <a:fillRect/>
+          </a:stretch>
+        </p:blipFill>
+        <p:spPr>
+          <a:xfrm>
+            <a:off x="3794760" y="3127248"/>
+            <a:ext cx="1078992" cy="215798"/>
+          </a:xfrm>
+          <a:prstGeom prst="rect">
+            <a:avLst/>
+          </a:prstGeom>
+        </p:spPr>
+      </p:pic>
+      <p:sp>
+        <p:nvSpPr>
+          <p:cNvPr id="16" name="Shape 13"/>
           <p:cNvSpPr/>
           <p:nvPr/>
         </p:nvSpPr>
@@ -21674,7 +21722,7 @@
       </p:sp>
       <p:sp>
         <p:nvSpPr>
-          <p:cNvPr id="16" name="Text 14"/>
+          <p:cNvPr id="17" name="Text 14"/>
           <p:cNvSpPr/>
           <p:nvPr/>
         </p:nvSpPr>
@@ -21712,7 +21760,7 @@
       </p:sp>
       <p:sp>
         <p:nvSpPr>
-          <p:cNvPr id="17" name="Shape 15"/>
+          <p:cNvPr id="18" name="Shape 15"/>
           <p:cNvSpPr/>
           <p:nvPr/>
         </p:nvSpPr>
@@ -21737,7 +21785,7 @@
       </p:sp>
       <p:sp>
         <p:nvSpPr>
-          <p:cNvPr id="18" name="Shape 16"/>
+          <p:cNvPr id="19" name="Shape 16"/>
           <p:cNvSpPr/>
           <p:nvPr/>
         </p:nvSpPr>
@@ -21764,7 +21812,7 @@
       </p:sp>
       <p:sp>
         <p:nvSpPr>
-          <p:cNvPr id="19" name="Text 17"/>
+          <p:cNvPr id="20" name="Text 17"/>
           <p:cNvSpPr/>
           <p:nvPr/>
         </p:nvSpPr>
@@ -21800,7 +21848,7 @@
       </p:sp>
       <p:sp>
         <p:nvSpPr>
-          <p:cNvPr id="20" name="Text 18"/>
+          <p:cNvPr id="21" name="Text 18"/>
           <p:cNvSpPr/>
           <p:nvPr/>
         </p:nvSpPr>
@@ -21838,7 +21886,7 @@
       </p:sp>
       <p:sp>
         <p:nvSpPr>
-          <p:cNvPr id="21" name="Shape 19"/>
+          <p:cNvPr id="22" name="Shape 19"/>
           <p:cNvSpPr/>
           <p:nvPr/>
         </p:nvSpPr>
@@ -21861,7 +21909,7 @@
       </p:sp>
       <p:sp>
         <p:nvSpPr>
-          <p:cNvPr id="22" name="Text 20"/>
+          <p:cNvPr id="23" name="Text 20"/>
           <p:cNvSpPr/>
           <p:nvPr/>
         </p:nvSpPr>
@@ -21899,7 +21947,7 @@
       </p:sp>
       <p:sp>
         <p:nvSpPr>
-          <p:cNvPr id="23" name="Shape 21"/>
+          <p:cNvPr id="24" name="Shape 21"/>
           <p:cNvSpPr/>
           <p:nvPr/>
         </p:nvSpPr>
@@ -21922,7 +21970,7 @@
       </p:sp>
       <p:sp>
         <p:nvSpPr>
-          <p:cNvPr id="24" name="Text 22"/>
+          <p:cNvPr id="25" name="Text 22"/>
           <p:cNvSpPr/>
           <p:nvPr/>
         </p:nvSpPr>
@@ -21961,7 +22009,7 @@
       </p:sp>
       <p:sp>
         <p:nvSpPr>
-          <p:cNvPr id="25" name="Text 23"/>
+          <p:cNvPr id="26" name="Text 23"/>
           <p:cNvSpPr/>
           <p:nvPr/>
         </p:nvSpPr>
@@ -34623,7 +34671,7 @@
                 <a:ea typeface="Aptos Display" pitchFamily="34" charset="-122"/>
                 <a:cs typeface="Aptos Display" pitchFamily="34" charset="-120"/>
               </a:rPr>
-              <a:t>Your one-week implementation plan</a:t>
+              <a:t>Your one-week implementation plan + contact</a:t>
             </a:r>
             <a:endParaRPr lang="en-US" sz="3000" dirty="0"/>
           </a:p>
@@ -34637,7 +34685,7 @@
         </p:nvSpPr>
         <p:spPr>
           <a:xfrm>
-            <a:off x="731520" y="2331720"/>
+            <a:off x="749808" y="2148840"/>
             <a:ext cx="402336" cy="402336"/>
           </a:xfrm>
           <a:prstGeom prst="ellipse">
@@ -34662,7 +34710,7 @@
         </p:nvSpPr>
         <p:spPr>
           <a:xfrm>
-            <a:off x="731520" y="2423160"/>
+            <a:off x="749808" y="2240280"/>
             <a:ext cx="402336" cy="146304"/>
           </a:xfrm>
           <a:prstGeom prst="rect">
@@ -34698,14 +34746,14 @@
         </p:nvSpPr>
         <p:spPr>
           <a:xfrm>
-            <a:off x="1143000" y="2532888"/>
-            <a:ext cx="1115568" cy="0"/>
+            <a:off x="1161288" y="2350008"/>
+            <a:ext cx="1078992" cy="0"/>
           </a:xfrm>
           <a:prstGeom prst="line">
             <a:avLst/>
           </a:prstGeom>
           <a:noFill/>
-          <a:ln w="17780">
+          <a:ln w="16510">
             <a:solidFill>
               <a:srgbClr val="D8E6E8"/>
             </a:solidFill>
@@ -34722,8 +34770,8 @@
         </p:nvSpPr>
         <p:spPr>
           <a:xfrm>
-            <a:off x="594360" y="2971800"/>
-            <a:ext cx="1417320" cy="640080"/>
+            <a:off x="640080" y="2761488"/>
+            <a:ext cx="1417320" cy="530352"/>
           </a:xfrm>
           <a:prstGeom prst="rect">
             <a:avLst/>
@@ -34741,14 +34789,14 @@
               <a:buNone/>
             </a:pPr>
             <a:r>
-              <a:rPr lang="en-US" sz="1180" b="1" dirty="0">
+              <a:rPr lang="en-US" sz="1100" b="1" dirty="0">
                 <a:solidFill>
                   <a:srgbClr val="102033"/>
                 </a:solidFill>
               </a:rPr>
               <a:t>Choose one workflow</a:t>
             </a:r>
-            <a:endParaRPr lang="en-US" sz="1180" dirty="0"/>
+            <a:endParaRPr lang="en-US" sz="1100" dirty="0"/>
           </a:p>
         </p:txBody>
       </p:sp>
@@ -34760,7 +34808,7 @@
         </p:nvSpPr>
         <p:spPr>
           <a:xfrm>
-            <a:off x="2788920" y="2496312"/>
+            <a:off x="2743200" y="2148840"/>
             <a:ext cx="402336" cy="402336"/>
           </a:xfrm>
           <a:prstGeom prst="ellipse">
@@ -34785,7 +34833,7 @@
         </p:nvSpPr>
         <p:spPr>
           <a:xfrm>
-            <a:off x="2788920" y="2587752"/>
+            <a:off x="2743200" y="2240280"/>
             <a:ext cx="402336" cy="146304"/>
           </a:xfrm>
           <a:prstGeom prst="rect">
@@ -34821,14 +34869,14 @@
         </p:nvSpPr>
         <p:spPr>
           <a:xfrm>
-            <a:off x="3200400" y="2532888"/>
-            <a:ext cx="1115568" cy="0"/>
+            <a:off x="3154680" y="2350008"/>
+            <a:ext cx="1078992" cy="0"/>
           </a:xfrm>
           <a:prstGeom prst="line">
             <a:avLst/>
           </a:prstGeom>
           <a:noFill/>
-          <a:ln w="17780">
+          <a:ln w="16510">
             <a:solidFill>
               <a:srgbClr val="D8E6E8"/>
             </a:solidFill>
@@ -34845,8 +34893,8 @@
         </p:nvSpPr>
         <p:spPr>
           <a:xfrm>
-            <a:off x="2651760" y="2971800"/>
-            <a:ext cx="1417320" cy="640080"/>
+            <a:off x="2633472" y="2761488"/>
+            <a:ext cx="1417320" cy="530352"/>
           </a:xfrm>
           <a:prstGeom prst="rect">
             <a:avLst/>
@@ -34864,14 +34912,14 @@
               <a:buNone/>
             </a:pPr>
             <a:r>
-              <a:rPr lang="en-US" sz="1180" b="1" dirty="0">
+              <a:rPr lang="en-US" sz="1100" b="1" dirty="0">
                 <a:solidFill>
                   <a:srgbClr val="102033"/>
                 </a:solidFill>
               </a:rPr>
               <a:t>Write one reusable prompt</a:t>
             </a:r>
-            <a:endParaRPr lang="en-US" sz="1180" dirty="0"/>
+            <a:endParaRPr lang="en-US" sz="1100" dirty="0"/>
           </a:p>
         </p:txBody>
       </p:sp>
@@ -34883,7 +34931,7 @@
         </p:nvSpPr>
         <p:spPr>
           <a:xfrm>
-            <a:off x="4846320" y="2331720"/>
+            <a:off x="4736592" y="2148840"/>
             <a:ext cx="402336" cy="402336"/>
           </a:xfrm>
           <a:prstGeom prst="ellipse">
@@ -34908,7 +34956,7 @@
         </p:nvSpPr>
         <p:spPr>
           <a:xfrm>
-            <a:off x="4846320" y="2423160"/>
+            <a:off x="4736592" y="2240280"/>
             <a:ext cx="402336" cy="146304"/>
           </a:xfrm>
           <a:prstGeom prst="rect">
@@ -34944,14 +34992,14 @@
         </p:nvSpPr>
         <p:spPr>
           <a:xfrm>
-            <a:off x="5257800" y="2532888"/>
-            <a:ext cx="1115568" cy="0"/>
+            <a:off x="5148072" y="2350008"/>
+            <a:ext cx="1078992" cy="0"/>
           </a:xfrm>
           <a:prstGeom prst="line">
             <a:avLst/>
           </a:prstGeom>
           <a:noFill/>
-          <a:ln w="17780">
+          <a:ln w="16510">
             <a:solidFill>
               <a:srgbClr val="D8E6E8"/>
             </a:solidFill>
@@ -34968,8 +35016,8 @@
         </p:nvSpPr>
         <p:spPr>
           <a:xfrm>
-            <a:off x="4709160" y="2971800"/>
-            <a:ext cx="1417320" cy="640080"/>
+            <a:off x="4626864" y="2761488"/>
+            <a:ext cx="1417320" cy="530352"/>
           </a:xfrm>
           <a:prstGeom prst="rect">
             <a:avLst/>
@@ -34987,14 +35035,14 @@
               <a:buNone/>
             </a:pPr>
             <a:r>
-              <a:rPr lang="en-US" sz="1180" b="1" dirty="0">
+              <a:rPr lang="en-US" sz="1100" b="1" dirty="0">
                 <a:solidFill>
                   <a:srgbClr val="102033"/>
                 </a:solidFill>
               </a:rPr>
               <a:t>Use it three times</a:t>
             </a:r>
-            <a:endParaRPr lang="en-US" sz="1180" dirty="0"/>
+            <a:endParaRPr lang="en-US" sz="1100" dirty="0"/>
           </a:p>
         </p:txBody>
       </p:sp>
@@ -35006,7 +35054,7 @@
         </p:nvSpPr>
         <p:spPr>
           <a:xfrm>
-            <a:off x="6903720" y="2496312"/>
+            <a:off x="6729984" y="2148840"/>
             <a:ext cx="402336" cy="402336"/>
           </a:xfrm>
           <a:prstGeom prst="ellipse">
@@ -35031,7 +35079,7 @@
         </p:nvSpPr>
         <p:spPr>
           <a:xfrm>
-            <a:off x="6903720" y="2587752"/>
+            <a:off x="6729984" y="2240280"/>
             <a:ext cx="402336" cy="146304"/>
           </a:xfrm>
           <a:prstGeom prst="rect">
@@ -35067,14 +35115,14 @@
         </p:nvSpPr>
         <p:spPr>
           <a:xfrm>
-            <a:off x="7315200" y="2532888"/>
-            <a:ext cx="1115568" cy="0"/>
+            <a:off x="7141464" y="2350008"/>
+            <a:ext cx="1078992" cy="0"/>
           </a:xfrm>
           <a:prstGeom prst="line">
             <a:avLst/>
           </a:prstGeom>
           <a:noFill/>
-          <a:ln w="17780">
+          <a:ln w="16510">
             <a:solidFill>
               <a:srgbClr val="D8E6E8"/>
             </a:solidFill>
@@ -35091,8 +35139,8 @@
         </p:nvSpPr>
         <p:spPr>
           <a:xfrm>
-            <a:off x="6766560" y="2971800"/>
-            <a:ext cx="1417320" cy="640080"/>
+            <a:off x="6620256" y="2761488"/>
+            <a:ext cx="1417320" cy="530352"/>
           </a:xfrm>
           <a:prstGeom prst="rect">
             <a:avLst/>
@@ -35110,14 +35158,14 @@
               <a:buNone/>
             </a:pPr>
             <a:r>
-              <a:rPr lang="en-US" sz="1180" b="1" dirty="0">
+              <a:rPr lang="en-US" sz="1100" b="1" dirty="0">
                 <a:solidFill>
                   <a:srgbClr val="102033"/>
                 </a:solidFill>
               </a:rPr>
               <a:t>Save what worked</a:t>
             </a:r>
-            <a:endParaRPr lang="en-US" sz="1180" dirty="0"/>
+            <a:endParaRPr lang="en-US" sz="1100" dirty="0"/>
           </a:p>
         </p:txBody>
       </p:sp>
@@ -35129,7 +35177,7 @@
         </p:nvSpPr>
         <p:spPr>
           <a:xfrm>
-            <a:off x="8961120" y="2331720"/>
+            <a:off x="8723376" y="2148840"/>
             <a:ext cx="402336" cy="402336"/>
           </a:xfrm>
           <a:prstGeom prst="ellipse">
@@ -35154,7 +35202,7 @@
         </p:nvSpPr>
         <p:spPr>
           <a:xfrm>
-            <a:off x="8961120" y="2423160"/>
+            <a:off x="8723376" y="2240280"/>
             <a:ext cx="402336" cy="146304"/>
           </a:xfrm>
           <a:prstGeom prst="rect">
@@ -35190,8 +35238,8 @@
         </p:nvSpPr>
         <p:spPr>
           <a:xfrm>
-            <a:off x="8823960" y="2971800"/>
-            <a:ext cx="1417320" cy="640080"/>
+            <a:off x="8613648" y="2761488"/>
+            <a:ext cx="1417320" cy="530352"/>
           </a:xfrm>
           <a:prstGeom prst="rect">
             <a:avLst/>
@@ -35209,12 +35257,75 @@
               <a:buNone/>
             </a:pPr>
             <a:r>
+              <a:rPr lang="en-US" sz="1100" b="1" dirty="0">
+                <a:solidFill>
+                  <a:srgbClr val="102033"/>
+                </a:solidFill>
+              </a:rPr>
+              <a:t>Review before using with clients</a:t>
+            </a:r>
+            <a:endParaRPr lang="en-US" sz="1100" dirty="0"/>
+          </a:p>
+        </p:txBody>
+      </p:sp>
+      <p:sp>
+        <p:nvSpPr>
+          <p:cNvPr id="30" name="Shape 28"/>
+          <p:cNvSpPr/>
+          <p:nvPr/>
+        </p:nvSpPr>
+        <p:spPr>
+          <a:xfrm>
+            <a:off x="841248" y="3977640"/>
+            <a:ext cx="9829800" cy="1024128"/>
+          </a:xfrm>
+          <a:prstGeom prst="roundRect">
+            <a:avLst>
+              <a:gd name="adj" fmla="val 5357"/>
+            </a:avLst>
+          </a:prstGeom>
+          <a:solidFill>
+            <a:srgbClr val="FFFFFF"/>
+          </a:solidFill>
+          <a:ln w="10160">
+            <a:solidFill>
+              <a:srgbClr val="C9DFE5"/>
+            </a:solidFill>
+            <a:prstDash val="solid"/>
+          </a:ln>
+        </p:spPr>
+      </p:sp>
+      <p:sp>
+        <p:nvSpPr>
+          <p:cNvPr id="31" name="Text 29"/>
+          <p:cNvSpPr/>
+          <p:nvPr/>
+        </p:nvSpPr>
+        <p:spPr>
+          <a:xfrm>
+            <a:off x="1115568" y="4187952"/>
+            <a:ext cx="3246120" cy="182880"/>
+          </a:xfrm>
+          <a:prstGeom prst="rect">
+            <a:avLst/>
+          </a:prstGeom>
+          <a:noFill/>
+          <a:ln/>
+        </p:spPr>
+        <p:txBody>
+          <a:bodyPr wrap="square" lIns="0" tIns="0" rIns="0" bIns="0" rtlCol="0" anchor="ctr"/>
+          <a:lstStyle/>
+          <a:p>
+            <a:pPr indent="0" marL="0">
+              <a:buNone/>
+            </a:pPr>
+            <a:r>
               <a:rPr lang="en-US" sz="1180" b="1" dirty="0">
                 <a:solidFill>
-                  <a:srgbClr val="102033"/>
-                </a:solidFill>
-              </a:rPr>
-              <a:t>Review before using with clients</a:t>
+                  <a:srgbClr val="16324F"/>
+                </a:solidFill>
+              </a:rPr>
+              <a:t>Presented by Ian Burton Price</a:t>
             </a:r>
             <a:endParaRPr lang="en-US" sz="1180" dirty="0"/>
           </a:p>
@@ -35222,7 +35333,83 @@
       </p:sp>
       <p:sp>
         <p:nvSpPr>
-          <p:cNvPr id="30" name="Shape 28"/>
+          <p:cNvPr id="32" name="Text 30"/>
+          <p:cNvSpPr/>
+          <p:nvPr/>
+        </p:nvSpPr>
+        <p:spPr>
+          <a:xfrm>
+            <a:off x="1115568" y="4462272"/>
+            <a:ext cx="4206240" cy="329184"/>
+          </a:xfrm>
+          <a:prstGeom prst="rect">
+            <a:avLst/>
+          </a:prstGeom>
+          <a:noFill/>
+          <a:ln/>
+        </p:spPr>
+        <p:txBody>
+          <a:bodyPr wrap="square" lIns="0" tIns="0" rIns="0" bIns="0" rtlCol="0" anchor="ctr">
+            <a:normAutofit/>
+          </a:bodyPr>
+          <a:lstStyle/>
+          <a:p>
+            <a:pPr indent="0" marL="0">
+              <a:buNone/>
+            </a:pPr>
+            <a:r>
+              <a:rPr lang="en-US" sz="980" dirty="0">
+                <a:solidFill>
+                  <a:srgbClr val="52606D"/>
+                </a:solidFill>
+              </a:rPr>
+              <a:t>REALTOR® | Dalton Wade Real Estate Group</a:t>
+            </a:r>
+            <a:endParaRPr lang="en-US" sz="980" dirty="0"/>
+          </a:p>
+          <a:p>
+            <a:pPr indent="0" marL="0">
+              <a:buNone/>
+            </a:pPr>
+            <a:r>
+              <a:rPr lang="en-US" sz="980" dirty="0">
+                <a:solidFill>
+                  <a:srgbClr val="52606D"/>
+                </a:solidFill>
+              </a:rPr>
+              <a:t>V.P. of Growth and Partnerships | GoHouse.ai</a:t>
+            </a:r>
+            <a:endParaRPr lang="en-US" sz="980" dirty="0"/>
+          </a:p>
+        </p:txBody>
+      </p:sp>
+      <p:pic>
+        <p:nvPicPr>
+          <p:cNvPr id="33" name="Image 0" descr="C:\Users\TR4_1950X\Documents\New project\assets\brand\gohouse-logo-w-text-large-transparent.png">    </p:cNvPr>
+          <p:cNvPicPr>
+            <a:picLocks noChangeAspect="1"/>
+          </p:cNvPicPr>
+          <p:nvPr/>
+        </p:nvPicPr>
+        <p:blipFill>
+          <a:blip r:embed="rId1"/>
+          <a:stretch>
+            <a:fillRect/>
+          </a:stretch>
+        </p:blipFill>
+        <p:spPr>
+          <a:xfrm>
+            <a:off x="7909560" y="4297680"/>
+            <a:ext cx="1965960" cy="393192"/>
+          </a:xfrm>
+          <a:prstGeom prst="rect">
+            <a:avLst/>
+          </a:prstGeom>
+        </p:spPr>
+      </p:pic>
+      <p:sp>
+        <p:nvSpPr>
+          <p:cNvPr id="34" name="Shape 31"/>
           <p:cNvSpPr/>
           <p:nvPr/>
         </p:nvSpPr>
@@ -35245,7 +35432,7 @@
       </p:sp>
       <p:sp>
         <p:nvSpPr>
-          <p:cNvPr id="31" name="Text 29"/>
+          <p:cNvPr id="35" name="Text 32"/>
           <p:cNvSpPr/>
           <p:nvPr/>
         </p:nvSpPr>
@@ -35284,7 +35471,7 @@
       </p:sp>
       <p:sp>
         <p:nvSpPr>
-          <p:cNvPr id="32" name="Text 30"/>
+          <p:cNvPr id="36" name="Text 33"/>
           <p:cNvSpPr/>
           <p:nvPr/>
         </p:nvSpPr>

</xml_diff>

<commit_message>
Update Course 1 real estate agent terminology
</commit_message>
<xml_diff>
--- a/slides/course-01-ai-for-real-estate-sales-approved-instructor-deck.pptx
+++ b/slides/course-01-ai-for-real-estate-sales-approved-instructor-deck.pptx
@@ -5159,12 +5159,12 @@
               <a:buNone/>
             </a:pPr>
             <a:r>
-              <a:rPr lang="en-US" sz="1100" b="1" dirty="0">
+              <a:rPr lang="en-US" sz="1100" b="1">
                 <a:solidFill>
                   <a:srgbClr val="F2B84B"/>
                 </a:solidFill>
               </a:rPr>
-              <a:t>APPROVED REALTOR® EDUCATION COURSE</a:t>
+              <a:t>APPROVED REAL ESTATE EDUCATION COURSE</a:t>
             </a:r>
             <a:endParaRPr lang="en-US" sz="1100" dirty="0"/>
           </a:p>
@@ -6515,7 +6515,7 @@
                 <a:ea typeface="Aptos" pitchFamily="34" charset="-122"/>
                 <a:cs typeface="Aptos" pitchFamily="34" charset="-120"/>
               </a:rPr>
-              <a:t>Approved REALTOR® education course | MIAMI REALTORS® + RWorld members</a:t>
+              <a:t>Approved real estate education course | MIAMI REALTORS® + RWorld members</a:t>
             </a:r>
             <a:endParaRPr lang="en-US" sz="720"/>
           </a:p>
@@ -6554,7 +6554,7 @@
                 <a:ea typeface="Aptos" pitchFamily="34" charset="-122"/>
                 <a:cs typeface="Aptos" pitchFamily="34" charset="-120"/>
               </a:rPr>
-              <a:t>9/46</a:t>
+              <a:t>10/47</a:t>
             </a:r>
             <a:endParaRPr lang="en-US" sz="720"/>
           </a:p>
@@ -7696,7 +7696,7 @@
                 <a:ea typeface="Aptos" pitchFamily="34" charset="-122"/>
                 <a:cs typeface="Aptos" pitchFamily="34" charset="-120"/>
               </a:rPr>
-              <a:t>Approved REALTOR® education course | MIAMI REALTORS® + RWorld members</a:t>
+              <a:t>Approved real estate education course | MIAMI REALTORS® + RWorld members</a:t>
             </a:r>
             <a:endParaRPr lang="en-US" sz="720"/>
           </a:p>
@@ -7741,7 +7741,7 @@
                 <a:ea typeface="Aptos" pitchFamily="34" charset="-122"/>
                 <a:cs typeface="Aptos" pitchFamily="34" charset="-120"/>
               </a:rPr>
-              <a:t>10/46</a:t>
+              <a:t>11/47</a:t>
             </a:r>
             <a:endParaRPr lang="en-US" sz="720"/>
           </a:p>
@@ -8484,7 +8484,7 @@
                 <a:ea typeface="Aptos" pitchFamily="34" charset="-122"/>
                 <a:cs typeface="Aptos" pitchFamily="34" charset="-120"/>
               </a:rPr>
-              <a:t>Approved REALTOR® education course | MIAMI REALTORS® + RWorld members</a:t>
+              <a:t>Approved real estate education course | MIAMI REALTORS® + RWorld members</a:t>
             </a:r>
             <a:endParaRPr lang="en-US" sz="720"/>
           </a:p>
@@ -8523,7 +8523,7 @@
                 <a:ea typeface="Aptos" pitchFamily="34" charset="-122"/>
                 <a:cs typeface="Aptos" pitchFamily="34" charset="-120"/>
               </a:rPr>
-              <a:t>11/46</a:t>
+              <a:t>12/47</a:t>
             </a:r>
             <a:endParaRPr lang="en-US" sz="720"/>
           </a:p>
@@ -9655,7 +9655,7 @@
                 <a:ea typeface="Aptos" pitchFamily="34" charset="-122"/>
                 <a:cs typeface="Aptos" pitchFamily="34" charset="-120"/>
               </a:rPr>
-              <a:t>Approved REALTOR® education course | MIAMI REALTORS® + RWorld members</a:t>
+              <a:t>Approved real estate education course | MIAMI REALTORS® + RWorld members</a:t>
             </a:r>
             <a:endParaRPr lang="en-US" sz="720"/>
           </a:p>
@@ -9694,7 +9694,7 @@
                 <a:ea typeface="Aptos" pitchFamily="34" charset="-122"/>
                 <a:cs typeface="Aptos" pitchFamily="34" charset="-120"/>
               </a:rPr>
-              <a:t>12/46</a:t>
+              <a:t>13/47</a:t>
             </a:r>
             <a:endParaRPr lang="en-US" sz="720"/>
           </a:p>
@@ -10533,7 +10533,7 @@
                 <a:ea typeface="Aptos" pitchFamily="34" charset="-122"/>
                 <a:cs typeface="Aptos" pitchFamily="34" charset="-120"/>
               </a:rPr>
-              <a:t>Approved REALTOR® education course | MIAMI REALTORS® + RWorld members</a:t>
+              <a:t>Approved real estate education course | MIAMI REALTORS® + RWorld members</a:t>
             </a:r>
             <a:endParaRPr lang="en-US" sz="720"/>
           </a:p>
@@ -10572,7 +10572,7 @@
                 <a:ea typeface="Aptos" pitchFamily="34" charset="-122"/>
                 <a:cs typeface="Aptos" pitchFamily="34" charset="-120"/>
               </a:rPr>
-              <a:t>13/46</a:t>
+              <a:t>14/47</a:t>
             </a:r>
             <a:endParaRPr lang="en-US" sz="720"/>
           </a:p>
@@ -11249,7 +11249,7 @@
                 <a:ea typeface="Aptos" pitchFamily="34" charset="-122"/>
                 <a:cs typeface="Aptos" pitchFamily="34" charset="-120"/>
               </a:rPr>
-              <a:t>Approved REALTOR® education course | MIAMI REALTORS® + RWorld members</a:t>
+              <a:t>Approved real estate education course | MIAMI REALTORS® + RWorld members</a:t>
             </a:r>
             <a:endParaRPr lang="en-US" sz="720"/>
           </a:p>
@@ -11288,7 +11288,7 @@
                 <a:ea typeface="Aptos" pitchFamily="34" charset="-122"/>
                 <a:cs typeface="Aptos" pitchFamily="34" charset="-120"/>
               </a:rPr>
-              <a:t>14/46</a:t>
+              <a:t>15/47</a:t>
             </a:r>
             <a:endParaRPr lang="en-US" sz="720"/>
           </a:p>
@@ -12649,7 +12649,7 @@
                 <a:ea typeface="Aptos" pitchFamily="34" charset="-122"/>
                 <a:cs typeface="Aptos" pitchFamily="34" charset="-120"/>
               </a:rPr>
-              <a:t>Approved REALTOR® education course | MIAMI REALTORS® + RWorld members</a:t>
+              <a:t>Approved real estate education course | MIAMI REALTORS® + RWorld members</a:t>
             </a:r>
             <a:endParaRPr lang="en-US" sz="720"/>
           </a:p>
@@ -12688,7 +12688,7 @@
                 <a:ea typeface="Aptos" pitchFamily="34" charset="-122"/>
                 <a:cs typeface="Aptos" pitchFamily="34" charset="-120"/>
               </a:rPr>
-              <a:t>16/46</a:t>
+              <a:t>17/47</a:t>
             </a:r>
             <a:endParaRPr lang="en-US" sz="720"/>
           </a:p>
@@ -13332,7 +13332,7 @@
                 <a:ea typeface="Aptos" pitchFamily="34" charset="-122"/>
                 <a:cs typeface="Aptos" pitchFamily="34" charset="-120"/>
               </a:rPr>
-              <a:t>Approved REALTOR® education course | MIAMI REALTORS® + RWorld members</a:t>
+              <a:t>Approved real estate education course | MIAMI REALTORS® + RWorld members</a:t>
             </a:r>
             <a:endParaRPr lang="en-US" sz="720"/>
           </a:p>
@@ -13371,7 +13371,7 @@
                 <a:ea typeface="Aptos" pitchFamily="34" charset="-122"/>
                 <a:cs typeface="Aptos" pitchFamily="34" charset="-120"/>
               </a:rPr>
-              <a:t>17/46</a:t>
+              <a:t>18/47</a:t>
             </a:r>
             <a:endParaRPr lang="en-US" sz="720"/>
           </a:p>
@@ -14120,7 +14120,7 @@
                 <a:ea typeface="Aptos" pitchFamily="34" charset="-122"/>
                 <a:cs typeface="Aptos" pitchFamily="34" charset="-120"/>
               </a:rPr>
-              <a:t>Approved REALTOR® education course | MIAMI REALTORS® + RWorld members</a:t>
+              <a:t>Approved real estate education course | MIAMI REALTORS® + RWorld members</a:t>
             </a:r>
             <a:endParaRPr lang="en-US" sz="720"/>
           </a:p>
@@ -14159,7 +14159,7 @@
                 <a:ea typeface="Aptos" pitchFamily="34" charset="-122"/>
                 <a:cs typeface="Aptos" pitchFamily="34" charset="-120"/>
               </a:rPr>
-              <a:t>18/46</a:t>
+              <a:t>19/47</a:t>
             </a:r>
             <a:endParaRPr lang="en-US" sz="720"/>
           </a:p>
@@ -15370,7 +15370,7 @@
               <a:defRPr/>
             </a:pPr>
             <a:r>
-              <a:rPr kumimoji="0" lang="en-US" sz="680" b="0" i="0" u="none" strike="noStrike" kern="1200" cap="none" spc="0" normalizeH="0" baseline="0" noProof="0" dirty="0">
+              <a:rPr kumimoji="0" lang="en-US" sz="680" b="0" i="0" u="none" strike="noStrike" kern="1200" cap="none" spc="0" normalizeH="0" baseline="0" noProof="0">
                 <a:ln>
                   <a:noFill/>
                 </a:ln>
@@ -15384,7 +15384,24 @@
                 <a:ea typeface="Aptos" pitchFamily="34" charset="-122"/>
                 <a:cs typeface="Aptos" pitchFamily="34" charset="-120"/>
               </a:rPr>
-              <a:t>Approved REALTOR® education course | MIAMI REALTORS® + RWorld members</a:t>
+              <a:t>Approved real estate education course </a:t>
+            </a:r>
+            <a:r>
+              <a:rPr kumimoji="0" lang="en-US" sz="680" b="0" i="0" u="none" strike="noStrike" kern="1200" cap="none" spc="0" normalizeH="0" baseline="0" noProof="0" dirty="0">
+                <a:ln>
+                  <a:noFill/>
+                </a:ln>
+                <a:solidFill>
+                  <a:srgbClr val="52606D"/>
+                </a:solidFill>
+                <a:effectLst/>
+                <a:uLnTx/>
+                <a:uFillTx/>
+                <a:latin typeface="Aptos" pitchFamily="34" charset="0"/>
+                <a:ea typeface="Aptos" pitchFamily="34" charset="-122"/>
+                <a:cs typeface="Aptos" pitchFamily="34" charset="-120"/>
+              </a:rPr>
+              <a:t>| MIAMI REALTORS® + RWorld members</a:t>
             </a:r>
             <a:endParaRPr kumimoji="0" lang="en-US" sz="680" b="0" i="0" u="none" strike="noStrike" kern="1200" cap="none" spc="0" normalizeH="0" baseline="0" noProof="0" dirty="0">
               <a:ln>
@@ -15456,7 +15473,7 @@
                 <a:ea typeface="Aptos" pitchFamily="34" charset="-122"/>
                 <a:cs typeface="Aptos" pitchFamily="34" charset="-120"/>
               </a:rPr>
-              <a:t>1/1</a:t>
+              <a:t>2/47</a:t>
             </a:r>
             <a:endParaRPr kumimoji="0" lang="en-US" sz="680" b="0" i="0" u="none" strike="noStrike" kern="1200" cap="none" spc="0" normalizeH="0" baseline="0" noProof="0" dirty="0">
               <a:ln>
@@ -16384,7 +16401,7 @@
                 <a:ea typeface="Aptos" pitchFamily="34" charset="-122"/>
                 <a:cs typeface="Aptos" pitchFamily="34" charset="-120"/>
               </a:rPr>
-              <a:t>Approved REALTOR® education course | MIAMI REALTORS® + RWorld members</a:t>
+              <a:t>Approved real estate education course | MIAMI REALTORS® + RWorld members</a:t>
             </a:r>
             <a:endParaRPr lang="en-US" sz="720"/>
           </a:p>
@@ -16423,7 +16440,7 @@
                 <a:ea typeface="Aptos" pitchFamily="34" charset="-122"/>
                 <a:cs typeface="Aptos" pitchFamily="34" charset="-120"/>
               </a:rPr>
-              <a:t>19/46</a:t>
+              <a:t>20/47</a:t>
             </a:r>
             <a:endParaRPr lang="en-US" sz="720"/>
           </a:p>
@@ -17320,7 +17337,7 @@
                 <a:ea typeface="Aptos" pitchFamily="34" charset="-122"/>
                 <a:cs typeface="Aptos" pitchFamily="34" charset="-120"/>
               </a:rPr>
-              <a:t>Approved REALTOR® education course | MIAMI REALTORS® + RWorld members</a:t>
+              <a:t>Approved real estate education course | MIAMI REALTORS® + RWorld members</a:t>
             </a:r>
             <a:endParaRPr lang="en-US" sz="720"/>
           </a:p>
@@ -17359,7 +17376,7 @@
                 <a:ea typeface="Aptos" pitchFamily="34" charset="-122"/>
                 <a:cs typeface="Aptos" pitchFamily="34" charset="-120"/>
               </a:rPr>
-              <a:t>20/46</a:t>
+              <a:t>21/47</a:t>
             </a:r>
             <a:endParaRPr lang="en-US" sz="720"/>
           </a:p>
@@ -17858,7 +17875,23 @@
                   <a:srgbClr val="102033"/>
                 </a:solidFill>
               </a:rPr>
-              <a:t>Rewrite this text so it sounds warm, concise, and natural for a REALTOR: [draft]</a:t>
+              <a:t>Rewrite this text so it </a:t>
+            </a:r>
+            <a:r>
+              <a:rPr lang="en-US" sz="1600">
+                <a:solidFill>
+                  <a:srgbClr val="102033"/>
+                </a:solidFill>
+              </a:rPr>
+              <a:t>sounds warm, concise, and natural for a Real Estate Agent: </a:t>
+            </a:r>
+            <a:r>
+              <a:rPr lang="en-US" sz="1600" dirty="0">
+                <a:solidFill>
+                  <a:srgbClr val="102033"/>
+                </a:solidFill>
+              </a:rPr>
+              <a:t>[draft]</a:t>
             </a:r>
             <a:endParaRPr lang="en-US" sz="1600" dirty="0"/>
           </a:p>
@@ -18207,7 +18240,7 @@
                 <a:ea typeface="Aptos" pitchFamily="34" charset="-122"/>
                 <a:cs typeface="Aptos" pitchFamily="34" charset="-120"/>
               </a:rPr>
-              <a:t>Approved REALTOR® education course | MIAMI REALTORS® + RWorld members</a:t>
+              <a:t>Approved real estate education course | MIAMI REALTORS® + RWorld members</a:t>
             </a:r>
             <a:endParaRPr lang="en-US" sz="720"/>
           </a:p>
@@ -18246,7 +18279,7 @@
                 <a:ea typeface="Aptos" pitchFamily="34" charset="-122"/>
                 <a:cs typeface="Aptos" pitchFamily="34" charset="-120"/>
               </a:rPr>
-              <a:t>21/46</a:t>
+              <a:t>22/47</a:t>
             </a:r>
             <a:endParaRPr lang="en-US" sz="720"/>
           </a:p>
@@ -18674,7 +18707,7 @@
                 <a:ea typeface="Aptos" pitchFamily="34" charset="-122"/>
                 <a:cs typeface="Aptos" pitchFamily="34" charset="-120"/>
               </a:rPr>
-              <a:t>Approved REALTOR® education course | MIAMI REALTORS® + RWorld members</a:t>
+              <a:t>Approved real estate education course | MIAMI REALTORS® + RWorld members</a:t>
             </a:r>
             <a:endParaRPr lang="en-US" sz="720"/>
           </a:p>
@@ -18713,7 +18746,7 @@
                 <a:ea typeface="Aptos" pitchFamily="34" charset="-122"/>
                 <a:cs typeface="Aptos" pitchFamily="34" charset="-120"/>
               </a:rPr>
-              <a:t>22/46</a:t>
+              <a:t>23/47</a:t>
             </a:r>
             <a:endParaRPr lang="en-US" sz="720"/>
           </a:p>
@@ -20191,7 +20224,7 @@
                 <a:ea typeface="Aptos" pitchFamily="34" charset="-122"/>
                 <a:cs typeface="Aptos" pitchFamily="34" charset="-120"/>
               </a:rPr>
-              <a:t>Approved REALTOR® education course | MIAMI REALTORS® + RWorld members</a:t>
+              <a:t>Approved real estate education course | MIAMI REALTORS® + RWorld members</a:t>
             </a:r>
             <a:endParaRPr lang="en-US" sz="720"/>
           </a:p>
@@ -20230,7 +20263,7 @@
                 <a:ea typeface="Aptos" pitchFamily="34" charset="-122"/>
                 <a:cs typeface="Aptos" pitchFamily="34" charset="-120"/>
               </a:rPr>
-              <a:t>24/46</a:t>
+              <a:t>25/47</a:t>
             </a:r>
             <a:endParaRPr lang="en-US" sz="720"/>
           </a:p>
@@ -21004,7 +21037,7 @@
                 <a:ea typeface="Aptos" pitchFamily="34" charset="-122"/>
                 <a:cs typeface="Aptos" pitchFamily="34" charset="-120"/>
               </a:rPr>
-              <a:t>Approved REALTOR® education course | MIAMI REALTORS® + RWorld members</a:t>
+              <a:t>Approved real estate education course | MIAMI REALTORS® + RWorld members</a:t>
             </a:r>
             <a:endParaRPr lang="en-US" sz="720"/>
           </a:p>
@@ -21043,7 +21076,7 @@
                 <a:ea typeface="Aptos" pitchFamily="34" charset="-122"/>
                 <a:cs typeface="Aptos" pitchFamily="34" charset="-120"/>
               </a:rPr>
-              <a:t>25/46</a:t>
+              <a:t>26/47</a:t>
             </a:r>
             <a:endParaRPr lang="en-US" sz="720"/>
           </a:p>
@@ -22311,7 +22344,7 @@
                 <a:ea typeface="Aptos" pitchFamily="34" charset="-122"/>
                 <a:cs typeface="Aptos" pitchFamily="34" charset="-120"/>
               </a:rPr>
-              <a:t>Approved REALTOR® education course | MIAMI REALTORS® + RWorld members</a:t>
+              <a:t>Approved real estate education course | MIAMI REALTORS® + RWorld members</a:t>
             </a:r>
             <a:endParaRPr lang="en-US" sz="720"/>
           </a:p>
@@ -22350,7 +22383,7 @@
                 <a:ea typeface="Aptos" pitchFamily="34" charset="-122"/>
                 <a:cs typeface="Aptos" pitchFamily="34" charset="-120"/>
               </a:rPr>
-              <a:t>26/46</a:t>
+              <a:t>27/47</a:t>
             </a:r>
             <a:endParaRPr lang="en-US" sz="720"/>
           </a:p>
@@ -23082,7 +23115,7 @@
                 <a:ea typeface="Aptos" pitchFamily="34" charset="-122"/>
                 <a:cs typeface="Aptos" pitchFamily="34" charset="-120"/>
               </a:rPr>
-              <a:t>Approved REALTOR® education course | MIAMI REALTORS® + RWorld members</a:t>
+              <a:t>Approved real estate education course | MIAMI REALTORS® + RWorld members</a:t>
             </a:r>
             <a:endParaRPr lang="en-US" sz="720"/>
           </a:p>
@@ -23121,7 +23154,7 @@
                 <a:ea typeface="Aptos" pitchFamily="34" charset="-122"/>
                 <a:cs typeface="Aptos" pitchFamily="34" charset="-120"/>
               </a:rPr>
-              <a:t>27/46</a:t>
+              <a:t>28/47</a:t>
             </a:r>
             <a:endParaRPr lang="en-US" sz="720"/>
           </a:p>
@@ -23987,7 +24020,7 @@
                 <a:ea typeface="Aptos" pitchFamily="34" charset="-122"/>
                 <a:cs typeface="Aptos" pitchFamily="34" charset="-120"/>
               </a:rPr>
-              <a:t>Approved REALTOR® education course | MIAMI REALTORS® + RWorld members</a:t>
+              <a:t>Approved real estate education course | MIAMI REALTORS® + RWorld members</a:t>
             </a:r>
             <a:endParaRPr lang="en-US" sz="720"/>
           </a:p>
@@ -24026,7 +24059,7 @@
                 <a:ea typeface="Aptos" pitchFamily="34" charset="-122"/>
                 <a:cs typeface="Aptos" pitchFamily="34" charset="-120"/>
               </a:rPr>
-              <a:t>28/46</a:t>
+              <a:t>29/47</a:t>
             </a:r>
             <a:endParaRPr lang="en-US" sz="720"/>
           </a:p>
@@ -24729,7 +24762,7 @@
                 <a:ea typeface="Aptos" pitchFamily="34" charset="-122"/>
                 <a:cs typeface="Aptos" pitchFamily="34" charset="-120"/>
               </a:rPr>
-              <a:t>Approved REALTOR® education course | MIAMI REALTORS® + RWorld members</a:t>
+              <a:t>Approved real estate education course | MIAMI REALTORS® + RWorld members</a:t>
             </a:r>
             <a:endParaRPr lang="en-US" sz="720"/>
           </a:p>
@@ -24768,7 +24801,7 @@
                 <a:ea typeface="Aptos" pitchFamily="34" charset="-122"/>
                 <a:cs typeface="Aptos" pitchFamily="34" charset="-120"/>
               </a:rPr>
-              <a:t>2/46</a:t>
+              <a:t>3/47</a:t>
             </a:r>
             <a:endParaRPr lang="en-US" sz="720"/>
           </a:p>
@@ -25930,7 +25963,7 @@
                 <a:ea typeface="Aptos" pitchFamily="34" charset="-122"/>
                 <a:cs typeface="Aptos" pitchFamily="34" charset="-120"/>
               </a:rPr>
-              <a:t>Approved REALTOR® education course | MIAMI REALTORS® + RWorld members</a:t>
+              <a:t>Approved real estate education course | MIAMI REALTORS® + RWorld members</a:t>
             </a:r>
             <a:endParaRPr lang="en-US" sz="720"/>
           </a:p>
@@ -25969,7 +26002,7 @@
                 <a:ea typeface="Aptos" pitchFamily="34" charset="-122"/>
                 <a:cs typeface="Aptos" pitchFamily="34" charset="-120"/>
               </a:rPr>
-              <a:t>29/46</a:t>
+              <a:t>30/47</a:t>
             </a:r>
             <a:endParaRPr lang="en-US" sz="720"/>
           </a:p>
@@ -26992,7 +27025,7 @@
                 <a:ea typeface="Aptos" pitchFamily="34" charset="-122"/>
                 <a:cs typeface="Aptos" pitchFamily="34" charset="-120"/>
               </a:rPr>
-              <a:t>Approved REALTOR® education course | MIAMI REALTORS® + RWorld members</a:t>
+              <a:t>Approved real estate education course | MIAMI REALTORS® + RWorld members</a:t>
             </a:r>
             <a:endParaRPr lang="en-US" sz="720"/>
           </a:p>
@@ -27031,7 +27064,7 @@
                 <a:ea typeface="Aptos" pitchFamily="34" charset="-122"/>
                 <a:cs typeface="Aptos" pitchFamily="34" charset="-120"/>
               </a:rPr>
-              <a:t>31/46</a:t>
+              <a:t>32/47</a:t>
             </a:r>
             <a:endParaRPr lang="en-US" sz="720"/>
           </a:p>
@@ -27793,7 +27826,7 @@
                 <a:ea typeface="Aptos" pitchFamily="34" charset="-122"/>
                 <a:cs typeface="Aptos" pitchFamily="34" charset="-120"/>
               </a:rPr>
-              <a:t>Approved REALTOR® education course | MIAMI REALTORS® + RWorld members</a:t>
+              <a:t>Approved real estate education course | MIAMI REALTORS® + RWorld members</a:t>
             </a:r>
             <a:endParaRPr lang="en-US" sz="720"/>
           </a:p>
@@ -27832,7 +27865,7 @@
                 <a:ea typeface="Aptos" pitchFamily="34" charset="-122"/>
                 <a:cs typeface="Aptos" pitchFamily="34" charset="-120"/>
               </a:rPr>
-              <a:t>32/46</a:t>
+              <a:t>33/47</a:t>
             </a:r>
             <a:endParaRPr lang="en-US" sz="720"/>
           </a:p>
@@ -28903,7 +28936,7 @@
               <a:buNone/>
             </a:pPr>
             <a:r>
-              <a:rPr lang="en-US" sz="720" dirty="0">
+              <a:rPr lang="en-US" sz="720">
                 <a:solidFill>
                   <a:srgbClr val="52606D"/>
                 </a:solidFill>
@@ -28911,10 +28944,10 @@
                 <a:ea typeface="Aptos" pitchFamily="34" charset="-122"/>
                 <a:cs typeface="Aptos" pitchFamily="34" charset="-120"/>
               </a:rPr>
-              <a:t>Approved REALTOR® education course | MIAMI REALTORS® + </a:t>
-            </a:r>
-            <a:r>
-              <a:rPr lang="en-US" sz="720" dirty="0" err="1">
+              <a:t>Approved real estate education course </a:t>
+            </a:r>
+            <a:r>
+              <a:rPr lang="en-US" sz="720" dirty="0">
                 <a:solidFill>
                   <a:srgbClr val="52606D"/>
                 </a:solidFill>
@@ -28922,10 +28955,10 @@
                 <a:ea typeface="Aptos" pitchFamily="34" charset="-122"/>
                 <a:cs typeface="Aptos" pitchFamily="34" charset="-120"/>
               </a:rPr>
-              <a:t>RWorld</a:t>
-            </a:r>
-            <a:r>
-              <a:rPr lang="en-US" sz="720" dirty="0">
+              <a:t>| MIAMI REALTORS® + </a:t>
+            </a:r>
+            <a:r>
+              <a:rPr lang="en-US" sz="720" dirty="0" err="1">
                 <a:solidFill>
                   <a:srgbClr val="52606D"/>
                 </a:solidFill>
@@ -28933,36 +28966,8 @@
                 <a:ea typeface="Aptos" pitchFamily="34" charset="-122"/>
                 <a:cs typeface="Aptos" pitchFamily="34" charset="-120"/>
               </a:rPr>
-              <a:t> members</a:t>
-            </a:r>
-            <a:endParaRPr lang="en-US" sz="720" dirty="0"/>
-          </a:p>
-        </p:txBody>
-      </p:sp>
-      <p:sp>
-        <p:nvSpPr>
-          <p:cNvPr id="31" name="Text 29"/>
-          <p:cNvSpPr/>
-          <p:nvPr/>
-        </p:nvSpPr>
-        <p:spPr>
-          <a:xfrm>
-            <a:off x="10927080" y="6565392"/>
-            <a:ext cx="731520" cy="164592"/>
-          </a:xfrm>
-          <a:prstGeom prst="rect">
-            <a:avLst/>
-          </a:prstGeom>
-          <a:noFill/>
-          <a:ln/>
-        </p:spPr>
-        <p:txBody>
-          <a:bodyPr wrap="square" lIns="0" tIns="0" rIns="0" bIns="0" rtlCol="0" anchor="ctr"/>
-          <a:lstStyle/>
-          <a:p>
-            <a:pPr marL="0" indent="0" algn="r">
-              <a:buNone/>
-            </a:pPr>
+              <a:t>RWorld</a:t>
+            </a:r>
             <a:r>
               <a:rPr lang="en-US" sz="720" dirty="0">
                 <a:solidFill>
@@ -28972,7 +28977,46 @@
                 <a:ea typeface="Aptos" pitchFamily="34" charset="-122"/>
                 <a:cs typeface="Aptos" pitchFamily="34" charset="-120"/>
               </a:rPr>
-              <a:t>33/46</a:t>
+              <a:t> members</a:t>
+            </a:r>
+            <a:endParaRPr lang="en-US" sz="720" dirty="0"/>
+          </a:p>
+        </p:txBody>
+      </p:sp>
+      <p:sp>
+        <p:nvSpPr>
+          <p:cNvPr id="31" name="Text 29"/>
+          <p:cNvSpPr/>
+          <p:nvPr/>
+        </p:nvSpPr>
+        <p:spPr>
+          <a:xfrm>
+            <a:off x="10927080" y="6565392"/>
+            <a:ext cx="731520" cy="164592"/>
+          </a:xfrm>
+          <a:prstGeom prst="rect">
+            <a:avLst/>
+          </a:prstGeom>
+          <a:noFill/>
+          <a:ln/>
+        </p:spPr>
+        <p:txBody>
+          <a:bodyPr wrap="square" lIns="0" tIns="0" rIns="0" bIns="0" rtlCol="0" anchor="ctr"/>
+          <a:lstStyle/>
+          <a:p>
+            <a:pPr marL="0" indent="0" algn="r">
+              <a:buNone/>
+            </a:pPr>
+            <a:r>
+              <a:rPr lang="en-US" sz="720" dirty="0">
+                <a:solidFill>
+                  <a:srgbClr val="52606D"/>
+                </a:solidFill>
+                <a:latin typeface="Aptos" pitchFamily="34" charset="0"/>
+                <a:ea typeface="Aptos" pitchFamily="34" charset="-122"/>
+                <a:cs typeface="Aptos" pitchFamily="34" charset="-120"/>
+              </a:rPr>
+              <a:t>34/47</a:t>
             </a:r>
             <a:endParaRPr lang="en-US" sz="720" dirty="0"/>
           </a:p>
@@ -30143,7 +30187,7 @@
                 <a:ea typeface="Aptos" pitchFamily="34" charset="-122"/>
                 <a:cs typeface="Aptos" pitchFamily="34" charset="-120"/>
               </a:rPr>
-              <a:t>Approved REALTOR® education course | MIAMI REALTORS® + RWorld members</a:t>
+              <a:t>Approved real estate education course | MIAMI REALTORS® + RWorld members</a:t>
             </a:r>
             <a:endParaRPr lang="en-US" sz="720"/>
           </a:p>
@@ -30182,7 +30226,7 @@
                 <a:ea typeface="Aptos" pitchFamily="34" charset="-122"/>
                 <a:cs typeface="Aptos" pitchFamily="34" charset="-120"/>
               </a:rPr>
-              <a:t>34/46</a:t>
+              <a:t>35/47</a:t>
             </a:r>
             <a:endParaRPr lang="en-US" sz="720"/>
           </a:p>
@@ -30928,7 +30972,7 @@
                 <a:ea typeface="Aptos" pitchFamily="34" charset="-122"/>
                 <a:cs typeface="Aptos" pitchFamily="34" charset="-120"/>
               </a:rPr>
-              <a:t>Approved REALTOR® education course | MIAMI REALTORS® + RWorld members</a:t>
+              <a:t>Approved real estate education course | MIAMI REALTORS® + RWorld members</a:t>
             </a:r>
             <a:endParaRPr lang="en-US" sz="720"/>
           </a:p>
@@ -30967,7 +31011,7 @@
                 <a:ea typeface="Aptos" pitchFamily="34" charset="-122"/>
                 <a:cs typeface="Aptos" pitchFamily="34" charset="-120"/>
               </a:rPr>
-              <a:t>35/46</a:t>
+              <a:t>36/47</a:t>
             </a:r>
             <a:endParaRPr lang="en-US" sz="720"/>
           </a:p>
@@ -31535,7 +31579,7 @@
                 <a:ea typeface="Aptos" pitchFamily="34" charset="-122"/>
                 <a:cs typeface="Aptos" pitchFamily="34" charset="-120"/>
               </a:rPr>
-              <a:t>Approved REALTOR® education course | MIAMI REALTORS® + RWorld members</a:t>
+              <a:t>Approved real estate education course | MIAMI REALTORS® + RWorld members</a:t>
             </a:r>
             <a:endParaRPr lang="en-US" sz="720"/>
           </a:p>
@@ -31574,7 +31618,7 @@
                 <a:ea typeface="Aptos" pitchFamily="34" charset="-122"/>
                 <a:cs typeface="Aptos" pitchFamily="34" charset="-120"/>
               </a:rPr>
-              <a:t>36/46</a:t>
+              <a:t>37/47</a:t>
             </a:r>
             <a:endParaRPr lang="en-US" sz="720"/>
           </a:p>
@@ -32139,7 +32183,7 @@
                 <a:ea typeface="Aptos" pitchFamily="34" charset="-122"/>
                 <a:cs typeface="Aptos" pitchFamily="34" charset="-120"/>
               </a:rPr>
-              <a:t>Approved REALTOR® education course | MIAMI REALTORS® + RWorld members</a:t>
+              <a:t>Approved real estate education course | MIAMI REALTORS® + RWorld members</a:t>
             </a:r>
             <a:endParaRPr lang="en-US" sz="720"/>
           </a:p>
@@ -32178,7 +32222,7 @@
                 <a:ea typeface="Aptos" pitchFamily="34" charset="-122"/>
                 <a:cs typeface="Aptos" pitchFamily="34" charset="-120"/>
               </a:rPr>
-              <a:t>37/46</a:t>
+              <a:t>38/47</a:t>
             </a:r>
             <a:endParaRPr lang="en-US" sz="720"/>
           </a:p>
@@ -32998,7 +33042,7 @@
                 <a:ea typeface="Aptos" pitchFamily="34" charset="-122"/>
                 <a:cs typeface="Aptos" pitchFamily="34" charset="-120"/>
               </a:rPr>
-              <a:t>Approved REALTOR® education course | MIAMI REALTORS® + RWorld members</a:t>
+              <a:t>Approved real estate education course | MIAMI REALTORS® + RWorld members</a:t>
             </a:r>
             <a:endParaRPr lang="en-US" sz="720"/>
           </a:p>
@@ -33037,7 +33081,7 @@
                 <a:ea typeface="Aptos" pitchFamily="34" charset="-122"/>
                 <a:cs typeface="Aptos" pitchFamily="34" charset="-120"/>
               </a:rPr>
-              <a:t>38/46</a:t>
+              <a:t>39/47</a:t>
             </a:r>
             <a:endParaRPr lang="en-US" sz="720"/>
           </a:p>
@@ -33500,28 +33544,28 @@
               <a:buNone/>
             </a:pPr>
             <a:r>
-              <a:rPr lang="en-US" sz="1200" dirty="0">
+              <a:rPr lang="en-US" sz="950">
                 <a:solidFill>
                   <a:srgbClr val="52606D"/>
                 </a:solidFill>
               </a:rPr>
-              <a:t>REALTOR® | Dalton Wade Real Estate Group</a:t>
-            </a:r>
-            <a:endParaRPr lang="en-US" sz="1200" dirty="0"/>
+              <a:t>Real Estate Agent | Dalton Wade Real Estate Group</a:t>
+            </a:r>
+            <a:endParaRPr lang="en-US" sz="950" dirty="0"/>
           </a:p>
           <a:p>
             <a:pPr marL="0" indent="0">
               <a:buNone/>
             </a:pPr>
             <a:r>
-              <a:rPr lang="en-US" sz="1200" dirty="0">
+              <a:rPr lang="en-US" sz="950" dirty="0">
                 <a:solidFill>
                   <a:srgbClr val="52606D"/>
                 </a:solidFill>
               </a:rPr>
               <a:t>V.P. of Growth and Partnerships | GoHouse.ai</a:t>
             </a:r>
-            <a:endParaRPr lang="en-US" sz="1200" dirty="0"/>
+            <a:endParaRPr lang="en-US" sz="950" dirty="0"/>
           </a:p>
         </p:txBody>
       </p:sp>
@@ -33856,7 +33900,7 @@
                 <a:ea typeface="Aptos" pitchFamily="34" charset="-122"/>
                 <a:cs typeface="Aptos" pitchFamily="34" charset="-120"/>
               </a:rPr>
-              <a:t>Approved REALTOR® education course | MIAMI REALTORS® + RWorld members</a:t>
+              <a:t>Approved real estate education course | MIAMI REALTORS® + RWorld members</a:t>
             </a:r>
             <a:endParaRPr lang="en-US" sz="720"/>
           </a:p>
@@ -33895,7 +33939,7 @@
                 <a:ea typeface="Aptos" pitchFamily="34" charset="-122"/>
                 <a:cs typeface="Aptos" pitchFamily="34" charset="-120"/>
               </a:rPr>
-              <a:t>3/46</a:t>
+              <a:t>4/47</a:t>
             </a:r>
             <a:endParaRPr lang="en-US" sz="720"/>
           </a:p>
@@ -35316,7 +35360,7 @@
                 <a:ea typeface="Aptos" pitchFamily="34" charset="-122"/>
                 <a:cs typeface="Aptos" pitchFamily="34" charset="-120"/>
               </a:rPr>
-              <a:t>Approved REALTOR® education course | MIAMI REALTORS® + RWorld members</a:t>
+              <a:t>Approved real estate education course | MIAMI REALTORS® + RWorld members</a:t>
             </a:r>
             <a:endParaRPr lang="en-US" sz="720"/>
           </a:p>
@@ -35355,7 +35399,7 @@
                 <a:ea typeface="Aptos" pitchFamily="34" charset="-122"/>
                 <a:cs typeface="Aptos" pitchFamily="34" charset="-120"/>
               </a:rPr>
-              <a:t>40/46</a:t>
+              <a:t>41/47</a:t>
             </a:r>
             <a:endParaRPr lang="en-US" sz="720"/>
           </a:p>
@@ -36133,7 +36177,7 @@
                 <a:ea typeface="Aptos" pitchFamily="34" charset="-122"/>
                 <a:cs typeface="Aptos" pitchFamily="34" charset="-120"/>
               </a:rPr>
-              <a:t>Approved REALTOR® education course | MIAMI REALTORS® + RWorld members</a:t>
+              <a:t>Approved real estate education course | MIAMI REALTORS® + RWorld members</a:t>
             </a:r>
             <a:endParaRPr lang="en-US" sz="720"/>
           </a:p>
@@ -36172,7 +36216,7 @@
                 <a:ea typeface="Aptos" pitchFamily="34" charset="-122"/>
                 <a:cs typeface="Aptos" pitchFamily="34" charset="-120"/>
               </a:rPr>
-              <a:t>41/46</a:t>
+              <a:t>42/47</a:t>
             </a:r>
             <a:endParaRPr lang="en-US" sz="720"/>
           </a:p>
@@ -37040,7 +37084,7 @@
                 <a:ea typeface="Aptos" pitchFamily="34" charset="-122"/>
                 <a:cs typeface="Aptos" pitchFamily="34" charset="-120"/>
               </a:rPr>
-              <a:t>Approved REALTOR® education course | MIAMI REALTORS® + RWorld members</a:t>
+              <a:t>Approved real estate education course | MIAMI REALTORS® + RWorld members</a:t>
             </a:r>
             <a:endParaRPr lang="en-US" sz="720"/>
           </a:p>
@@ -37079,7 +37123,7 @@
                 <a:ea typeface="Aptos" pitchFamily="34" charset="-122"/>
                 <a:cs typeface="Aptos" pitchFamily="34" charset="-120"/>
               </a:rPr>
-              <a:t>42/46</a:t>
+              <a:t>43/47</a:t>
             </a:r>
             <a:endParaRPr lang="en-US" sz="720"/>
           </a:p>
@@ -37910,7 +37954,7 @@
                 <a:ea typeface="Aptos" pitchFamily="34" charset="-122"/>
                 <a:cs typeface="Aptos" pitchFamily="34" charset="-120"/>
               </a:rPr>
-              <a:t>Approved REALTOR® education course | MIAMI REALTORS® + RWorld members</a:t>
+              <a:t>Approved real estate education course | MIAMI REALTORS® + RWorld members</a:t>
             </a:r>
             <a:endParaRPr lang="en-US" sz="720"/>
           </a:p>
@@ -37949,7 +37993,7 @@
                 <a:ea typeface="Aptos" pitchFamily="34" charset="-122"/>
                 <a:cs typeface="Aptos" pitchFamily="34" charset="-120"/>
               </a:rPr>
-              <a:t>43/46</a:t>
+              <a:t>44/47</a:t>
             </a:r>
             <a:endParaRPr lang="en-US" sz="720"/>
           </a:p>
@@ -39077,7 +39121,7 @@
                 <a:ea typeface="Aptos" pitchFamily="34" charset="-122"/>
                 <a:cs typeface="Aptos" pitchFamily="34" charset="-120"/>
               </a:rPr>
-              <a:t>Approved REALTOR® education course | MIAMI REALTORS® + RWorld members</a:t>
+              <a:t>Approved real estate education course | MIAMI REALTORS® + RWorld members</a:t>
             </a:r>
             <a:endParaRPr lang="en-US" sz="720"/>
           </a:p>
@@ -39116,7 +39160,7 @@
                 <a:ea typeface="Aptos" pitchFamily="34" charset="-122"/>
                 <a:cs typeface="Aptos" pitchFamily="34" charset="-120"/>
               </a:rPr>
-              <a:t>44/46</a:t>
+              <a:t>45/47</a:t>
             </a:r>
             <a:endParaRPr lang="en-US" sz="720"/>
           </a:p>
@@ -40234,7 +40278,7 @@
                 <a:ea typeface="Aptos" pitchFamily="34" charset="-122"/>
                 <a:cs typeface="Aptos" pitchFamily="34" charset="-120"/>
               </a:rPr>
-              <a:t>Approved REALTOR® education course | MIAMI REALTORS® + RWorld members</a:t>
+              <a:t>Approved real estate education course | MIAMI REALTORS® + RWorld members</a:t>
             </a:r>
             <a:endParaRPr lang="en-US" sz="720"/>
           </a:p>
@@ -40273,7 +40317,7 @@
                 <a:ea typeface="Aptos" pitchFamily="34" charset="-122"/>
                 <a:cs typeface="Aptos" pitchFamily="34" charset="-120"/>
               </a:rPr>
-              <a:t>45/46</a:t>
+              <a:t>46/47</a:t>
             </a:r>
             <a:endParaRPr lang="en-US" sz="720"/>
           </a:p>
@@ -41173,12 +41217,12 @@
               <a:buNone/>
             </a:pPr>
             <a:r>
-              <a:rPr lang="en-US" sz="980" dirty="0">
+              <a:rPr lang="en-US" sz="980">
                 <a:solidFill>
                   <a:srgbClr val="52606D"/>
                 </a:solidFill>
               </a:rPr>
-              <a:t>REALTOR® | Dalton Wade Real Estate Group</a:t>
+              <a:t>Real Estate Agent | Dalton Wade Real Estate Group</a:t>
             </a:r>
             <a:endParaRPr lang="en-US" sz="980" dirty="0"/>
           </a:p>
@@ -41285,7 +41329,7 @@
                 <a:ea typeface="Aptos" pitchFamily="34" charset="-122"/>
                 <a:cs typeface="Aptos" pitchFamily="34" charset="-120"/>
               </a:rPr>
-              <a:t>Approved REALTOR® education course | MIAMI REALTORS® + RWorld members</a:t>
+              <a:t>Approved real estate education course | MIAMI REALTORS® + RWorld members</a:t>
             </a:r>
             <a:endParaRPr lang="en-US" sz="720"/>
           </a:p>
@@ -41324,7 +41368,7 @@
                 <a:ea typeface="Aptos" pitchFamily="34" charset="-122"/>
                 <a:cs typeface="Aptos" pitchFamily="34" charset="-120"/>
               </a:rPr>
-              <a:t>46/46</a:t>
+              <a:t>47/47</a:t>
             </a:r>
             <a:endParaRPr lang="en-US" sz="720"/>
           </a:p>
@@ -42930,7 +42974,7 @@
                 <a:ea typeface="Aptos" pitchFamily="34" charset="-122"/>
                 <a:cs typeface="Aptos" pitchFamily="34" charset="-120"/>
               </a:rPr>
-              <a:t>Approved REALTOR® education course | MIAMI REALTORS® + RWorld members</a:t>
+              <a:t>Approved real estate education course | MIAMI REALTORS® + RWorld members</a:t>
             </a:r>
             <a:endParaRPr lang="en-US" sz="720"/>
           </a:p>
@@ -42969,7 +43013,7 @@
                 <a:ea typeface="Aptos" pitchFamily="34" charset="-122"/>
                 <a:cs typeface="Aptos" pitchFamily="34" charset="-120"/>
               </a:rPr>
-              <a:t>4/46</a:t>
+              <a:t>5/47</a:t>
             </a:r>
             <a:endParaRPr lang="en-US" sz="720"/>
           </a:p>
@@ -43580,7 +43624,7 @@
                 <a:ea typeface="Aptos" pitchFamily="34" charset="-122"/>
                 <a:cs typeface="Aptos" pitchFamily="34" charset="-120"/>
               </a:rPr>
-              <a:t>Approved REALTOR® education course | MIAMI REALTORS® + RWorld members</a:t>
+              <a:t>Approved real estate education course | MIAMI REALTORS® + RWorld members</a:t>
             </a:r>
             <a:endParaRPr lang="en-US" sz="720"/>
           </a:p>
@@ -43619,7 +43663,7 @@
                 <a:ea typeface="Aptos" pitchFamily="34" charset="-122"/>
                 <a:cs typeface="Aptos" pitchFamily="34" charset="-120"/>
               </a:rPr>
-              <a:t>5/46</a:t>
+              <a:t>6/47</a:t>
             </a:r>
             <a:endParaRPr lang="en-US" sz="720"/>
           </a:p>
@@ -45524,7 +45568,7 @@
                 <a:ea typeface="Aptos" pitchFamily="34" charset="-122"/>
                 <a:cs typeface="Aptos" pitchFamily="34" charset="-120"/>
               </a:rPr>
-              <a:t>Approved REALTOR® education course | MIAMI REALTORS® + RWorld members</a:t>
+              <a:t>Approved real estate education course | MIAMI REALTORS® + RWorld members</a:t>
             </a:r>
             <a:endParaRPr lang="en-US" sz="720"/>
           </a:p>
@@ -45563,7 +45607,7 @@
                 <a:ea typeface="Aptos" pitchFamily="34" charset="-122"/>
                 <a:cs typeface="Aptos" pitchFamily="34" charset="-120"/>
               </a:rPr>
-              <a:t>7/46</a:t>
+              <a:t>8/47</a:t>
             </a:r>
             <a:endParaRPr lang="en-US" sz="720"/>
           </a:p>
@@ -46343,7 +46387,7 @@
                 <a:ea typeface="Aptos" pitchFamily="34" charset="-122"/>
                 <a:cs typeface="Aptos" pitchFamily="34" charset="-120"/>
               </a:rPr>
-              <a:t>Approved REALTOR® education course | MIAMI REALTORS® + RWorld members</a:t>
+              <a:t>Approved real estate education course | MIAMI REALTORS® + RWorld members</a:t>
             </a:r>
             <a:endParaRPr lang="en-US" sz="720"/>
           </a:p>
@@ -46382,7 +46426,7 @@
                 <a:ea typeface="Aptos" pitchFamily="34" charset="-122"/>
                 <a:cs typeface="Aptos" pitchFamily="34" charset="-120"/>
               </a:rPr>
-              <a:t>8/46</a:t>
+              <a:t>9/47</a:t>
             </a:r>
             <a:endParaRPr lang="en-US" sz="720"/>
           </a:p>

</xml_diff>

<commit_message>
Restore instructor REALTOR credential
</commit_message>
<xml_diff>
--- a/slides/course-01-ai-for-real-estate-sales-approved-instructor-deck.pptx
+++ b/slides/course-01-ai-for-real-estate-sales-approved-instructor-deck.pptx
@@ -33549,7 +33549,7 @@
                   <a:srgbClr val="52606D"/>
                 </a:solidFill>
               </a:rPr>
-              <a:t>Real Estate Agent | Dalton Wade Real Estate Group</a:t>
+              <a:t>REALTOR® | Dalton Wade Real Estate Group</a:t>
             </a:r>
             <a:endParaRPr lang="en-US" sz="950" dirty="0"/>
           </a:p>
@@ -41222,7 +41222,7 @@
                   <a:srgbClr val="52606D"/>
                 </a:solidFill>
               </a:rPr>
-              <a:t>Real Estate Agent | Dalton Wade Real Estate Group</a:t>
+              <a:t>REALTOR® | Dalton Wade Real Estate Group</a:t>
             </a:r>
             <a:endParaRPr lang="en-US" sz="980" dirty="0"/>
           </a:p>

</xml_diff>

<commit_message>
Add Course 1 student resource landing package
</commit_message>
<xml_diff>
--- a/slides/course-01-ai-for-real-estate-sales-approved-instructor-deck.pptx
+++ b/slides/course-01-ai-for-real-estate-sales-approved-instructor-deck.pptx
@@ -42234,6 +42234,135 @@
           </a:prstGeom>
         </p:spPr>
       </p:pic>
+      <p:pic>
+        <p:nvPicPr>
+          <p:cNvPr id="78" name="Course resources QR code" descr="qr-gohouse-miami-ai-course.png"/>
+          <p:cNvPicPr>
+            <a:picLocks noChangeAspect="1"/>
+          </p:cNvPicPr>
+          <p:nvPr/>
+        </p:nvPicPr>
+        <p:blipFill>
+          <a:blip r:embed="rId10"/>
+          <a:stretch>
+            <a:fillRect/>
+          </a:stretch>
+        </p:blipFill>
+        <p:spPr>
+          <a:xfrm>
+            <a:off x="5559552" y="5266944"/>
+            <a:ext cx="713232" cy="713232"/>
+          </a:xfrm>
+          <a:prstGeom prst="rect">
+            <a:avLst/>
+          </a:prstGeom>
+        </p:spPr>
+      </p:pic>
+      <p:sp>
+        <p:nvSpPr>
+          <p:cNvPr id="79" name="Course resources label"/>
+          <p:cNvSpPr txBox="1"/>
+          <p:nvPr/>
+        </p:nvSpPr>
+        <p:spPr>
+          <a:xfrm>
+            <a:off x="6364224" y="5303520"/>
+            <a:ext cx="1536192" cy="182880"/>
+          </a:xfrm>
+          <a:prstGeom prst="rect">
+            <a:avLst/>
+          </a:prstGeom>
+          <a:noFill/>
+        </p:spPr>
+        <p:txBody>
+          <a:bodyPr wrap="none">
+            <a:spAutoFit/>
+          </a:bodyPr>
+          <a:lstStyle/>
+          <a:p>
+            <a:pPr algn="l"/>
+            <a:r>
+              <a:rPr sz="850" b="1">
+                <a:solidFill>
+                  <a:srgbClr val="0E335F"/>
+                </a:solidFill>
+                <a:latin typeface="Aptos Display"/>
+              </a:rPr>
+              <a:t>Scan for class resources</a:t>
+            </a:r>
+          </a:p>
+        </p:txBody>
+      </p:sp>
+      <p:sp>
+        <p:nvSpPr>
+          <p:cNvPr id="80" name="Course resources support"/>
+          <p:cNvSpPr txBox="1"/>
+          <p:nvPr/>
+        </p:nvSpPr>
+        <p:spPr>
+          <a:xfrm>
+            <a:off x="6364224" y="5522976"/>
+            <a:ext cx="1627632" cy="329184"/>
+          </a:xfrm>
+          <a:prstGeom prst="rect">
+            <a:avLst/>
+          </a:prstGeom>
+          <a:noFill/>
+        </p:spPr>
+        <p:txBody>
+          <a:bodyPr wrap="square">
+            <a:spAutoFit/>
+          </a:bodyPr>
+          <a:lstStyle/>
+          <a:p>
+            <a:pPr algn="l"/>
+            <a:r>
+              <a:rPr sz="650">
+                <a:solidFill>
+                  <a:srgbClr val="4F5E70"/>
+                </a:solidFill>
+                <a:latin typeface="Aptos"/>
+              </a:rPr>
+              <a:t>Prompt library, plan, checklists, and deck PDF.</a:t>
+            </a:r>
+          </a:p>
+        </p:txBody>
+      </p:sp>
+      <p:sp>
+        <p:nvSpPr>
+          <p:cNvPr id="81" name="Course resources url"/>
+          <p:cNvSpPr txBox="1"/>
+          <p:nvPr/>
+        </p:nvSpPr>
+        <p:spPr>
+          <a:xfrm>
+            <a:off x="6364224" y="5843016"/>
+            <a:ext cx="1554480" cy="146304"/>
+          </a:xfrm>
+          <a:prstGeom prst="rect">
+            <a:avLst/>
+          </a:prstGeom>
+          <a:noFill/>
+        </p:spPr>
+        <p:txBody>
+          <a:bodyPr wrap="none">
+            <a:spAutoFit/>
+          </a:bodyPr>
+          <a:lstStyle/>
+          <a:p>
+            <a:pPr algn="l"/>
+            <a:r>
+              <a:rPr sz="620">
+                <a:solidFill>
+                  <a:srgbClr val="2D6F83"/>
+                </a:solidFill>
+                <a:latin typeface="Aptos"/>
+              </a:rPr>
+              <a:t>gohouse.ai/miami-ai-course</a:t>
+            </a:r>
+          </a:p>
+        </p:txBody>
+      </p:sp>
     </p:spTree>
   </p:cSld>
   <p:clrMapOvr>

</xml_diff>

<commit_message>
Update Course 1 QR code landing URL
</commit_message>
<xml_diff>
--- a/slides/course-01-ai-for-real-estate-sales-approved-instructor-deck.pptx
+++ b/slides/course-01-ai-for-real-estate-sales-approved-instructor-deck.pptx
@@ -42236,14 +42236,14 @@
       </p:pic>
       <p:pic>
         <p:nvPicPr>
-          <p:cNvPr id="78" name="Course resources QR code" descr="qr-gohouse-miami-ai-course.png"/>
+          <p:cNvPr id="78" name="Course resources QR code" descr="qr-gohouse-ai-for-real-estate-sales.png"/>
           <p:cNvPicPr>
             <a:picLocks noChangeAspect="1"/>
           </p:cNvPicPr>
           <p:nvPr/>
         </p:nvPicPr>
         <p:blipFill>
-          <a:blip r:embed="rId10"/>
+          <a:blip r:embed="rId11"/>
           <a:stretch>
             <a:fillRect/>
           </a:stretch>
@@ -42266,16 +42266,16 @@
         </p:nvSpPr>
         <p:spPr>
           <a:xfrm>
-            <a:off x="6364224" y="5303520"/>
-            <a:ext cx="1536192" cy="182880"/>
-          </a:xfrm>
-          <a:prstGeom prst="rect">
-            <a:avLst/>
-          </a:prstGeom>
-          <a:noFill/>
-        </p:spPr>
-        <p:txBody>
-          <a:bodyPr wrap="none">
+            <a:off x="6364224" y="5285232"/>
+            <a:ext cx="1664208" cy="182880"/>
+          </a:xfrm>
+          <a:prstGeom prst="rect">
+            <a:avLst/>
+          </a:prstGeom>
+          <a:noFill/>
+        </p:spPr>
+        <p:txBody>
+          <a:bodyPr wrap="none" lIns="0" rIns="0" tIns="0" bIns="0">
             <a:spAutoFit/>
           </a:bodyPr>
           <a:lstStyle/>
@@ -42301,23 +42301,23 @@
         </p:nvSpPr>
         <p:spPr>
           <a:xfrm>
-            <a:off x="6364224" y="5522976"/>
-            <a:ext cx="1627632" cy="329184"/>
-          </a:xfrm>
-          <a:prstGeom prst="rect">
-            <a:avLst/>
-          </a:prstGeom>
-          <a:noFill/>
-        </p:spPr>
-        <p:txBody>
-          <a:bodyPr wrap="square">
+            <a:off x="6364224" y="5504688"/>
+            <a:ext cx="1700784" cy="274320"/>
+          </a:xfrm>
+          <a:prstGeom prst="rect">
+            <a:avLst/>
+          </a:prstGeom>
+          <a:noFill/>
+        </p:spPr>
+        <p:txBody>
+          <a:bodyPr wrap="square" lIns="0" rIns="0" tIns="0" bIns="0">
             <a:spAutoFit/>
           </a:bodyPr>
           <a:lstStyle/>
           <a:p>
             <a:pPr algn="l"/>
             <a:r>
-              <a:rPr sz="650">
+              <a:rPr sz="620">
                 <a:solidFill>
                   <a:srgbClr val="4F5E70"/>
                 </a:solidFill>
@@ -42336,29 +42336,30 @@
         </p:nvSpPr>
         <p:spPr>
           <a:xfrm>
-            <a:off x="6364224" y="5843016"/>
-            <a:ext cx="1554480" cy="146304"/>
-          </a:xfrm>
-          <a:prstGeom prst="rect">
-            <a:avLst/>
-          </a:prstGeom>
-          <a:noFill/>
-        </p:spPr>
-        <p:txBody>
-          <a:bodyPr wrap="none">
+            <a:off x="6364224" y="5788152"/>
+            <a:ext cx="1737360" cy="246888"/>
+          </a:xfrm>
+          <a:prstGeom prst="rect">
+            <a:avLst/>
+          </a:prstGeom>
+          <a:noFill/>
+        </p:spPr>
+        <p:txBody>
+          <a:bodyPr wrap="square" lIns="0" rIns="0" tIns="0" bIns="0">
             <a:spAutoFit/>
           </a:bodyPr>
           <a:lstStyle/>
           <a:p>
             <a:pPr algn="l"/>
             <a:r>
-              <a:rPr sz="620">
+              <a:rPr sz="580">
                 <a:solidFill>
                   <a:srgbClr val="2D6F83"/>
                 </a:solidFill>
                 <a:latin typeface="Aptos"/>
               </a:rPr>
-              <a:t>gohouse.ai/miami-ai-course</a:t>
+              <a:t>gohouse.ai/classes/
+ai-for-real-estate-sales</a:t>
             </a:r>
           </a:p>
         </p:txBody>

</xml_diff>